<commit_message>
Retarget the agent-loop deck to M100 single-machine deployment
Drop cluster, replica and router content: Loop B now targets the SLO
capacity of one machine, and the deep dive reports single-machine
capacity for a fixed TP8 launch (H20 preset as a labelled stand-in until
an M100 spec exists). Rebuild the differentiation table with one owner
column so no cell is left blank, and shorten lines that wrapped badly in
PowerPoint.
</commit_message>
<xml_diff>
--- a/slides/sglang_maestro_agent_loops.pptx
+++ b/slides/sglang_maestro_agent_loops.pptx
@@ -3264,7 +3264,31 @@
                 <a:ea typeface="Microsoft YaHei"/>
                 <a:cs typeface="Microsoft YaHei"/>
               </a:rPr>
-              <a:t>面向 H20 类与定制芯片，用三个 Agent Loop 分别助力：框架迭代、模型适配与评估优化、算子绑定评估与优化</a:t>
+              <a:t>面向 M100 芯片的单机部署，用三个 Agent Loop 分别助力：</a:t>
+            </a:r>
+          </a:p>
+          <a:p>
+            <a:pPr algn="l" latinLnBrk="0">
+              <a:lnSpc>
+                <a:spcPct val="120000"/>
+              </a:lnSpc>
+              <a:spcBef>
+                <a:spcPts val="0"/>
+              </a:spcBef>
+              <a:spcAft>
+                <a:spcPts val="0"/>
+              </a:spcAft>
+            </a:pPr>
+            <a:r>
+              <a:rPr sz="1500" b="0">
+                <a:solidFill>
+                  <a:srgbClr val="C5CCD4"/>
+                </a:solidFill>
+                <a:latin typeface="Microsoft YaHei"/>
+                <a:ea typeface="Microsoft YaHei"/>
+                <a:cs typeface="Microsoft YaHei"/>
+              </a:rPr>
+              <a:t>框架迭代、模型适配与评估优化、算子绑定评估与优化</a:t>
             </a:r>
           </a:p>
         </p:txBody>
@@ -4080,7 +4104,31 @@
                 <a:ea typeface="Microsoft YaHei"/>
                 <a:cs typeface="Microsoft YaHei"/>
               </a:rPr>
-              <a:t>这一版 SGLang 在这颗芯片上能开哪些特性、插件要补什么</a:t>
+              <a:t>这一版 SGLang 在 M100 上能开哪些特性、</a:t>
+            </a:r>
+          </a:p>
+          <a:p>
+            <a:pPr algn="l" latinLnBrk="0">
+              <a:lnSpc>
+                <a:spcPct val="110000"/>
+              </a:lnSpc>
+              <a:spcBef>
+                <a:spcPts val="0"/>
+              </a:spcBef>
+              <a:spcAft>
+                <a:spcPts val="0"/>
+              </a:spcAft>
+            </a:pPr>
+            <a:r>
+              <a:rPr sz="1150" b="0">
+                <a:solidFill>
+                  <a:srgbClr val="35424F"/>
+                </a:solidFill>
+                <a:latin typeface="Microsoft YaHei"/>
+                <a:ea typeface="Microsoft YaHei"/>
+                <a:cs typeface="Microsoft YaHei"/>
+              </a:rPr>
+              <a:t>插件要补什么</a:t>
             </a:r>
           </a:p>
         </p:txBody>
@@ -4540,7 +4588,7 @@
         <p:spPr>
           <a:xfrm>
             <a:off x="1371600" y="3858768"/>
-            <a:ext cx="3611880" cy="457200"/>
+            <a:ext cx="3675887" cy="457200"/>
           </a:xfrm>
           <a:prstGeom prst="rect">
             <a:avLst/>
@@ -4573,7 +4621,7 @@
                 <a:ea typeface="Microsoft YaHei"/>
                 <a:cs typeface="Microsoft YaHei"/>
               </a:rPr>
-              <a:t>新模型能不能上、怎么上、按 SLO 最少几张卡</a:t>
+              <a:t>新模型能不能上、怎么配、单机 SLO 内能扛多少</a:t>
             </a:r>
           </a:p>
         </p:txBody>
@@ -5033,7 +5081,7 @@
         <p:spPr>
           <a:xfrm>
             <a:off x="7894015" y="3858768"/>
-            <a:ext cx="3611880" cy="457200"/>
+            <a:ext cx="3675887" cy="457200"/>
           </a:xfrm>
           <a:prstGeom prst="rect">
             <a:avLst/>
@@ -6277,7 +6325,7 @@
                 <a:ea typeface="Microsoft YaHei"/>
                 <a:cs typeface="Microsoft YaHei"/>
               </a:rPr>
-              <a:t>SGLang 每升一版，Agent 重算这颗芯片能开哪些特性、怎么调</a:t>
+              <a:t>SGLang 每升一版，Agent 重算 M100 能开哪些特性、怎么调</a:t>
             </a:r>
           </a:p>
         </p:txBody>
@@ -6448,7 +6496,7 @@
                 <a:ea typeface="Microsoft YaHei"/>
                 <a:cs typeface="Microsoft YaHei"/>
               </a:rPr>
-              <a:t>新芯片 YAML</a:t>
+              <a:t>M100 插件更新</a:t>
             </a:r>
           </a:p>
         </p:txBody>
@@ -7393,7 +7441,7 @@
         <p:spPr>
           <a:xfrm>
             <a:off x="7635240" y="3493008"/>
-            <a:ext cx="2834640" cy="256032"/>
+            <a:ext cx="3200400" cy="256032"/>
           </a:xfrm>
           <a:prstGeom prst="roundRect">
             <a:avLst>
@@ -8700,7 +8748,7 @@
                 <a:ea typeface="Microsoft YaHei"/>
                 <a:cs typeface="Microsoft YaHei"/>
               </a:rPr>
-              <a:t>新模型上芯片：从“能不能跑”一路推到“按 SLO 最少几张卡”</a:t>
+              <a:t>新模型上 M100：从“能不能跑”一路推到“单机 SLO 内扛多少”</a:t>
             </a:r>
           </a:p>
         </p:txBody>
@@ -8847,7 +8895,7 @@
                 <a:ea typeface="Microsoft YaHei"/>
                 <a:cs typeface="Microsoft YaHei"/>
               </a:rPr>
-              <a:t>满足 SLO 的</a:t>
+              <a:t>单机 SLO 内</a:t>
             </a:r>
           </a:p>
           <a:p>
@@ -8871,7 +8919,7 @@
                 <a:ea typeface="Microsoft YaHei"/>
                 <a:cs typeface="Microsoft YaHei"/>
               </a:rPr>
-              <a:t>最少卡数</a:t>
+              <a:t>能扛多少请求</a:t>
             </a:r>
           </a:p>
         </p:txBody>
@@ -9053,7 +9101,7 @@
                 <a:ea typeface="Microsoft YaHei"/>
                 <a:cs typeface="Microsoft YaHei"/>
               </a:rPr>
-              <a:t>按精度定最少卡数</a:t>
+              <a:t>按精度算几卡放得下</a:t>
             </a:r>
           </a:p>
         </p:txBody>
@@ -9762,7 +9810,7 @@
                 <a:ea typeface="Microsoft YaHei"/>
                 <a:cs typeface="Microsoft YaHei"/>
               </a:rPr>
-              <a:t>每个实例规模先套 Loop A 调好的 launch；TTFT 卡住时试更短的 prefill，TPOT 卡住时试 mixed chunk（1024 / 512 / 256）</a:t>
+              <a:t>先套 Loop A 调好的 launch；TTFT 先超标时试 prefill 更快的布局（prefill CP、关 DP attention），TPOT 先超标且没开投机解码时试 mixed chunk（1024 / 512 / 256）</a:t>
             </a:r>
           </a:p>
         </p:txBody>
@@ -9775,7 +9823,7 @@
         </p:nvSpPr>
         <p:spPr>
           <a:xfrm>
-            <a:off x="6629400" y="2944368"/>
+            <a:off x="6629400" y="3008376"/>
             <a:ext cx="310896" cy="310896"/>
           </a:xfrm>
           <a:prstGeom prst="ellipse">
@@ -9827,7 +9875,7 @@
         </p:nvSpPr>
         <p:spPr>
           <a:xfrm>
-            <a:off x="7068312" y="2926080"/>
+            <a:off x="7068312" y="2990088"/>
             <a:ext cx="4574743" cy="329184"/>
           </a:xfrm>
           <a:prstGeom prst="rect">
@@ -9874,7 +9922,7 @@
         </p:nvSpPr>
         <p:spPr>
           <a:xfrm>
-            <a:off x="7068312" y="3273552"/>
+            <a:off x="7068312" y="3337560"/>
             <a:ext cx="4574743" cy="914400"/>
           </a:xfrm>
           <a:prstGeom prst="rect">
@@ -9908,7 +9956,7 @@
                 <a:ea typeface="Microsoft YaHei"/>
                 <a:cs typeface="Microsoft YaHei"/>
               </a:rPr>
-              <a:t>仿真 SGLang 调度：prefill 优先、chunked prefill、KV 准入与回收、DP rank 同步走 step；按 P90 判 SLO，再把整集群放到 router 后复核，不达标最多加 3 个实例</a:t>
+              <a:t>仿真 SGLang 调度：prefill 优先、chunked prefill、KV 准入与回收、DP rank 同步走 step；按 P90 判 SLO，二分搜索单机在 SLO 内的最大到达率</a:t>
             </a:r>
           </a:p>
         </p:txBody>
@@ -9921,7 +9969,7 @@
         </p:nvSpPr>
         <p:spPr>
           <a:xfrm>
-            <a:off x="6629400" y="4242816"/>
+            <a:off x="6629400" y="4187951"/>
             <a:ext cx="310896" cy="310896"/>
           </a:xfrm>
           <a:prstGeom prst="ellipse">
@@ -9973,7 +10021,7 @@
         </p:nvSpPr>
         <p:spPr>
           <a:xfrm>
-            <a:off x="7068312" y="4224528"/>
+            <a:off x="7068312" y="4169663"/>
             <a:ext cx="4574743" cy="329184"/>
           </a:xfrm>
           <a:prstGeom prst="rect">
@@ -10020,7 +10068,7 @@
         </p:nvSpPr>
         <p:spPr>
           <a:xfrm>
-            <a:off x="7068312" y="4572000"/>
+            <a:off x="7068312" y="4517136"/>
             <a:ext cx="4574743" cy="914400"/>
           </a:xfrm>
           <a:prstGeom prst="rect">
@@ -10096,8 +10144,8 @@
         </p:nvSpPr>
         <p:spPr>
           <a:xfrm>
-            <a:off x="6812280" y="5303520"/>
-            <a:ext cx="4647895" cy="868680"/>
+            <a:off x="6793992" y="5303520"/>
+            <a:ext cx="4739335" cy="868680"/>
           </a:xfrm>
           <a:prstGeom prst="rect">
             <a:avLst/>
@@ -10165,7 +10213,7 @@
                 <a:ea typeface="Microsoft YaHei"/>
                 <a:cs typeface="Microsoft YaHei"/>
               </a:rPr>
-              <a:t>算子缺口按占 step 比例分级（≥10% 高、≥3% 中），交给 Loop C</a:t>
+              <a:t>算子缺口按占 step 比例分级（≥10% 高、≥3% 中）交给 Loop C</a:t>
             </a:r>
           </a:p>
           <a:p>
@@ -10854,7 +10902,7 @@
                 <a:ea typeface="Microsoft YaHei"/>
                 <a:cs typeface="Microsoft YaHei"/>
               </a:rPr>
-              <a:t>本芯片实际走的路径</a:t>
+              <a:t>M100 上实际走的路径</a:t>
             </a:r>
             <a:r>
               <a:rPr sz="1050" b="0">
@@ -11192,7 +11240,7 @@
                 <a:ea typeface="Microsoft YaHei"/>
                 <a:cs typeface="Microsoft YaHei"/>
               </a:rPr>
-              <a:t>回落 torch 参考实现</a:t>
+              <a:t>回落 torch 实现</a:t>
             </a:r>
           </a:p>
         </p:txBody>
@@ -12635,7 +12683,7 @@
                 <a:ea typeface="Microsoft YaHei"/>
                 <a:cs typeface="Microsoft YaHei"/>
               </a:rPr>
-              <a:t>平台 kernel → 核对是否被分发到 → 真实形状复测 → Loop B 换算模型级收益</a:t>
+              <a:t>平台 kernel → 核对是否被分发 → 真实形状复测 → Loop B 换算模型级收益</a:t>
             </a:r>
           </a:p>
         </p:txBody>
@@ -12888,7 +12936,7 @@
                 <a:ea typeface="Microsoft YaHei"/>
                 <a:cs typeface="Microsoft YaHei"/>
               </a:rPr>
-              <a:t>我们不止做算子级：以算子级结果为输入，一路评估到 step、调度、SLO 和卡数</a:t>
+              <a:t>我们不止做算子级：以算子级结果为输入，一路评估到 step、调度和单机 SLO</a:t>
             </a:r>
           </a:p>
         </p:txBody>
@@ -12949,7 +12997,7 @@
         <p:spPr>
           <a:xfrm>
             <a:off x="2331720" y="1783080"/>
-            <a:ext cx="4983480" cy="457200"/>
+            <a:ext cx="4892040" cy="457200"/>
           </a:xfrm>
           <a:prstGeom prst="rect">
             <a:avLst/>
@@ -12995,8 +13043,8 @@
         </p:nvSpPr>
         <p:spPr>
           <a:xfrm>
-            <a:off x="7315200" y="1783080"/>
-            <a:ext cx="1965960" cy="457200"/>
+            <a:off x="7269480" y="1783080"/>
+            <a:ext cx="1371600" cy="457200"/>
           </a:xfrm>
           <a:prstGeom prst="rect">
             <a:avLst/>
@@ -13009,19 +13057,97 @@
           </a:bodyPr>
           <a:lstStyle/>
           <a:p>
-            <a:pPr algn="ctr" latinLnBrk="0">
-              <a:lnSpc>
-                <a:spcPct val="100000"/>
-              </a:lnSpc>
-              <a:spcBef>
-                <a:spcPts val="0"/>
-              </a:spcBef>
-              <a:spcAft>
-                <a:spcPts val="0"/>
-              </a:spcAft>
-            </a:pPr>
-            <a:r>
-              <a:rPr sz="1200" b="1">
+            <a:pPr algn="l" latinLnBrk="0">
+              <a:lnSpc>
+                <a:spcPct val="100000"/>
+              </a:lnSpc>
+              <a:spcBef>
+                <a:spcPts val="0"/>
+              </a:spcBef>
+              <a:spcAft>
+                <a:spcPts val="0"/>
+              </a:spcAft>
+            </a:pPr>
+            <a:r>
+              <a:rPr sz="1150" b="1">
+                <a:solidFill>
+                  <a:srgbClr val="66727F"/>
+                </a:solidFill>
+                <a:latin typeface="Microsoft YaHei"/>
+                <a:ea typeface="Microsoft YaHei"/>
+                <a:cs typeface="Microsoft YaHei"/>
+              </a:rPr>
+              <a:t>谁来做 · 怎么做</a:t>
+            </a:r>
+          </a:p>
+        </p:txBody>
+      </p:sp>
+      <p:sp>
+        <p:nvSpPr>
+          <p:cNvPr id="8" name="Rounded Rectangle 7"/>
+          <p:cNvSpPr/>
+          <p:nvPr/>
+        </p:nvSpPr>
+        <p:spPr>
+          <a:xfrm>
+            <a:off x="8595360" y="1947672"/>
+            <a:ext cx="128016" cy="128016"/>
+          </a:xfrm>
+          <a:prstGeom prst="roundRect">
+            <a:avLst>
+              <a:gd name="adj" fmla="val 20000"/>
+            </a:avLst>
+          </a:prstGeom>
+          <a:solidFill>
+            <a:srgbClr val="1E8A6E"/>
+          </a:solidFill>
+          <a:ln>
+            <a:noFill/>
+          </a:ln>
+        </p:spPr>
+        <p:txBody>
+          <a:bodyPr rtlCol="0" anchor="ctr"/>
+          <a:lstStyle/>
+          <a:p>
+            <a:pPr algn="ctr"/>
+          </a:p>
+        </p:txBody>
+      </p:sp>
+      <p:sp>
+        <p:nvSpPr>
+          <p:cNvPr id="9" name="TextBox 8"/>
+          <p:cNvSpPr txBox="1"/>
+          <p:nvPr/>
+        </p:nvSpPr>
+        <p:spPr>
+          <a:xfrm>
+            <a:off x="8778240" y="1783080"/>
+            <a:ext cx="1024128" cy="457200"/>
+          </a:xfrm>
+          <a:prstGeom prst="rect">
+            <a:avLst/>
+          </a:prstGeom>
+          <a:noFill/>
+        </p:spPr>
+        <p:txBody>
+          <a:bodyPr wrap="square" anchor="ctr" lIns="0" tIns="0" rIns="0" bIns="0">
+            <a:noAutofit/>
+          </a:bodyPr>
+          <a:lstStyle/>
+          <a:p>
+            <a:pPr algn="l" latinLnBrk="0">
+              <a:lnSpc>
+                <a:spcPct val="100000"/>
+              </a:lnSpc>
+              <a:spcBef>
+                <a:spcPts val="0"/>
+              </a:spcBef>
+              <a:spcAft>
+                <a:spcPts val="0"/>
+              </a:spcAft>
+            </a:pPr>
+            <a:r>
+              <a:rPr sz="1000" b="1">
                 <a:solidFill>
                   <a:srgbClr val="35424F"/>
                 </a:solidFill>
@@ -13029,45 +13155,52 @@
                 <a:ea typeface="Microsoft YaHei"/>
                 <a:cs typeface="Microsoft YaHei"/>
               </a:rPr>
-              <a:t>平台算子 Agent</a:t>
-            </a:r>
-          </a:p>
-          <a:p>
-            <a:pPr algn="ctr" latinLnBrk="0">
-              <a:lnSpc>
-                <a:spcPct val="100000"/>
-              </a:lnSpc>
-              <a:spcBef>
-                <a:spcPts val="0"/>
-              </a:spcBef>
-              <a:spcAft>
-                <a:spcPts val="0"/>
-              </a:spcAft>
-            </a:pPr>
-            <a:r>
-              <a:rPr sz="1000" b="0">
-                <a:solidFill>
-                  <a:srgbClr val="66727F"/>
-                </a:solidFill>
-                <a:latin typeface="Microsoft YaHei"/>
-                <a:ea typeface="Microsoft YaHei"/>
-                <a:cs typeface="Microsoft YaHei"/>
-              </a:rPr>
-              <a:t>算子级</a:t>
-            </a:r>
-          </a:p>
-        </p:txBody>
-      </p:sp>
-      <p:sp>
-        <p:nvSpPr>
-          <p:cNvPr id="8" name="TextBox 7"/>
+              <a:t>我们 · 模型级</a:t>
+            </a:r>
+          </a:p>
+        </p:txBody>
+      </p:sp>
+      <p:sp>
+        <p:nvSpPr>
+          <p:cNvPr id="10" name="Rounded Rectangle 9"/>
+          <p:cNvSpPr/>
+          <p:nvPr/>
+        </p:nvSpPr>
+        <p:spPr>
+          <a:xfrm>
+            <a:off x="9802368" y="1947672"/>
+            <a:ext cx="128016" cy="128016"/>
+          </a:xfrm>
+          <a:prstGeom prst="roundRect">
+            <a:avLst>
+              <a:gd name="adj" fmla="val 20000"/>
+            </a:avLst>
+          </a:prstGeom>
+          <a:solidFill>
+            <a:srgbClr val="35424F"/>
+          </a:solidFill>
+          <a:ln>
+            <a:noFill/>
+          </a:ln>
+        </p:spPr>
+        <p:txBody>
+          <a:bodyPr rtlCol="0" anchor="ctr"/>
+          <a:lstStyle/>
+          <a:p>
+            <a:pPr algn="ctr"/>
+          </a:p>
+        </p:txBody>
+      </p:sp>
+      <p:sp>
+        <p:nvSpPr>
+          <p:cNvPr id="11" name="TextBox 10"/>
           <p:cNvSpPr txBox="1"/>
           <p:nvPr/>
         </p:nvSpPr>
         <p:spPr>
           <a:xfrm>
-            <a:off x="9372600" y="1783080"/>
-            <a:ext cx="2270455" cy="457200"/>
+            <a:off x="9985248" y="1783080"/>
+            <a:ext cx="1627632" cy="457200"/>
           </a:xfrm>
           <a:prstGeom prst="rect">
             <a:avLst/>
@@ -13080,58 +13213,34 @@
           </a:bodyPr>
           <a:lstStyle/>
           <a:p>
-            <a:pPr algn="ctr" latinLnBrk="0">
-              <a:lnSpc>
-                <a:spcPct val="100000"/>
-              </a:lnSpc>
-              <a:spcBef>
-                <a:spcPts val="0"/>
-              </a:spcBef>
-              <a:spcAft>
-                <a:spcPts val="0"/>
-              </a:spcAft>
-            </a:pPr>
-            <a:r>
-              <a:rPr sz="1200" b="1">
-                <a:solidFill>
-                  <a:srgbClr val="1E8A6E"/>
-                </a:solidFill>
-                <a:latin typeface="Microsoft YaHei"/>
-                <a:ea typeface="Microsoft YaHei"/>
-                <a:cs typeface="Microsoft YaHei"/>
-              </a:rPr>
-              <a:t>sglang-maestro</a:t>
-            </a:r>
-          </a:p>
-          <a:p>
-            <a:pPr algn="ctr" latinLnBrk="0">
-              <a:lnSpc>
-                <a:spcPct val="100000"/>
-              </a:lnSpc>
-              <a:spcBef>
-                <a:spcPts val="0"/>
-              </a:spcBef>
-              <a:spcAft>
-                <a:spcPts val="0"/>
-              </a:spcAft>
-            </a:pPr>
-            <a:r>
-              <a:rPr sz="1000" b="0">
-                <a:solidFill>
-                  <a:srgbClr val="1E8A6E"/>
-                </a:solidFill>
-                <a:latin typeface="Microsoft YaHei"/>
-                <a:ea typeface="Microsoft YaHei"/>
-                <a:cs typeface="Microsoft YaHei"/>
-              </a:rPr>
-              <a:t>基于算子级 → 模型级</a:t>
-            </a:r>
-          </a:p>
-        </p:txBody>
-      </p:sp>
-      <p:sp>
-        <p:nvSpPr>
-          <p:cNvPr id="9" name="Rectangle 8"/>
+            <a:pPr algn="l" latinLnBrk="0">
+              <a:lnSpc>
+                <a:spcPct val="100000"/>
+              </a:lnSpc>
+              <a:spcBef>
+                <a:spcPts val="0"/>
+              </a:spcBef>
+              <a:spcAft>
+                <a:spcPts val="0"/>
+              </a:spcAft>
+            </a:pPr>
+            <a:r>
+              <a:rPr sz="1000" b="1">
+                <a:solidFill>
+                  <a:srgbClr val="35424F"/>
+                </a:solidFill>
+                <a:latin typeface="Microsoft YaHei"/>
+                <a:ea typeface="Microsoft YaHei"/>
+                <a:cs typeface="Microsoft YaHei"/>
+              </a:rPr>
+              <a:t>平台算子 Agent · 算子级</a:t>
+            </a:r>
+          </a:p>
+        </p:txBody>
+      </p:sp>
+      <p:sp>
+        <p:nvSpPr>
+          <p:cNvPr id="12" name="Rectangle 11"/>
           <p:cNvSpPr/>
           <p:nvPr/>
         </p:nvSpPr>
@@ -13187,21 +13296,21 @@
                 <a:ea typeface="Microsoft YaHei"/>
                 <a:cs typeface="Microsoft YaHei"/>
               </a:rPr>
-              <a:t>集群与 SLO</a:t>
-            </a:r>
-          </a:p>
-        </p:txBody>
-      </p:sp>
-      <p:sp>
-        <p:nvSpPr>
-          <p:cNvPr id="10" name="Rectangle 9"/>
+              <a:t>单机 SLO</a:t>
+            </a:r>
+          </a:p>
+        </p:txBody>
+      </p:sp>
+      <p:sp>
+        <p:nvSpPr>
+          <p:cNvPr id="13" name="Rectangle 12"/>
           <p:cNvSpPr/>
           <p:nvPr/>
         </p:nvSpPr>
         <p:spPr>
           <a:xfrm>
             <a:off x="2240280" y="2331720"/>
-            <a:ext cx="4983480" cy="530352"/>
+            <a:ext cx="4892040" cy="530352"/>
           </a:xfrm>
           <a:prstGeom prst="rect">
             <a:avLst/>
@@ -13239,21 +13348,21 @@
                 <a:ea typeface="Microsoft YaHei"/>
                 <a:cs typeface="Microsoft YaHei"/>
               </a:rPr>
-              <a:t>满足 SLO 最少几张卡？实例怎么切、几个副本、router 怎么配？</a:t>
-            </a:r>
-          </a:p>
-        </p:txBody>
-      </p:sp>
-      <p:sp>
-        <p:nvSpPr>
-          <p:cNvPr id="11" name="Rectangle 10"/>
+              <a:t>单机在 SLO 内能扛多少请求？先超标的是 TTFT 还是 TPOT？</a:t>
+            </a:r>
+          </a:p>
+        </p:txBody>
+      </p:sp>
+      <p:sp>
+        <p:nvSpPr>
+          <p:cNvPr id="14" name="Rectangle 13"/>
           <p:cNvSpPr/>
           <p:nvPr/>
         </p:nvSpPr>
         <p:spPr>
           <a:xfrm>
-            <a:off x="9372600" y="2331720"/>
-            <a:ext cx="2270455" cy="530352"/>
+            <a:off x="7269480" y="2331720"/>
+            <a:ext cx="4373575" cy="530352"/>
           </a:xfrm>
           <a:prstGeom prst="rect">
             <a:avLst/>
@@ -13266,24 +13375,24 @@
           </a:ln>
         </p:spPr>
         <p:txBody>
-          <a:bodyPr rtlCol="0" anchor="ctr" wrap="square" lIns="73152" tIns="0" rIns="73152" bIns="0">
+          <a:bodyPr rtlCol="0" anchor="ctr" wrap="square" tIns="0" bIns="0">
             <a:noAutofit/>
           </a:bodyPr>
           <a:lstStyle/>
           <a:p>
             <a:pPr algn="ctr" latinLnBrk="0">
               <a:lnSpc>
-                <a:spcPct val="105000"/>
-              </a:lnSpc>
-              <a:spcBef>
-                <a:spcPts val="0"/>
-              </a:spcBef>
-              <a:spcAft>
-                <a:spcPts val="0"/>
-              </a:spcAft>
-            </a:pPr>
-            <a:r>
-              <a:rPr sz="1050" b="1">
+                <a:spcPct val="100000"/>
+              </a:lnSpc>
+              <a:spcBef>
+                <a:spcPts val="0"/>
+              </a:spcBef>
+              <a:spcAft>
+                <a:spcPts val="0"/>
+              </a:spcAft>
+            </a:pPr>
+            <a:r>
+              <a:rPr sz="1100" b="1">
                 <a:solidFill>
                   <a:srgbClr val="FFFFFF"/>
                 </a:solidFill>
@@ -13291,14 +13400,14 @@
                 <a:ea typeface="Microsoft YaHei"/>
                 <a:cs typeface="Microsoft YaHei"/>
               </a:rPr>
-              <a:t>部署仿真与规划</a:t>
-            </a:r>
-          </a:p>
-        </p:txBody>
-      </p:sp>
-      <p:sp>
-        <p:nvSpPr>
-          <p:cNvPr id="12" name="Rectangle 11"/>
+              <a:t>单机部署仿真：二分搜索 SLO 内最大到达率</a:t>
+            </a:r>
+          </a:p>
+        </p:txBody>
+      </p:sp>
+      <p:sp>
+        <p:nvSpPr>
+          <p:cNvPr id="15" name="Rectangle 14"/>
           <p:cNvSpPr/>
           <p:nvPr/>
         </p:nvSpPr>
@@ -13361,14 +13470,14 @@
       </p:sp>
       <p:sp>
         <p:nvSpPr>
-          <p:cNvPr id="13" name="Rectangle 12"/>
+          <p:cNvPr id="16" name="Rectangle 15"/>
           <p:cNvSpPr/>
           <p:nvPr/>
         </p:nvSpPr>
         <p:spPr>
           <a:xfrm>
             <a:off x="2240280" y="2926079"/>
-            <a:ext cx="4983480" cy="530352"/>
+            <a:ext cx="4892040" cy="530352"/>
           </a:xfrm>
           <a:prstGeom prst="rect">
             <a:avLst/>
@@ -13406,21 +13515,21 @@
                 <a:ea typeface="Microsoft YaHei"/>
                 <a:cs typeface="Microsoft YaHei"/>
               </a:rPr>
-              <a:t>chunked prefill、KV 准入、DP attention、投机解码、HiCache 怎么开？</a:t>
-            </a:r>
-          </a:p>
-        </p:txBody>
-      </p:sp>
-      <p:sp>
-        <p:nvSpPr>
-          <p:cNvPr id="14" name="Rectangle 13"/>
+              <a:t>chunked prefill、DP attention、投机解码、HiCache 怎么开？</a:t>
+            </a:r>
+          </a:p>
+        </p:txBody>
+      </p:sp>
+      <p:sp>
+        <p:nvSpPr>
+          <p:cNvPr id="17" name="Rectangle 16"/>
           <p:cNvSpPr/>
           <p:nvPr/>
         </p:nvSpPr>
         <p:spPr>
           <a:xfrm>
-            <a:off x="9372600" y="2926079"/>
-            <a:ext cx="2270455" cy="530352"/>
+            <a:off x="7269480" y="2926079"/>
+            <a:ext cx="4373575" cy="530352"/>
           </a:xfrm>
           <a:prstGeom prst="rect">
             <a:avLst/>
@@ -13433,24 +13542,24 @@
           </a:ln>
         </p:spPr>
         <p:txBody>
-          <a:bodyPr rtlCol="0" anchor="ctr" wrap="square" lIns="73152" tIns="0" rIns="73152" bIns="0">
+          <a:bodyPr rtlCol="0" anchor="ctr" wrap="square" tIns="0" bIns="0">
             <a:noAutofit/>
           </a:bodyPr>
           <a:lstStyle/>
           <a:p>
             <a:pPr algn="ctr" latinLnBrk="0">
               <a:lnSpc>
-                <a:spcPct val="105000"/>
-              </a:lnSpc>
-              <a:spcBef>
-                <a:spcPts val="0"/>
-              </a:spcBef>
-              <a:spcAft>
-                <a:spcPts val="0"/>
-              </a:spcAft>
-            </a:pPr>
-            <a:r>
-              <a:rPr sz="1050" b="1">
+                <a:spcPct val="100000"/>
+              </a:lnSpc>
+              <a:spcBef>
+                <a:spcPts val="0"/>
+              </a:spcBef>
+              <a:spcAft>
+                <a:spcPts val="0"/>
+              </a:spcAft>
+            </a:pPr>
+            <a:r>
+              <a:rPr sz="1100" b="1">
                 <a:solidFill>
                   <a:srgbClr val="FFFFFF"/>
                 </a:solidFill>
@@ -13465,7 +13574,7 @@
       </p:sp>
       <p:sp>
         <p:nvSpPr>
-          <p:cNvPr id="15" name="Rectangle 14"/>
+          <p:cNvPr id="18" name="Rectangle 17"/>
           <p:cNvSpPr/>
           <p:nvPr/>
         </p:nvSpPr>
@@ -13528,14 +13637,14 @@
       </p:sp>
       <p:sp>
         <p:nvSpPr>
-          <p:cNvPr id="16" name="Rectangle 15"/>
+          <p:cNvPr id="19" name="Rectangle 18"/>
           <p:cNvSpPr/>
           <p:nvPr/>
         </p:nvSpPr>
         <p:spPr>
           <a:xfrm>
             <a:off x="2240280" y="3520439"/>
-            <a:ext cx="4983480" cy="530352"/>
+            <a:ext cx="4892040" cy="530352"/>
           </a:xfrm>
           <a:prstGeom prst="rect">
             <a:avLst/>
@@ -13580,14 +13689,14 @@
       </p:sp>
       <p:sp>
         <p:nvSpPr>
-          <p:cNvPr id="17" name="Rectangle 16"/>
+          <p:cNvPr id="20" name="Rectangle 19"/>
           <p:cNvSpPr/>
           <p:nvPr/>
         </p:nvSpPr>
         <p:spPr>
           <a:xfrm>
-            <a:off x="9372600" y="3520439"/>
-            <a:ext cx="2270455" cy="530352"/>
+            <a:off x="7269480" y="3520439"/>
+            <a:ext cx="4373575" cy="530352"/>
           </a:xfrm>
           <a:prstGeom prst="rect">
             <a:avLst/>
@@ -13600,24 +13709,24 @@
           </a:ln>
         </p:spPr>
         <p:txBody>
-          <a:bodyPr rtlCol="0" anchor="ctr" wrap="square" lIns="73152" tIns="0" rIns="73152" bIns="0">
+          <a:bodyPr rtlCol="0" anchor="ctr" wrap="square" tIns="0" bIns="0">
             <a:noAutofit/>
           </a:bodyPr>
           <a:lstStyle/>
           <a:p>
             <a:pPr algn="ctr" latinLnBrk="0">
               <a:lnSpc>
-                <a:spcPct val="105000"/>
-              </a:lnSpc>
-              <a:spcBef>
-                <a:spcPts val="0"/>
-              </a:spcBef>
-              <a:spcAft>
-                <a:spcPts val="0"/>
-              </a:spcAft>
-            </a:pPr>
-            <a:r>
-              <a:rPr sz="1050" b="1">
+                <a:spcPct val="100000"/>
+              </a:lnSpc>
+              <a:spcBef>
+                <a:spcPts val="0"/>
+              </a:spcBef>
+              <a:spcAft>
+                <a:spcPts val="0"/>
+              </a:spcAft>
+            </a:pPr>
+            <a:r>
+              <a:rPr sz="1100" b="1">
                 <a:solidFill>
                   <a:srgbClr val="FFFFFF"/>
                 </a:solidFill>
@@ -13625,14 +13734,14 @@
                 <a:ea typeface="Microsoft YaHei"/>
                 <a:cs typeface="Microsoft YaHei"/>
               </a:rPr>
-              <a:t>trace 期望对实测；融合 / 重叠 / 多流 / 预取</a:t>
-            </a:r>
-          </a:p>
-        </p:txBody>
-      </p:sp>
-      <p:sp>
-        <p:nvSpPr>
-          <p:cNvPr id="18" name="Rectangle 17"/>
+              <a:t>trace 期望对实测；评估融合、通算重叠、多流、预取</a:t>
+            </a:r>
+          </a:p>
+        </p:txBody>
+      </p:sp>
+      <p:sp>
+        <p:nvSpPr>
+          <p:cNvPr id="21" name="Rectangle 20"/>
           <p:cNvSpPr/>
           <p:nvPr/>
         </p:nvSpPr>
@@ -13695,14 +13804,14 @@
       </p:sp>
       <p:sp>
         <p:nvSpPr>
-          <p:cNvPr id="19" name="Rectangle 18"/>
+          <p:cNvPr id="22" name="Rectangle 21"/>
           <p:cNvSpPr/>
           <p:nvPr/>
         </p:nvSpPr>
         <p:spPr>
           <a:xfrm>
             <a:off x="2240280" y="4114800"/>
-            <a:ext cx="4983480" cy="530352"/>
+            <a:ext cx="4892040" cy="530352"/>
           </a:xfrm>
           <a:prstGeom prst="rect">
             <a:avLst/>
@@ -13747,14 +13856,14 @@
       </p:sp>
       <p:sp>
         <p:nvSpPr>
-          <p:cNvPr id="20" name="Rectangle 19"/>
+          <p:cNvPr id="23" name="Rectangle 22"/>
           <p:cNvSpPr/>
           <p:nvPr/>
         </p:nvSpPr>
         <p:spPr>
           <a:xfrm>
-            <a:off x="9372600" y="4114800"/>
-            <a:ext cx="2270455" cy="530352"/>
+            <a:off x="7269480" y="4114800"/>
+            <a:ext cx="4373575" cy="530352"/>
           </a:xfrm>
           <a:prstGeom prst="rect">
             <a:avLst/>
@@ -13767,24 +13876,24 @@
           </a:ln>
         </p:spPr>
         <p:txBody>
-          <a:bodyPr rtlCol="0" anchor="ctr" wrap="square" lIns="73152" tIns="0" rIns="73152" bIns="0">
+          <a:bodyPr rtlCol="0" anchor="ctr" wrap="square" tIns="0" bIns="0">
             <a:noAutofit/>
           </a:bodyPr>
           <a:lstStyle/>
           <a:p>
             <a:pPr algn="ctr" latinLnBrk="0">
               <a:lnSpc>
-                <a:spcPct val="105000"/>
-              </a:lnSpc>
-              <a:spcBef>
-                <a:spcPts val="0"/>
-              </a:spcBef>
-              <a:spcAft>
-                <a:spcPts val="0"/>
-              </a:spcAft>
-            </a:pPr>
-            <a:r>
-              <a:rPr sz="1050" b="1">
+                <a:spcPct val="100000"/>
+              </a:lnSpc>
+              <a:spcBef>
+                <a:spcPts val="0"/>
+              </a:spcBef>
+              <a:spcAft>
+                <a:spcPts val="0"/>
+              </a:spcAft>
+            </a:pPr>
+            <a:r>
+              <a:rPr sz="1100" b="1">
                 <a:solidFill>
                   <a:srgbClr val="FFFFFF"/>
                 </a:solidFill>
@@ -13792,14 +13901,14 @@
                 <a:ea typeface="Microsoft YaHei"/>
                 <a:cs typeface="Microsoft YaHei"/>
               </a:rPr>
-              <a:t>静态解析分发路径，缺口按占比排序</a:t>
-            </a:r>
-          </a:p>
-        </p:txBody>
-      </p:sp>
-      <p:sp>
-        <p:nvSpPr>
-          <p:cNvPr id="21" name="Rectangle 20"/>
+              <a:t>静态解析分发路径；缺口按占 step 比例排序</a:t>
+            </a:r>
+          </a:p>
+        </p:txBody>
+      </p:sp>
+      <p:sp>
+        <p:nvSpPr>
+          <p:cNvPr id="24" name="Rectangle 23"/>
           <p:cNvSpPr/>
           <p:nvPr/>
         </p:nvSpPr>
@@ -13862,14 +13971,14 @@
       </p:sp>
       <p:sp>
         <p:nvSpPr>
-          <p:cNvPr id="22" name="Rectangle 21"/>
+          <p:cNvPr id="25" name="Rectangle 24"/>
           <p:cNvSpPr/>
           <p:nvPr/>
         </p:nvSpPr>
         <p:spPr>
           <a:xfrm>
             <a:off x="2240280" y="4709159"/>
-            <a:ext cx="4983480" cy="530352"/>
+            <a:ext cx="4892040" cy="530352"/>
           </a:xfrm>
           <a:prstGeom prst="rect">
             <a:avLst/>
@@ -13914,14 +14023,14 @@
       </p:sp>
       <p:sp>
         <p:nvSpPr>
-          <p:cNvPr id="23" name="Rectangle 22"/>
+          <p:cNvPr id="26" name="Rectangle 25"/>
           <p:cNvSpPr/>
           <p:nvPr/>
         </p:nvSpPr>
         <p:spPr>
           <a:xfrm>
-            <a:off x="7315200" y="4709159"/>
-            <a:ext cx="1965960" cy="530352"/>
+            <a:off x="7269480" y="4709159"/>
+            <a:ext cx="2141067" cy="530352"/>
           </a:xfrm>
           <a:prstGeom prst="rect">
             <a:avLst/>
@@ -13966,14 +14075,14 @@
       </p:sp>
       <p:sp>
         <p:nvSpPr>
-          <p:cNvPr id="24" name="Rectangle 23"/>
+          <p:cNvPr id="27" name="Rectangle 26"/>
           <p:cNvSpPr/>
           <p:nvPr/>
         </p:nvSpPr>
         <p:spPr>
           <a:xfrm>
-            <a:off x="9372600" y="4709159"/>
-            <a:ext cx="2270455" cy="530352"/>
+            <a:off x="9501987" y="4709159"/>
+            <a:ext cx="2141067" cy="530352"/>
           </a:xfrm>
           <a:prstGeom prst="rect">
             <a:avLst/>
@@ -14021,7 +14130,7 @@
       </p:sp>
       <p:sp>
         <p:nvSpPr>
-          <p:cNvPr id="25" name="Rectangle 24"/>
+          <p:cNvPr id="28" name="Rectangle 27"/>
           <p:cNvSpPr/>
           <p:nvPr/>
         </p:nvSpPr>
@@ -14050,7 +14159,7 @@
       </p:sp>
       <p:sp>
         <p:nvSpPr>
-          <p:cNvPr id="26" name="TextBox 25"/>
+          <p:cNvPr id="29" name="TextBox 28"/>
           <p:cNvSpPr txBox="1"/>
           <p:nvPr/>
         </p:nvSpPr>
@@ -14160,14 +14269,14 @@
                 <a:ea typeface="Microsoft YaHei"/>
                 <a:cs typeface="Microsoft YaHei"/>
               </a:rPr>
-              <a:t>满足 SLO 时的卡数、TTFT / TPOT、SLO 达成率</a:t>
-            </a:r>
-          </a:p>
-        </p:txBody>
-      </p:sp>
-      <p:sp>
-        <p:nvSpPr>
-          <p:cNvPr id="27" name="Rectangle 26"/>
+              <a:t>单机 SLO 内容量、TTFT / TPOT、SLO 达成率</a:t>
+            </a:r>
+          </a:p>
+        </p:txBody>
+      </p:sp>
+      <p:sp>
+        <p:nvSpPr>
+          <p:cNvPr id="30" name="Rectangle 29"/>
           <p:cNvSpPr/>
           <p:nvPr/>
         </p:nvSpPr>
@@ -14199,7 +14308,7 @@
       </p:sp>
       <p:sp>
         <p:nvSpPr>
-          <p:cNvPr id="28" name="TextBox 27"/>
+          <p:cNvPr id="31" name="TextBox 30"/>
           <p:cNvSpPr txBox="1"/>
           <p:nvPr/>
         </p:nvSpPr>
@@ -14316,7 +14425,7 @@
       </p:sp>
       <p:sp>
         <p:nvSpPr>
-          <p:cNvPr id="29" name="TextBox 28"/>
+          <p:cNvPr id="32" name="TextBox 31"/>
           <p:cNvSpPr txBox="1"/>
           <p:nvPr/>
         </p:nvSpPr>
@@ -14357,6 +14466,53 @@
                 <a:cs typeface="Microsoft YaHei"/>
               </a:rPr>
               <a:t>06 / 09</a:t>
+            </a:r>
+          </a:p>
+        </p:txBody>
+      </p:sp>
+      <p:sp>
+        <p:nvSpPr>
+          <p:cNvPr id="33" name="TextBox 32"/>
+          <p:cNvSpPr txBox="1"/>
+          <p:nvPr/>
+        </p:nvSpPr>
+        <p:spPr>
+          <a:xfrm>
+            <a:off x="548640" y="6382512"/>
+            <a:ext cx="9905695" cy="256032"/>
+          </a:xfrm>
+          <a:prstGeom prst="rect">
+            <a:avLst/>
+          </a:prstGeom>
+          <a:noFill/>
+        </p:spPr>
+        <p:txBody>
+          <a:bodyPr wrap="square" anchor="ctr" lIns="0" tIns="0" rIns="0" bIns="0">
+            <a:noAutofit/>
+          </a:bodyPr>
+          <a:lstStyle/>
+          <a:p>
+            <a:pPr algn="l" latinLnBrk="0">
+              <a:lnSpc>
+                <a:spcPct val="100000"/>
+              </a:lnSpc>
+              <a:spcBef>
+                <a:spcPts val="0"/>
+              </a:spcBef>
+              <a:spcAft>
+                <a:spcPts val="0"/>
+              </a:spcAft>
+            </a:pPr>
+            <a:r>
+              <a:rPr sz="1000" b="0">
+                <a:solidFill>
+                  <a:srgbClr val="66727F"/>
+                </a:solidFill>
+                <a:latin typeface="Microsoft YaHei"/>
+                <a:ea typeface="Microsoft YaHei"/>
+                <a:cs typeface="Microsoft YaHei"/>
+              </a:rPr>
+              <a:t>虚线 = 规划中：与平台算子 Agent 的自动对接</a:t>
             </a:r>
           </a:p>
         </p:txBody>
@@ -14468,7 +14624,7 @@
                 <a:ea typeface="Microsoft YaHei"/>
                 <a:cs typeface="Microsoft YaHei"/>
               </a:rPr>
-              <a:t>难点：算子快 30%，模型级收益可能是 0，也可能省下三分之一的卡</a:t>
+              <a:t>难点：算子同样快 30%，单机容量可能只涨 2%，也可能涨 40%</a:t>
             </a:r>
           </a:p>
         </p:txBody>
@@ -14515,7 +14671,7 @@
                 <a:ea typeface="Microsoft YaHei"/>
                 <a:cs typeface="Microsoft YaHei"/>
               </a:rPr>
-              <a:t>推演：Qwen3-32B · H20 预设 · 算子级成本模型 + 离散事件仿真；未经实测校准，只用来说明方法</a:t>
+              <a:t>推演：Qwen3-32B · 单机 8 卡、单个 TP8 实例 · 成本模型 + 离散事件仿真；未经实测校准，只用来说明方法</a:t>
             </a:r>
           </a:p>
         </p:txBody>
@@ -14528,8 +14684,8 @@
         </p:nvSpPr>
         <p:spPr>
           <a:xfrm>
-            <a:off x="2478024" y="1810512"/>
-            <a:ext cx="1298448" cy="475488"/>
+            <a:off x="694944" y="1810512"/>
+            <a:ext cx="1636776" cy="475488"/>
           </a:xfrm>
           <a:prstGeom prst="rect">
             <a:avLst/>
@@ -14542,7 +14698,7 @@
           </a:bodyPr>
           <a:lstStyle/>
           <a:p>
-            <a:pPr algn="ctr" latinLnBrk="0">
+            <a:pPr algn="l" latinLnBrk="0">
               <a:lnSpc>
                 <a:spcPct val="100000"/>
               </a:lnSpc>
@@ -14562,7 +14718,31 @@
                 <a:ea typeface="Microsoft YaHei"/>
                 <a:cs typeface="Microsoft YaHei"/>
               </a:rPr>
-              <a:t>基线</a:t>
+              <a:t>单机 SLO 内容量</a:t>
+            </a:r>
+          </a:p>
+          <a:p>
+            <a:pPr algn="l" latinLnBrk="0">
+              <a:lnSpc>
+                <a:spcPct val="100000"/>
+              </a:lnSpc>
+              <a:spcBef>
+                <a:spcPts val="0"/>
+              </a:spcBef>
+              <a:spcAft>
+                <a:spcPts val="0"/>
+              </a:spcAft>
+            </a:pPr>
+            <a:r>
+              <a:rPr sz="950" b="0">
+                <a:solidFill>
+                  <a:srgbClr val="66727F"/>
+                </a:solidFill>
+                <a:latin typeface="Microsoft YaHei"/>
+                <a:ea typeface="Microsoft YaHei"/>
+                <a:cs typeface="Microsoft YaHei"/>
+              </a:rPr>
+              <a:t>最大到达率</a:t>
             </a:r>
           </a:p>
         </p:txBody>
@@ -14575,8 +14755,8 @@
         </p:nvSpPr>
         <p:spPr>
           <a:xfrm>
-            <a:off x="3831335" y="1810512"/>
-            <a:ext cx="1298448" cy="475488"/>
+            <a:off x="2386584" y="1810512"/>
+            <a:ext cx="1371600" cy="475488"/>
           </a:xfrm>
           <a:prstGeom prst="rect">
             <a:avLst/>
@@ -14609,31 +14789,7 @@
                 <a:ea typeface="Microsoft YaHei"/>
                 <a:cs typeface="Microsoft YaHei"/>
               </a:rPr>
-              <a:t>attention</a:t>
-            </a:r>
-          </a:p>
-          <a:p>
-            <a:pPr algn="ctr" latinLnBrk="0">
-              <a:lnSpc>
-                <a:spcPct val="100000"/>
-              </a:lnSpc>
-              <a:spcBef>
-                <a:spcPts val="0"/>
-              </a:spcBef>
-              <a:spcAft>
-                <a:spcPts val="0"/>
-              </a:spcAft>
-            </a:pPr>
-            <a:r>
-              <a:rPr sz="1100" b="1">
-                <a:solidFill>
-                  <a:srgbClr val="35424F"/>
-                </a:solidFill>
-                <a:latin typeface="Microsoft YaHei"/>
-                <a:ea typeface="Microsoft YaHei"/>
-                <a:cs typeface="Microsoft YaHei"/>
-              </a:rPr>
-              <a:t>耗时 −30%</a:t>
+              <a:t>基线</a:t>
             </a:r>
           </a:p>
         </p:txBody>
@@ -14646,8 +14802,8 @@
         </p:nvSpPr>
         <p:spPr>
           <a:xfrm>
-            <a:off x="5184648" y="1810512"/>
-            <a:ext cx="1298448" cy="475488"/>
+            <a:off x="3813048" y="1810512"/>
+            <a:ext cx="1371600" cy="475488"/>
           </a:xfrm>
           <a:prstGeom prst="rect">
             <a:avLst/>
@@ -14680,6 +14836,77 @@
                 <a:ea typeface="Microsoft YaHei"/>
                 <a:cs typeface="Microsoft YaHei"/>
               </a:rPr>
+              <a:t>attention</a:t>
+            </a:r>
+          </a:p>
+          <a:p>
+            <a:pPr algn="ctr" latinLnBrk="0">
+              <a:lnSpc>
+                <a:spcPct val="100000"/>
+              </a:lnSpc>
+              <a:spcBef>
+                <a:spcPts val="0"/>
+              </a:spcBef>
+              <a:spcAft>
+                <a:spcPts val="0"/>
+              </a:spcAft>
+            </a:pPr>
+            <a:r>
+              <a:rPr sz="1100" b="1">
+                <a:solidFill>
+                  <a:srgbClr val="35424F"/>
+                </a:solidFill>
+                <a:latin typeface="Microsoft YaHei"/>
+                <a:ea typeface="Microsoft YaHei"/>
+                <a:cs typeface="Microsoft YaHei"/>
+              </a:rPr>
+              <a:t>耗时 −30%</a:t>
+            </a:r>
+          </a:p>
+        </p:txBody>
+      </p:sp>
+      <p:sp>
+        <p:nvSpPr>
+          <p:cNvPr id="8" name="TextBox 7"/>
+          <p:cNvSpPr txBox="1"/>
+          <p:nvPr/>
+        </p:nvSpPr>
+        <p:spPr>
+          <a:xfrm>
+            <a:off x="5239512" y="1810512"/>
+            <a:ext cx="1371600" cy="475488"/>
+          </a:xfrm>
+          <a:prstGeom prst="rect">
+            <a:avLst/>
+          </a:prstGeom>
+          <a:noFill/>
+        </p:spPr>
+        <p:txBody>
+          <a:bodyPr wrap="square" anchor="ctr" lIns="0" tIns="0" rIns="0" bIns="0">
+            <a:noAutofit/>
+          </a:bodyPr>
+          <a:lstStyle/>
+          <a:p>
+            <a:pPr algn="ctr" latinLnBrk="0">
+              <a:lnSpc>
+                <a:spcPct val="100000"/>
+              </a:lnSpc>
+              <a:spcBef>
+                <a:spcPts val="0"/>
+              </a:spcBef>
+              <a:spcAft>
+                <a:spcPts val="0"/>
+              </a:spcAft>
+            </a:pPr>
+            <a:r>
+              <a:rPr sz="1100" b="1">
+                <a:solidFill>
+                  <a:srgbClr val="35424F"/>
+                </a:solidFill>
+                <a:latin typeface="Microsoft YaHei"/>
+                <a:ea typeface="Microsoft YaHei"/>
+                <a:cs typeface="Microsoft YaHei"/>
+              </a:rPr>
               <a:t>GEMM</a:t>
             </a:r>
           </a:p>
@@ -14711,14 +14938,14 @@
       </p:sp>
       <p:sp>
         <p:nvSpPr>
-          <p:cNvPr id="8" name="Rectangle 7"/>
+          <p:cNvPr id="9" name="Rectangle 8"/>
           <p:cNvSpPr/>
           <p:nvPr/>
         </p:nvSpPr>
         <p:spPr>
           <a:xfrm>
             <a:off x="548640" y="2359152"/>
-            <a:ext cx="1874519" cy="1353312"/>
+            <a:ext cx="1783080" cy="1280160"/>
           </a:xfrm>
           <a:prstGeom prst="rect">
             <a:avLst/>
@@ -14780,7 +15007,7 @@
                 <a:ea typeface="Microsoft YaHei"/>
                 <a:cs typeface="Microsoft YaHei"/>
               </a:rPr>
-              <a:t>输入 1–4K · 8 req/s</a:t>
+              <a:t>输入 1–4K</a:t>
             </a:r>
           </a:p>
           <a:p>
@@ -14835,14 +15062,14 @@
       </p:sp>
       <p:sp>
         <p:nvSpPr>
-          <p:cNvPr id="9" name="Rectangle 8"/>
+          <p:cNvPr id="10" name="Rectangle 9"/>
           <p:cNvSpPr/>
           <p:nvPr/>
         </p:nvSpPr>
         <p:spPr>
           <a:xfrm>
-            <a:off x="2478024" y="2359152"/>
-            <a:ext cx="1298448" cy="1353312"/>
+            <a:off x="2386584" y="2359152"/>
+            <a:ext cx="1371600" cy="1280160"/>
           </a:xfrm>
           <a:prstGeom prst="rect">
             <a:avLst/>
@@ -14864,72 +15091,14 @@
       </p:sp>
       <p:sp>
         <p:nvSpPr>
-          <p:cNvPr id="10" name="TextBox 9"/>
-          <p:cNvSpPr txBox="1"/>
-          <p:nvPr/>
-        </p:nvSpPr>
-        <p:spPr>
-          <a:xfrm>
-            <a:off x="2478024" y="2560320"/>
-            <a:ext cx="1298448" cy="566928"/>
-          </a:xfrm>
-          <a:prstGeom prst="rect">
-            <a:avLst/>
-          </a:prstGeom>
-          <a:noFill/>
-        </p:spPr>
-        <p:txBody>
-          <a:bodyPr wrap="square" anchor="ctr" lIns="0" tIns="0" rIns="0" bIns="0">
-            <a:noAutofit/>
-          </a:bodyPr>
-          <a:lstStyle/>
-          <a:p>
-            <a:pPr algn="ctr" latinLnBrk="0">
-              <a:lnSpc>
-                <a:spcPct val="100000"/>
-              </a:lnSpc>
-              <a:spcBef>
-                <a:spcPts val="0"/>
-              </a:spcBef>
-              <a:spcAft>
-                <a:spcPts val="0"/>
-              </a:spcAft>
-            </a:pPr>
-            <a:r>
-              <a:rPr sz="2800" b="1">
-                <a:solidFill>
-                  <a:srgbClr val="16202A"/>
-                </a:solidFill>
-                <a:latin typeface="Arial"/>
-                <a:ea typeface="Microsoft YaHei"/>
-                <a:cs typeface="Microsoft YaHei"/>
-              </a:rPr>
-              <a:t>24</a:t>
-            </a:r>
-            <a:r>
-              <a:rPr sz="1200" b="1">
-                <a:solidFill>
-                  <a:srgbClr val="16202A"/>
-                </a:solidFill>
-                <a:latin typeface="Microsoft YaHei"/>
-                <a:ea typeface="Microsoft YaHei"/>
-                <a:cs typeface="Microsoft YaHei"/>
-              </a:rPr>
-              <a:t> 卡</a:t>
-            </a:r>
-          </a:p>
-        </p:txBody>
-      </p:sp>
-      <p:sp>
-        <p:nvSpPr>
           <p:cNvPr id="11" name="TextBox 10"/>
           <p:cNvSpPr txBox="1"/>
           <p:nvPr/>
         </p:nvSpPr>
         <p:spPr>
           <a:xfrm>
-            <a:off x="2532888" y="3145536"/>
-            <a:ext cx="1188719" cy="420624"/>
+            <a:off x="2386584" y="2523744"/>
+            <a:ext cx="1371600" cy="548640"/>
           </a:xfrm>
           <a:prstGeom prst="rect">
             <a:avLst/>
@@ -14937,6 +15106,64 @@
           <a:noFill/>
         </p:spPr>
         <p:txBody>
+          <a:bodyPr wrap="square" anchor="ctr" lIns="0" tIns="0" rIns="0" bIns="0">
+            <a:noAutofit/>
+          </a:bodyPr>
+          <a:lstStyle/>
+          <a:p>
+            <a:pPr algn="ctr" latinLnBrk="0">
+              <a:lnSpc>
+                <a:spcPct val="100000"/>
+              </a:lnSpc>
+              <a:spcBef>
+                <a:spcPts val="0"/>
+              </a:spcBef>
+              <a:spcAft>
+                <a:spcPts val="0"/>
+              </a:spcAft>
+            </a:pPr>
+            <a:r>
+              <a:rPr sz="2600" b="1">
+                <a:solidFill>
+                  <a:srgbClr val="16202A"/>
+                </a:solidFill>
+                <a:latin typeface="Arial"/>
+                <a:ea typeface="Microsoft YaHei"/>
+                <a:cs typeface="Microsoft YaHei"/>
+              </a:rPr>
+              <a:t>2.69</a:t>
+            </a:r>
+            <a:r>
+              <a:rPr sz="1100" b="1">
+                <a:solidFill>
+                  <a:srgbClr val="16202A"/>
+                </a:solidFill>
+                <a:latin typeface="Microsoft YaHei"/>
+                <a:ea typeface="Microsoft YaHei"/>
+                <a:cs typeface="Microsoft YaHei"/>
+              </a:rPr>
+              <a:t> req/s</a:t>
+            </a:r>
+          </a:p>
+        </p:txBody>
+      </p:sp>
+      <p:sp>
+        <p:nvSpPr>
+          <p:cNvPr id="12" name="TextBox 11"/>
+          <p:cNvSpPr txBox="1"/>
+          <p:nvPr/>
+        </p:nvSpPr>
+        <p:spPr>
+          <a:xfrm>
+            <a:off x="2432303" y="3108960"/>
+            <a:ext cx="1280160" cy="457200"/>
+          </a:xfrm>
+          <a:prstGeom prst="rect">
+            <a:avLst/>
+          </a:prstGeom>
+          <a:noFill/>
+        </p:spPr>
+        <p:txBody>
           <a:bodyPr wrap="square" anchor="t" lIns="0" tIns="0" rIns="0" bIns="0">
             <a:noAutofit/>
           </a:bodyPr>
@@ -14954,7 +15181,7 @@
               </a:spcAft>
             </a:pPr>
             <a:r>
-              <a:rPr sz="950" b="0">
+              <a:rPr sz="1000" b="0">
                 <a:solidFill>
                   <a:srgbClr val="35424F"/>
                 </a:solidFill>
@@ -14962,21 +15189,21 @@
                 <a:ea typeface="Microsoft YaHei"/>
                 <a:cs typeface="Microsoft YaHei"/>
               </a:rPr>
-              <a:t>3 × TP8</a:t>
-            </a:r>
-          </a:p>
-        </p:txBody>
-      </p:sp>
-      <p:sp>
-        <p:nvSpPr>
-          <p:cNvPr id="12" name="Rectangle 11"/>
+              <a:t>TTFT 先超标</a:t>
+            </a:r>
+          </a:p>
+        </p:txBody>
+      </p:sp>
+      <p:sp>
+        <p:nvSpPr>
+          <p:cNvPr id="13" name="Rectangle 12"/>
           <p:cNvSpPr/>
           <p:nvPr/>
         </p:nvSpPr>
         <p:spPr>
           <a:xfrm>
-            <a:off x="3831335" y="2359152"/>
-            <a:ext cx="1298448" cy="1353312"/>
+            <a:off x="3813048" y="2359152"/>
+            <a:ext cx="1371600" cy="1280160"/>
           </a:xfrm>
           <a:prstGeom prst="rect">
             <a:avLst/>
@@ -15000,72 +15227,14 @@
       </p:sp>
       <p:sp>
         <p:nvSpPr>
-          <p:cNvPr id="13" name="TextBox 12"/>
-          <p:cNvSpPr txBox="1"/>
-          <p:nvPr/>
-        </p:nvSpPr>
-        <p:spPr>
-          <a:xfrm>
-            <a:off x="3831335" y="2560320"/>
-            <a:ext cx="1298448" cy="566928"/>
-          </a:xfrm>
-          <a:prstGeom prst="rect">
-            <a:avLst/>
-          </a:prstGeom>
-          <a:noFill/>
-        </p:spPr>
-        <p:txBody>
-          <a:bodyPr wrap="square" anchor="ctr" lIns="0" tIns="0" rIns="0" bIns="0">
-            <a:noAutofit/>
-          </a:bodyPr>
-          <a:lstStyle/>
-          <a:p>
-            <a:pPr algn="ctr" latinLnBrk="0">
-              <a:lnSpc>
-                <a:spcPct val="100000"/>
-              </a:lnSpc>
-              <a:spcBef>
-                <a:spcPts val="0"/>
-              </a:spcBef>
-              <a:spcAft>
-                <a:spcPts val="0"/>
-              </a:spcAft>
-            </a:pPr>
-            <a:r>
-              <a:rPr sz="2800" b="1">
-                <a:solidFill>
-                  <a:srgbClr val="8C96A1"/>
-                </a:solidFill>
-                <a:latin typeface="Arial"/>
-                <a:ea typeface="Microsoft YaHei"/>
-                <a:cs typeface="Microsoft YaHei"/>
-              </a:rPr>
-              <a:t>24</a:t>
-            </a:r>
-            <a:r>
-              <a:rPr sz="1200" b="1">
-                <a:solidFill>
-                  <a:srgbClr val="8C96A1"/>
-                </a:solidFill>
-                <a:latin typeface="Microsoft YaHei"/>
-                <a:ea typeface="Microsoft YaHei"/>
-                <a:cs typeface="Microsoft YaHei"/>
-              </a:rPr>
-              <a:t> 卡</a:t>
-            </a:r>
-          </a:p>
-        </p:txBody>
-      </p:sp>
-      <p:sp>
-        <p:nvSpPr>
           <p:cNvPr id="14" name="TextBox 13"/>
           <p:cNvSpPr txBox="1"/>
           <p:nvPr/>
         </p:nvSpPr>
         <p:spPr>
           <a:xfrm>
-            <a:off x="3886199" y="3145536"/>
-            <a:ext cx="1188719" cy="420624"/>
+            <a:off x="3813048" y="2523744"/>
+            <a:ext cx="1371600" cy="548640"/>
           </a:xfrm>
           <a:prstGeom prst="rect">
             <a:avLst/>
@@ -15073,6 +15242,64 @@
           <a:noFill/>
         </p:spPr>
         <p:txBody>
+          <a:bodyPr wrap="square" anchor="ctr" lIns="0" tIns="0" rIns="0" bIns="0">
+            <a:noAutofit/>
+          </a:bodyPr>
+          <a:lstStyle/>
+          <a:p>
+            <a:pPr algn="ctr" latinLnBrk="0">
+              <a:lnSpc>
+                <a:spcPct val="100000"/>
+              </a:lnSpc>
+              <a:spcBef>
+                <a:spcPts val="0"/>
+              </a:spcBef>
+              <a:spcAft>
+                <a:spcPts val="0"/>
+              </a:spcAft>
+            </a:pPr>
+            <a:r>
+              <a:rPr sz="2600" b="1">
+                <a:solidFill>
+                  <a:srgbClr val="8C96A1"/>
+                </a:solidFill>
+                <a:latin typeface="Arial"/>
+                <a:ea typeface="Microsoft YaHei"/>
+                <a:cs typeface="Microsoft YaHei"/>
+              </a:rPr>
+              <a:t>+1.7%</a:t>
+            </a:r>
+            <a:r>
+              <a:rPr sz="1100" b="1">
+                <a:solidFill>
+                  <a:srgbClr val="8C96A1"/>
+                </a:solidFill>
+                <a:latin typeface="Microsoft YaHei"/>
+                <a:ea typeface="Microsoft YaHei"/>
+                <a:cs typeface="Microsoft YaHei"/>
+              </a:rPr>
+              <a:t/>
+            </a:r>
+          </a:p>
+        </p:txBody>
+      </p:sp>
+      <p:sp>
+        <p:nvSpPr>
+          <p:cNvPr id="15" name="TextBox 14"/>
+          <p:cNvSpPr txBox="1"/>
+          <p:nvPr/>
+        </p:nvSpPr>
+        <p:spPr>
+          <a:xfrm>
+            <a:off x="3858768" y="3108960"/>
+            <a:ext cx="1280160" cy="457200"/>
+          </a:xfrm>
+          <a:prstGeom prst="rect">
+            <a:avLst/>
+          </a:prstGeom>
+          <a:noFill/>
+        </p:spPr>
+        <p:txBody>
           <a:bodyPr wrap="square" anchor="t" lIns="0" tIns="0" rIns="0" bIns="0">
             <a:noAutofit/>
           </a:bodyPr>
@@ -15086,11 +15313,11 @@
                 <a:spcPts val="0"/>
               </a:spcBef>
               <a:spcAft>
-                <a:spcPts val="0"/>
-              </a:spcAft>
-            </a:pPr>
-            <a:r>
-              <a:rPr sz="950" b="0">
+                <a:spcPts val="100"/>
+              </a:spcAft>
+            </a:pPr>
+            <a:r>
+              <a:rPr sz="1000" b="0">
                 <a:solidFill>
                   <a:srgbClr val="66727F"/>
                 </a:solidFill>
@@ -15098,21 +15325,461 @@
                 <a:ea typeface="Microsoft YaHei"/>
                 <a:cs typeface="Microsoft YaHei"/>
               </a:rPr>
-              <a:t>不变（单实例承载 +2%）</a:t>
-            </a:r>
-          </a:p>
-        </p:txBody>
-      </p:sp>
-      <p:sp>
-        <p:nvSpPr>
-          <p:cNvPr id="15" name="Rectangle 14"/>
+              <a:t>2.74 req/s</a:t>
+            </a:r>
+          </a:p>
+          <a:p>
+            <a:pPr algn="ctr" latinLnBrk="0">
+              <a:lnSpc>
+                <a:spcPct val="100000"/>
+              </a:lnSpc>
+              <a:spcBef>
+                <a:spcPts val="0"/>
+              </a:spcBef>
+              <a:spcAft>
+                <a:spcPts val="0"/>
+              </a:spcAft>
+            </a:pPr>
+            <a:r>
+              <a:rPr sz="1000" b="0">
+                <a:solidFill>
+                  <a:srgbClr val="66727F"/>
+                </a:solidFill>
+                <a:latin typeface="Microsoft YaHei"/>
+                <a:ea typeface="Microsoft YaHei"/>
+                <a:cs typeface="Microsoft YaHei"/>
+              </a:rPr>
+              <a:t>仍是 TTFT 先超标</a:t>
+            </a:r>
+          </a:p>
+        </p:txBody>
+      </p:sp>
+      <p:sp>
+        <p:nvSpPr>
+          <p:cNvPr id="16" name="Rectangle 15"/>
           <p:cNvSpPr/>
           <p:nvPr/>
         </p:nvSpPr>
         <p:spPr>
           <a:xfrm>
-            <a:off x="5184648" y="2359152"/>
-            <a:ext cx="1298448" cy="1353312"/>
+            <a:off x="5239512" y="2359152"/>
+            <a:ext cx="1371600" cy="1280160"/>
+          </a:xfrm>
+          <a:prstGeom prst="rect">
+            <a:avLst/>
+          </a:prstGeom>
+          <a:solidFill>
+            <a:srgbClr val="E2F2EC"/>
+          </a:solidFill>
+          <a:ln>
+            <a:noFill/>
+          </a:ln>
+        </p:spPr>
+        <p:txBody>
+          <a:bodyPr rtlCol="0" anchor="ctr"/>
+          <a:lstStyle/>
+          <a:p>
+            <a:pPr algn="ctr"/>
+          </a:p>
+        </p:txBody>
+      </p:sp>
+      <p:sp>
+        <p:nvSpPr>
+          <p:cNvPr id="17" name="TextBox 16"/>
+          <p:cNvSpPr txBox="1"/>
+          <p:nvPr/>
+        </p:nvSpPr>
+        <p:spPr>
+          <a:xfrm>
+            <a:off x="5239512" y="2523744"/>
+            <a:ext cx="1371600" cy="548640"/>
+          </a:xfrm>
+          <a:prstGeom prst="rect">
+            <a:avLst/>
+          </a:prstGeom>
+          <a:noFill/>
+        </p:spPr>
+        <p:txBody>
+          <a:bodyPr wrap="square" anchor="ctr" lIns="0" tIns="0" rIns="0" bIns="0">
+            <a:noAutofit/>
+          </a:bodyPr>
+          <a:lstStyle/>
+          <a:p>
+            <a:pPr algn="ctr" latinLnBrk="0">
+              <a:lnSpc>
+                <a:spcPct val="100000"/>
+              </a:lnSpc>
+              <a:spcBef>
+                <a:spcPts val="0"/>
+              </a:spcBef>
+              <a:spcAft>
+                <a:spcPts val="0"/>
+              </a:spcAft>
+            </a:pPr>
+            <a:r>
+              <a:rPr sz="2600" b="1">
+                <a:solidFill>
+                  <a:srgbClr val="1E8A6E"/>
+                </a:solidFill>
+                <a:latin typeface="Arial"/>
+                <a:ea typeface="Microsoft YaHei"/>
+                <a:cs typeface="Microsoft YaHei"/>
+              </a:rPr>
+              <a:t>+40%</a:t>
+            </a:r>
+            <a:r>
+              <a:rPr sz="1100" b="1">
+                <a:solidFill>
+                  <a:srgbClr val="1E8A6E"/>
+                </a:solidFill>
+                <a:latin typeface="Microsoft YaHei"/>
+                <a:ea typeface="Microsoft YaHei"/>
+                <a:cs typeface="Microsoft YaHei"/>
+              </a:rPr>
+              <a:t/>
+            </a:r>
+          </a:p>
+        </p:txBody>
+      </p:sp>
+      <p:sp>
+        <p:nvSpPr>
+          <p:cNvPr id="18" name="TextBox 17"/>
+          <p:cNvSpPr txBox="1"/>
+          <p:nvPr/>
+        </p:nvSpPr>
+        <p:spPr>
+          <a:xfrm>
+            <a:off x="5285232" y="3108960"/>
+            <a:ext cx="1280160" cy="457200"/>
+          </a:xfrm>
+          <a:prstGeom prst="rect">
+            <a:avLst/>
+          </a:prstGeom>
+          <a:noFill/>
+        </p:spPr>
+        <p:txBody>
+          <a:bodyPr wrap="square" anchor="t" lIns="0" tIns="0" rIns="0" bIns="0">
+            <a:noAutofit/>
+          </a:bodyPr>
+          <a:lstStyle/>
+          <a:p>
+            <a:pPr algn="ctr" latinLnBrk="0">
+              <a:lnSpc>
+                <a:spcPct val="100000"/>
+              </a:lnSpc>
+              <a:spcBef>
+                <a:spcPts val="0"/>
+              </a:spcBef>
+              <a:spcAft>
+                <a:spcPts val="100"/>
+              </a:spcAft>
+            </a:pPr>
+            <a:r>
+              <a:rPr sz="1000" b="0">
+                <a:solidFill>
+                  <a:srgbClr val="35424F"/>
+                </a:solidFill>
+                <a:latin typeface="Microsoft YaHei"/>
+                <a:ea typeface="Microsoft YaHei"/>
+                <a:cs typeface="Microsoft YaHei"/>
+              </a:rPr>
+              <a:t>3.75 req/s</a:t>
+            </a:r>
+          </a:p>
+          <a:p>
+            <a:pPr algn="ctr" latinLnBrk="0">
+              <a:lnSpc>
+                <a:spcPct val="100000"/>
+              </a:lnSpc>
+              <a:spcBef>
+                <a:spcPts val="0"/>
+              </a:spcBef>
+              <a:spcAft>
+                <a:spcPts val="0"/>
+              </a:spcAft>
+            </a:pPr>
+            <a:r>
+              <a:rPr sz="1000" b="0">
+                <a:solidFill>
+                  <a:srgbClr val="35424F"/>
+                </a:solidFill>
+                <a:latin typeface="Microsoft YaHei"/>
+                <a:ea typeface="Microsoft YaHei"/>
+                <a:cs typeface="Microsoft YaHei"/>
+              </a:rPr>
+              <a:t>仍是 TTFT 先超标</a:t>
+            </a:r>
+          </a:p>
+        </p:txBody>
+      </p:sp>
+      <p:sp>
+        <p:nvSpPr>
+          <p:cNvPr id="19" name="Rectangle 18"/>
+          <p:cNvSpPr/>
+          <p:nvPr/>
+        </p:nvSpPr>
+        <p:spPr>
+          <a:xfrm>
+            <a:off x="548640" y="3730752"/>
+            <a:ext cx="1783080" cy="1280160"/>
+          </a:xfrm>
+          <a:prstGeom prst="rect">
+            <a:avLst/>
+          </a:prstGeom>
+          <a:solidFill>
+            <a:srgbClr val="EEF1F4"/>
+          </a:solidFill>
+          <a:ln>
+            <a:noFill/>
+          </a:ln>
+        </p:spPr>
+        <p:txBody>
+          <a:bodyPr rtlCol="0" anchor="ctr" wrap="square" lIns="146304" tIns="36576" rIns="73152" bIns="36576">
+            <a:noAutofit/>
+          </a:bodyPr>
+          <a:lstStyle/>
+          <a:p>
+            <a:pPr algn="l" latinLnBrk="0">
+              <a:lnSpc>
+                <a:spcPct val="100000"/>
+              </a:lnSpc>
+              <a:spcBef>
+                <a:spcPts val="0"/>
+              </a:spcBef>
+              <a:spcAft>
+                <a:spcPts val="500"/>
+              </a:spcAft>
+            </a:pPr>
+            <a:r>
+              <a:rPr sz="1400" b="1">
+                <a:solidFill>
+                  <a:srgbClr val="16202A"/>
+                </a:solidFill>
+                <a:latin typeface="Microsoft YaHei"/>
+                <a:ea typeface="Microsoft YaHei"/>
+                <a:cs typeface="Microsoft YaHei"/>
+              </a:rPr>
+              <a:t>长上下文 RAG</a:t>
+            </a:r>
+          </a:p>
+          <a:p>
+            <a:pPr algn="l" latinLnBrk="0">
+              <a:lnSpc>
+                <a:spcPct val="100000"/>
+              </a:lnSpc>
+              <a:spcBef>
+                <a:spcPts val="0"/>
+              </a:spcBef>
+              <a:spcAft>
+                <a:spcPts val="100"/>
+              </a:spcAft>
+            </a:pPr>
+            <a:r>
+              <a:rPr sz="1000" b="0">
+                <a:solidFill>
+                  <a:srgbClr val="66727F"/>
+                </a:solidFill>
+                <a:latin typeface="Microsoft YaHei"/>
+                <a:ea typeface="Microsoft YaHei"/>
+                <a:cs typeface="Microsoft YaHei"/>
+              </a:rPr>
+              <a:t>输入 25–32K</a:t>
+            </a:r>
+          </a:p>
+          <a:p>
+            <a:pPr algn="l" latinLnBrk="0">
+              <a:lnSpc>
+                <a:spcPct val="100000"/>
+              </a:lnSpc>
+              <a:spcBef>
+                <a:spcPts val="0"/>
+              </a:spcBef>
+              <a:spcAft>
+                <a:spcPts val="100"/>
+              </a:spcAft>
+            </a:pPr>
+            <a:r>
+              <a:rPr sz="1000" b="0">
+                <a:solidFill>
+                  <a:srgbClr val="66727F"/>
+                </a:solidFill>
+                <a:latin typeface="Microsoft YaHei"/>
+                <a:ea typeface="Microsoft YaHei"/>
+                <a:cs typeface="Microsoft YaHei"/>
+              </a:rPr>
+              <a:t>P90 TTFT ≤ 8 s</a:t>
+            </a:r>
+          </a:p>
+          <a:p>
+            <a:pPr algn="l" latinLnBrk="0">
+              <a:lnSpc>
+                <a:spcPct val="100000"/>
+              </a:lnSpc>
+              <a:spcBef>
+                <a:spcPts val="0"/>
+              </a:spcBef>
+              <a:spcAft>
+                <a:spcPts val="100"/>
+              </a:spcAft>
+            </a:pPr>
+            <a:r>
+              <a:rPr sz="1000" b="0">
+                <a:solidFill>
+                  <a:srgbClr val="66727F"/>
+                </a:solidFill>
+                <a:latin typeface="Microsoft YaHei"/>
+                <a:ea typeface="Microsoft YaHei"/>
+                <a:cs typeface="Microsoft YaHei"/>
+              </a:rPr>
+              <a:t>P90 TPOT ≤ 60 ms</a:t>
+            </a:r>
+          </a:p>
+        </p:txBody>
+      </p:sp>
+      <p:sp>
+        <p:nvSpPr>
+          <p:cNvPr id="20" name="Rectangle 19"/>
+          <p:cNvSpPr/>
+          <p:nvPr/>
+        </p:nvSpPr>
+        <p:spPr>
+          <a:xfrm>
+            <a:off x="2386584" y="3730752"/>
+            <a:ext cx="1371600" cy="1280160"/>
+          </a:xfrm>
+          <a:prstGeom prst="rect">
+            <a:avLst/>
+          </a:prstGeom>
+          <a:solidFill>
+            <a:srgbClr val="F6F7F9"/>
+          </a:solidFill>
+          <a:ln>
+            <a:noFill/>
+          </a:ln>
+        </p:spPr>
+        <p:txBody>
+          <a:bodyPr rtlCol="0" anchor="ctr"/>
+          <a:lstStyle/>
+          <a:p>
+            <a:pPr algn="ctr"/>
+          </a:p>
+        </p:txBody>
+      </p:sp>
+      <p:sp>
+        <p:nvSpPr>
+          <p:cNvPr id="21" name="TextBox 20"/>
+          <p:cNvSpPr txBox="1"/>
+          <p:nvPr/>
+        </p:nvSpPr>
+        <p:spPr>
+          <a:xfrm>
+            <a:off x="2386584" y="3895344"/>
+            <a:ext cx="1371600" cy="548640"/>
+          </a:xfrm>
+          <a:prstGeom prst="rect">
+            <a:avLst/>
+          </a:prstGeom>
+          <a:noFill/>
+        </p:spPr>
+        <p:txBody>
+          <a:bodyPr wrap="square" anchor="ctr" lIns="0" tIns="0" rIns="0" bIns="0">
+            <a:noAutofit/>
+          </a:bodyPr>
+          <a:lstStyle/>
+          <a:p>
+            <a:pPr algn="ctr" latinLnBrk="0">
+              <a:lnSpc>
+                <a:spcPct val="100000"/>
+              </a:lnSpc>
+              <a:spcBef>
+                <a:spcPts val="0"/>
+              </a:spcBef>
+              <a:spcAft>
+                <a:spcPts val="0"/>
+              </a:spcAft>
+            </a:pPr>
+            <a:r>
+              <a:rPr sz="2600" b="1">
+                <a:solidFill>
+                  <a:srgbClr val="16202A"/>
+                </a:solidFill>
+                <a:latin typeface="Arial"/>
+                <a:ea typeface="Microsoft YaHei"/>
+                <a:cs typeface="Microsoft YaHei"/>
+              </a:rPr>
+              <a:t>5.8</a:t>
+            </a:r>
+            <a:r>
+              <a:rPr sz="1100" b="1">
+                <a:solidFill>
+                  <a:srgbClr val="16202A"/>
+                </a:solidFill>
+                <a:latin typeface="Microsoft YaHei"/>
+                <a:ea typeface="Microsoft YaHei"/>
+                <a:cs typeface="Microsoft YaHei"/>
+              </a:rPr>
+              <a:t> req/min</a:t>
+            </a:r>
+          </a:p>
+        </p:txBody>
+      </p:sp>
+      <p:sp>
+        <p:nvSpPr>
+          <p:cNvPr id="22" name="TextBox 21"/>
+          <p:cNvSpPr txBox="1"/>
+          <p:nvPr/>
+        </p:nvSpPr>
+        <p:spPr>
+          <a:xfrm>
+            <a:off x="2432303" y="4480560"/>
+            <a:ext cx="1280160" cy="457200"/>
+          </a:xfrm>
+          <a:prstGeom prst="rect">
+            <a:avLst/>
+          </a:prstGeom>
+          <a:noFill/>
+        </p:spPr>
+        <p:txBody>
+          <a:bodyPr wrap="square" anchor="t" lIns="0" tIns="0" rIns="0" bIns="0">
+            <a:noAutofit/>
+          </a:bodyPr>
+          <a:lstStyle/>
+          <a:p>
+            <a:pPr algn="ctr" latinLnBrk="0">
+              <a:lnSpc>
+                <a:spcPct val="100000"/>
+              </a:lnSpc>
+              <a:spcBef>
+                <a:spcPts val="0"/>
+              </a:spcBef>
+              <a:spcAft>
+                <a:spcPts val="0"/>
+              </a:spcAft>
+            </a:pPr>
+            <a:r>
+              <a:rPr sz="1000" b="0">
+                <a:solidFill>
+                  <a:srgbClr val="35424F"/>
+                </a:solidFill>
+                <a:latin typeface="Microsoft YaHei"/>
+                <a:ea typeface="Microsoft YaHei"/>
+                <a:cs typeface="Microsoft YaHei"/>
+              </a:rPr>
+              <a:t>TTFT 先超标</a:t>
+            </a:r>
+          </a:p>
+        </p:txBody>
+      </p:sp>
+      <p:sp>
+        <p:nvSpPr>
+          <p:cNvPr id="23" name="Rectangle 22"/>
+          <p:cNvSpPr/>
+          <p:nvPr/>
+        </p:nvSpPr>
+        <p:spPr>
+          <a:xfrm>
+            <a:off x="3813048" y="3730752"/>
+            <a:ext cx="1371600" cy="1280160"/>
           </a:xfrm>
           <a:prstGeom prst="rect">
             <a:avLst/>
@@ -15136,14 +15803,14 @@
       </p:sp>
       <p:sp>
         <p:nvSpPr>
-          <p:cNvPr id="16" name="TextBox 15"/>
+          <p:cNvPr id="24" name="TextBox 23"/>
           <p:cNvSpPr txBox="1"/>
           <p:nvPr/>
         </p:nvSpPr>
         <p:spPr>
           <a:xfrm>
-            <a:off x="5184648" y="2560320"/>
-            <a:ext cx="1298448" cy="566928"/>
+            <a:off x="3813048" y="3895344"/>
+            <a:ext cx="1371600" cy="548640"/>
           </a:xfrm>
           <a:prstGeom prst="rect">
             <a:avLst/>
@@ -15168,7 +15835,7 @@
               </a:spcAft>
             </a:pPr>
             <a:r>
-              <a:rPr sz="2800" b="1">
+              <a:rPr sz="2600" b="1">
                 <a:solidFill>
                   <a:srgbClr val="1E8A6E"/>
                 </a:solidFill>
@@ -15176,10 +15843,10 @@
                 <a:ea typeface="Microsoft YaHei"/>
                 <a:cs typeface="Microsoft YaHei"/>
               </a:rPr>
-              <a:t>20</a:t>
-            </a:r>
-            <a:r>
-              <a:rPr sz="1200" b="1">
+              <a:t>+21%</a:t>
+            </a:r>
+            <a:r>
+              <a:rPr sz="1100" b="1">
                 <a:solidFill>
                   <a:srgbClr val="1E8A6E"/>
                 </a:solidFill>
@@ -15187,21 +15854,21 @@
                 <a:ea typeface="Microsoft YaHei"/>
                 <a:cs typeface="Microsoft YaHei"/>
               </a:rPr>
-              <a:t> 卡</a:t>
-            </a:r>
-          </a:p>
-        </p:txBody>
-      </p:sp>
-      <p:sp>
-        <p:nvSpPr>
-          <p:cNvPr id="17" name="TextBox 16"/>
+              <a:t/>
+            </a:r>
+          </a:p>
+        </p:txBody>
+      </p:sp>
+      <p:sp>
+        <p:nvSpPr>
+          <p:cNvPr id="25" name="TextBox 24"/>
           <p:cNvSpPr txBox="1"/>
           <p:nvPr/>
         </p:nvSpPr>
         <p:spPr>
           <a:xfrm>
-            <a:off x="5239512" y="3145536"/>
-            <a:ext cx="1188719" cy="420624"/>
+            <a:off x="3858768" y="4480560"/>
+            <a:ext cx="1280160" cy="457200"/>
           </a:xfrm>
           <a:prstGeom prst="rect">
             <a:avLst/>
@@ -15222,11 +15889,11 @@
                 <a:spcPts val="0"/>
               </a:spcBef>
               <a:spcAft>
-                <a:spcPts val="0"/>
-              </a:spcAft>
-            </a:pPr>
-            <a:r>
-              <a:rPr sz="950" b="0">
+                <a:spcPts val="100"/>
+              </a:spcAft>
+            </a:pPr>
+            <a:r>
+              <a:rPr sz="1000" b="0">
                 <a:solidFill>
                   <a:srgbClr val="35424F"/>
                 </a:solidFill>
@@ -15234,279 +15901,45 @@
                 <a:ea typeface="Microsoft YaHei"/>
                 <a:cs typeface="Microsoft YaHei"/>
               </a:rPr>
-              <a:t>−17% · 5 × TP4</a:t>
-            </a:r>
-          </a:p>
-        </p:txBody>
-      </p:sp>
-      <p:sp>
-        <p:nvSpPr>
-          <p:cNvPr id="18" name="Rectangle 17"/>
+              <a:t>7.0 req/min</a:t>
+            </a:r>
+          </a:p>
+          <a:p>
+            <a:pPr algn="ctr" latinLnBrk="0">
+              <a:lnSpc>
+                <a:spcPct val="100000"/>
+              </a:lnSpc>
+              <a:spcBef>
+                <a:spcPts val="0"/>
+              </a:spcBef>
+              <a:spcAft>
+                <a:spcPts val="0"/>
+              </a:spcAft>
+            </a:pPr>
+            <a:r>
+              <a:rPr sz="1000" b="1">
+                <a:solidFill>
+                  <a:srgbClr val="C0612C"/>
+                </a:solidFill>
+                <a:latin typeface="Microsoft YaHei"/>
+                <a:ea typeface="Microsoft YaHei"/>
+                <a:cs typeface="Microsoft YaHei"/>
+              </a:rPr>
+              <a:t>转为 TPOT 先超标</a:t>
+            </a:r>
+          </a:p>
+        </p:txBody>
+      </p:sp>
+      <p:sp>
+        <p:nvSpPr>
+          <p:cNvPr id="26" name="Rectangle 25"/>
           <p:cNvSpPr/>
           <p:nvPr/>
         </p:nvSpPr>
         <p:spPr>
           <a:xfrm>
-            <a:off x="548640" y="3803904"/>
-            <a:ext cx="1874519" cy="1353312"/>
-          </a:xfrm>
-          <a:prstGeom prst="rect">
-            <a:avLst/>
-          </a:prstGeom>
-          <a:solidFill>
-            <a:srgbClr val="EEF1F4"/>
-          </a:solidFill>
-          <a:ln>
-            <a:noFill/>
-          </a:ln>
-        </p:spPr>
-        <p:txBody>
-          <a:bodyPr rtlCol="0" anchor="ctr" wrap="square" lIns="146304" tIns="36576" rIns="73152" bIns="36576">
-            <a:noAutofit/>
-          </a:bodyPr>
-          <a:lstStyle/>
-          <a:p>
-            <a:pPr algn="l" latinLnBrk="0">
-              <a:lnSpc>
-                <a:spcPct val="100000"/>
-              </a:lnSpc>
-              <a:spcBef>
-                <a:spcPts val="0"/>
-              </a:spcBef>
-              <a:spcAft>
-                <a:spcPts val="500"/>
-              </a:spcAft>
-            </a:pPr>
-            <a:r>
-              <a:rPr sz="1400" b="1">
-                <a:solidFill>
-                  <a:srgbClr val="16202A"/>
-                </a:solidFill>
-                <a:latin typeface="Microsoft YaHei"/>
-                <a:ea typeface="Microsoft YaHei"/>
-                <a:cs typeface="Microsoft YaHei"/>
-              </a:rPr>
-              <a:t>长上下文 RAG</a:t>
-            </a:r>
-          </a:p>
-          <a:p>
-            <a:pPr algn="l" latinLnBrk="0">
-              <a:lnSpc>
-                <a:spcPct val="100000"/>
-              </a:lnSpc>
-              <a:spcBef>
-                <a:spcPts val="0"/>
-              </a:spcBef>
-              <a:spcAft>
-                <a:spcPts val="100"/>
-              </a:spcAft>
-            </a:pPr>
-            <a:r>
-              <a:rPr sz="1000" b="0">
-                <a:solidFill>
-                  <a:srgbClr val="66727F"/>
-                </a:solidFill>
-                <a:latin typeface="Microsoft YaHei"/>
-                <a:ea typeface="Microsoft YaHei"/>
-                <a:cs typeface="Microsoft YaHei"/>
-              </a:rPr>
-              <a:t>输入 25–32K · 0.5 req/s</a:t>
-            </a:r>
-          </a:p>
-          <a:p>
-            <a:pPr algn="l" latinLnBrk="0">
-              <a:lnSpc>
-                <a:spcPct val="100000"/>
-              </a:lnSpc>
-              <a:spcBef>
-                <a:spcPts val="0"/>
-              </a:spcBef>
-              <a:spcAft>
-                <a:spcPts val="100"/>
-              </a:spcAft>
-            </a:pPr>
-            <a:r>
-              <a:rPr sz="1000" b="0">
-                <a:solidFill>
-                  <a:srgbClr val="66727F"/>
-                </a:solidFill>
-                <a:latin typeface="Microsoft YaHei"/>
-                <a:ea typeface="Microsoft YaHei"/>
-                <a:cs typeface="Microsoft YaHei"/>
-              </a:rPr>
-              <a:t>P90 TTFT ≤ 8 s</a:t>
-            </a:r>
-          </a:p>
-          <a:p>
-            <a:pPr algn="l" latinLnBrk="0">
-              <a:lnSpc>
-                <a:spcPct val="100000"/>
-              </a:lnSpc>
-              <a:spcBef>
-                <a:spcPts val="0"/>
-              </a:spcBef>
-              <a:spcAft>
-                <a:spcPts val="100"/>
-              </a:spcAft>
-            </a:pPr>
-            <a:r>
-              <a:rPr sz="1000" b="0">
-                <a:solidFill>
-                  <a:srgbClr val="66727F"/>
-                </a:solidFill>
-                <a:latin typeface="Microsoft YaHei"/>
-                <a:ea typeface="Microsoft YaHei"/>
-                <a:cs typeface="Microsoft YaHei"/>
-              </a:rPr>
-              <a:t>P90 TPOT ≤ 60 ms</a:t>
-            </a:r>
-          </a:p>
-        </p:txBody>
-      </p:sp>
-      <p:sp>
-        <p:nvSpPr>
-          <p:cNvPr id="19" name="Rectangle 18"/>
-          <p:cNvSpPr/>
-          <p:nvPr/>
-        </p:nvSpPr>
-        <p:spPr>
-          <a:xfrm>
-            <a:off x="2478024" y="3803904"/>
-            <a:ext cx="1298448" cy="1353312"/>
-          </a:xfrm>
-          <a:prstGeom prst="rect">
-            <a:avLst/>
-          </a:prstGeom>
-          <a:solidFill>
-            <a:srgbClr val="F6F7F9"/>
-          </a:solidFill>
-          <a:ln>
-            <a:noFill/>
-          </a:ln>
-        </p:spPr>
-        <p:txBody>
-          <a:bodyPr rtlCol="0" anchor="ctr"/>
-          <a:lstStyle/>
-          <a:p>
-            <a:pPr algn="ctr"/>
-          </a:p>
-        </p:txBody>
-      </p:sp>
-      <p:sp>
-        <p:nvSpPr>
-          <p:cNvPr id="20" name="TextBox 19"/>
-          <p:cNvSpPr txBox="1"/>
-          <p:nvPr/>
-        </p:nvSpPr>
-        <p:spPr>
-          <a:xfrm>
-            <a:off x="2478024" y="4005072"/>
-            <a:ext cx="1298448" cy="566928"/>
-          </a:xfrm>
-          <a:prstGeom prst="rect">
-            <a:avLst/>
-          </a:prstGeom>
-          <a:noFill/>
-        </p:spPr>
-        <p:txBody>
-          <a:bodyPr wrap="square" anchor="ctr" lIns="0" tIns="0" rIns="0" bIns="0">
-            <a:noAutofit/>
-          </a:bodyPr>
-          <a:lstStyle/>
-          <a:p>
-            <a:pPr algn="ctr" latinLnBrk="0">
-              <a:lnSpc>
-                <a:spcPct val="100000"/>
-              </a:lnSpc>
-              <a:spcBef>
-                <a:spcPts val="0"/>
-              </a:spcBef>
-              <a:spcAft>
-                <a:spcPts val="0"/>
-              </a:spcAft>
-            </a:pPr>
-            <a:r>
-              <a:rPr sz="2800" b="1">
-                <a:solidFill>
-                  <a:srgbClr val="16202A"/>
-                </a:solidFill>
-                <a:latin typeface="Arial"/>
-                <a:ea typeface="Microsoft YaHei"/>
-                <a:cs typeface="Microsoft YaHei"/>
-              </a:rPr>
-              <a:t>48</a:t>
-            </a:r>
-            <a:r>
-              <a:rPr sz="1200" b="1">
-                <a:solidFill>
-                  <a:srgbClr val="16202A"/>
-                </a:solidFill>
-                <a:latin typeface="Microsoft YaHei"/>
-                <a:ea typeface="Microsoft YaHei"/>
-                <a:cs typeface="Microsoft YaHei"/>
-              </a:rPr>
-              <a:t> 卡</a:t>
-            </a:r>
-          </a:p>
-        </p:txBody>
-      </p:sp>
-      <p:sp>
-        <p:nvSpPr>
-          <p:cNvPr id="21" name="TextBox 20"/>
-          <p:cNvSpPr txBox="1"/>
-          <p:nvPr/>
-        </p:nvSpPr>
-        <p:spPr>
-          <a:xfrm>
-            <a:off x="2532888" y="4590288"/>
-            <a:ext cx="1188719" cy="420624"/>
-          </a:xfrm>
-          <a:prstGeom prst="rect">
-            <a:avLst/>
-          </a:prstGeom>
-          <a:noFill/>
-        </p:spPr>
-        <p:txBody>
-          <a:bodyPr wrap="square" anchor="t" lIns="0" tIns="0" rIns="0" bIns="0">
-            <a:noAutofit/>
-          </a:bodyPr>
-          <a:lstStyle/>
-          <a:p>
-            <a:pPr algn="ctr" latinLnBrk="0">
-              <a:lnSpc>
-                <a:spcPct val="100000"/>
-              </a:lnSpc>
-              <a:spcBef>
-                <a:spcPts val="0"/>
-              </a:spcBef>
-              <a:spcAft>
-                <a:spcPts val="0"/>
-              </a:spcAft>
-            </a:pPr>
-            <a:r>
-              <a:rPr sz="950" b="0">
-                <a:solidFill>
-                  <a:srgbClr val="35424F"/>
-                </a:solidFill>
-                <a:latin typeface="Microsoft YaHei"/>
-                <a:ea typeface="Microsoft YaHei"/>
-                <a:cs typeface="Microsoft YaHei"/>
-              </a:rPr>
-              <a:t>6 × TP8</a:t>
-            </a:r>
-          </a:p>
-        </p:txBody>
-      </p:sp>
-      <p:sp>
-        <p:nvSpPr>
-          <p:cNvPr id="22" name="Rectangle 21"/>
-          <p:cNvSpPr/>
-          <p:nvPr/>
-        </p:nvSpPr>
-        <p:spPr>
-          <a:xfrm>
-            <a:off x="3831335" y="3803904"/>
-            <a:ext cx="1298448" cy="1353312"/>
+            <a:off x="5239512" y="3730752"/>
+            <a:ext cx="1371600" cy="1280160"/>
           </a:xfrm>
           <a:prstGeom prst="rect">
             <a:avLst/>
@@ -15530,206 +15963,14 @@
       </p:sp>
       <p:sp>
         <p:nvSpPr>
-          <p:cNvPr id="23" name="TextBox 22"/>
-          <p:cNvSpPr txBox="1"/>
-          <p:nvPr/>
-        </p:nvSpPr>
-        <p:spPr>
-          <a:xfrm>
-            <a:off x="3831335" y="4005072"/>
-            <a:ext cx="1298448" cy="566928"/>
-          </a:xfrm>
-          <a:prstGeom prst="rect">
-            <a:avLst/>
-          </a:prstGeom>
-          <a:noFill/>
-        </p:spPr>
-        <p:txBody>
-          <a:bodyPr wrap="square" anchor="ctr" lIns="0" tIns="0" rIns="0" bIns="0">
-            <a:noAutofit/>
-          </a:bodyPr>
-          <a:lstStyle/>
-          <a:p>
-            <a:pPr algn="ctr" latinLnBrk="0">
-              <a:lnSpc>
-                <a:spcPct val="100000"/>
-              </a:lnSpc>
-              <a:spcBef>
-                <a:spcPts val="0"/>
-              </a:spcBef>
-              <a:spcAft>
-                <a:spcPts val="0"/>
-              </a:spcAft>
-            </a:pPr>
-            <a:r>
-              <a:rPr sz="2800" b="1">
-                <a:solidFill>
-                  <a:srgbClr val="1E8A6E"/>
-                </a:solidFill>
-                <a:latin typeface="Arial"/>
-                <a:ea typeface="Microsoft YaHei"/>
-                <a:cs typeface="Microsoft YaHei"/>
-              </a:rPr>
-              <a:t>40</a:t>
-            </a:r>
-            <a:r>
-              <a:rPr sz="1200" b="1">
-                <a:solidFill>
-                  <a:srgbClr val="1E8A6E"/>
-                </a:solidFill>
-                <a:latin typeface="Microsoft YaHei"/>
-                <a:ea typeface="Microsoft YaHei"/>
-                <a:cs typeface="Microsoft YaHei"/>
-              </a:rPr>
-              <a:t> 卡</a:t>
-            </a:r>
-          </a:p>
-        </p:txBody>
-      </p:sp>
-      <p:sp>
-        <p:nvSpPr>
-          <p:cNvPr id="24" name="TextBox 23"/>
-          <p:cNvSpPr txBox="1"/>
-          <p:nvPr/>
-        </p:nvSpPr>
-        <p:spPr>
-          <a:xfrm>
-            <a:off x="3886199" y="4590288"/>
-            <a:ext cx="1188719" cy="420624"/>
-          </a:xfrm>
-          <a:prstGeom prst="rect">
-            <a:avLst/>
-          </a:prstGeom>
-          <a:noFill/>
-        </p:spPr>
-        <p:txBody>
-          <a:bodyPr wrap="square" anchor="t" lIns="0" tIns="0" rIns="0" bIns="0">
-            <a:noAutofit/>
-          </a:bodyPr>
-          <a:lstStyle/>
-          <a:p>
-            <a:pPr algn="ctr" latinLnBrk="0">
-              <a:lnSpc>
-                <a:spcPct val="100000"/>
-              </a:lnSpc>
-              <a:spcBef>
-                <a:spcPts val="0"/>
-              </a:spcBef>
-              <a:spcAft>
-                <a:spcPts val="0"/>
-              </a:spcAft>
-            </a:pPr>
-            <a:r>
-              <a:rPr sz="950" b="0">
-                <a:solidFill>
-                  <a:srgbClr val="35424F"/>
-                </a:solidFill>
-                <a:latin typeface="Microsoft YaHei"/>
-                <a:ea typeface="Microsoft YaHei"/>
-                <a:cs typeface="Microsoft YaHei"/>
-              </a:rPr>
-              <a:t>−17% · 5 × TP8</a:t>
-            </a:r>
-          </a:p>
-        </p:txBody>
-      </p:sp>
-      <p:sp>
-        <p:nvSpPr>
-          <p:cNvPr id="25" name="Rectangle 24"/>
-          <p:cNvSpPr/>
-          <p:nvPr/>
-        </p:nvSpPr>
-        <p:spPr>
-          <a:xfrm>
-            <a:off x="5184648" y="3803904"/>
-            <a:ext cx="1298448" cy="1353312"/>
-          </a:xfrm>
-          <a:prstGeom prst="rect">
-            <a:avLst/>
-          </a:prstGeom>
-          <a:solidFill>
-            <a:srgbClr val="E2F2EC"/>
-          </a:solidFill>
-          <a:ln>
-            <a:noFill/>
-          </a:ln>
-        </p:spPr>
-        <p:txBody>
-          <a:bodyPr rtlCol="0" anchor="ctr"/>
-          <a:lstStyle/>
-          <a:p>
-            <a:pPr algn="ctr"/>
-          </a:p>
-        </p:txBody>
-      </p:sp>
-      <p:sp>
-        <p:nvSpPr>
-          <p:cNvPr id="26" name="TextBox 25"/>
-          <p:cNvSpPr txBox="1"/>
-          <p:nvPr/>
-        </p:nvSpPr>
-        <p:spPr>
-          <a:xfrm>
-            <a:off x="5184648" y="4005072"/>
-            <a:ext cx="1298448" cy="566928"/>
-          </a:xfrm>
-          <a:prstGeom prst="rect">
-            <a:avLst/>
-          </a:prstGeom>
-          <a:noFill/>
-        </p:spPr>
-        <p:txBody>
-          <a:bodyPr wrap="square" anchor="ctr" lIns="0" tIns="0" rIns="0" bIns="0">
-            <a:noAutofit/>
-          </a:bodyPr>
-          <a:lstStyle/>
-          <a:p>
-            <a:pPr algn="ctr" latinLnBrk="0">
-              <a:lnSpc>
-                <a:spcPct val="100000"/>
-              </a:lnSpc>
-              <a:spcBef>
-                <a:spcPts val="0"/>
-              </a:spcBef>
-              <a:spcAft>
-                <a:spcPts val="0"/>
-              </a:spcAft>
-            </a:pPr>
-            <a:r>
-              <a:rPr sz="2800" b="1">
-                <a:solidFill>
-                  <a:srgbClr val="1E8A6E"/>
-                </a:solidFill>
-                <a:latin typeface="Arial"/>
-                <a:ea typeface="Microsoft YaHei"/>
-                <a:cs typeface="Microsoft YaHei"/>
-              </a:rPr>
-              <a:t>32</a:t>
-            </a:r>
-            <a:r>
-              <a:rPr sz="1200" b="1">
-                <a:solidFill>
-                  <a:srgbClr val="1E8A6E"/>
-                </a:solidFill>
-                <a:latin typeface="Microsoft YaHei"/>
-                <a:ea typeface="Microsoft YaHei"/>
-                <a:cs typeface="Microsoft YaHei"/>
-              </a:rPr>
-              <a:t> 卡</a:t>
-            </a:r>
-          </a:p>
-        </p:txBody>
-      </p:sp>
-      <p:sp>
-        <p:nvSpPr>
           <p:cNvPr id="27" name="TextBox 26"/>
           <p:cNvSpPr txBox="1"/>
           <p:nvPr/>
         </p:nvSpPr>
         <p:spPr>
           <a:xfrm>
-            <a:off x="5239512" y="4590288"/>
-            <a:ext cx="1188719" cy="420624"/>
+            <a:off x="5239512" y="3895344"/>
+            <a:ext cx="1371600" cy="548640"/>
           </a:xfrm>
           <a:prstGeom prst="rect">
             <a:avLst/>
@@ -15737,7 +15978,7 @@
           <a:noFill/>
         </p:spPr>
         <p:txBody>
-          <a:bodyPr wrap="square" anchor="t" lIns="0" tIns="0" rIns="0" bIns="0">
+          <a:bodyPr wrap="square" anchor="ctr" lIns="0" tIns="0" rIns="0" bIns="0">
             <a:noAutofit/>
           </a:bodyPr>
           <a:lstStyle/>
@@ -15754,15 +15995,26 @@
               </a:spcAft>
             </a:pPr>
             <a:r>
-              <a:rPr sz="950" b="0">
-                <a:solidFill>
-                  <a:srgbClr val="35424F"/>
-                </a:solidFill>
-                <a:latin typeface="Microsoft YaHei"/>
-                <a:ea typeface="Microsoft YaHei"/>
-                <a:cs typeface="Microsoft YaHei"/>
-              </a:rPr>
-              <a:t>−33% · 4 × TP8</a:t>
+              <a:rPr sz="2600" b="1">
+                <a:solidFill>
+                  <a:srgbClr val="1E8A6E"/>
+                </a:solidFill>
+                <a:latin typeface="Arial"/>
+                <a:ea typeface="Microsoft YaHei"/>
+                <a:cs typeface="Microsoft YaHei"/>
+              </a:rPr>
+              <a:t>+31%</a:t>
+            </a:r>
+            <a:r>
+              <a:rPr sz="1100" b="1">
+                <a:solidFill>
+                  <a:srgbClr val="1E8A6E"/>
+                </a:solidFill>
+                <a:latin typeface="Microsoft YaHei"/>
+                <a:ea typeface="Microsoft YaHei"/>
+                <a:cs typeface="Microsoft YaHei"/>
+              </a:rPr>
+              <a:t/>
             </a:r>
           </a:p>
         </p:txBody>
@@ -15775,8 +16027,8 @@
         </p:nvSpPr>
         <p:spPr>
           <a:xfrm>
-            <a:off x="548640" y="5266944"/>
-            <a:ext cx="5934456" cy="274320"/>
+            <a:off x="5285232" y="4480560"/>
+            <a:ext cx="1280160" cy="457200"/>
           </a:xfrm>
           <a:prstGeom prst="rect">
             <a:avLst/>
@@ -15784,32 +16036,56 @@
           <a:noFill/>
         </p:spPr>
         <p:txBody>
-          <a:bodyPr wrap="square" anchor="ctr" lIns="0" tIns="0" rIns="0" bIns="0">
-            <a:noAutofit/>
-          </a:bodyPr>
-          <a:lstStyle/>
-          <a:p>
-            <a:pPr algn="l" latinLnBrk="0">
-              <a:lnSpc>
-                <a:spcPct val="100000"/>
-              </a:lnSpc>
-              <a:spcBef>
-                <a:spcPts val="0"/>
-              </a:spcBef>
-              <a:spcAft>
-                <a:spcPts val="0"/>
+          <a:bodyPr wrap="square" anchor="t" lIns="0" tIns="0" rIns="0" bIns="0">
+            <a:noAutofit/>
+          </a:bodyPr>
+          <a:lstStyle/>
+          <a:p>
+            <a:pPr algn="ctr" latinLnBrk="0">
+              <a:lnSpc>
+                <a:spcPct val="100000"/>
+              </a:lnSpc>
+              <a:spcBef>
+                <a:spcPts val="0"/>
+              </a:spcBef>
+              <a:spcAft>
+                <a:spcPts val="100"/>
               </a:spcAft>
             </a:pPr>
             <a:r>
               <a:rPr sz="1000" b="0">
                 <a:solidFill>
-                  <a:srgbClr val="66727F"/>
-                </a:solidFill>
-                <a:latin typeface="Microsoft YaHei"/>
-                <a:ea typeface="Microsoft YaHei"/>
-                <a:cs typeface="Microsoft YaHei"/>
-              </a:rPr>
-              <a:t>实例形态与副本数由规划器自动选择：6 个方案都带 EAGLE3（接受率按 0.7 假设），均不含 PD 分离</a:t>
+                  <a:srgbClr val="35424F"/>
+                </a:solidFill>
+                <a:latin typeface="Microsoft YaHei"/>
+                <a:ea typeface="Microsoft YaHei"/>
+                <a:cs typeface="Microsoft YaHei"/>
+              </a:rPr>
+              <a:t>7.6 req/min</a:t>
+            </a:r>
+          </a:p>
+          <a:p>
+            <a:pPr algn="ctr" latinLnBrk="0">
+              <a:lnSpc>
+                <a:spcPct val="100000"/>
+              </a:lnSpc>
+              <a:spcBef>
+                <a:spcPts val="0"/>
+              </a:spcBef>
+              <a:spcAft>
+                <a:spcPts val="0"/>
+              </a:spcAft>
+            </a:pPr>
+            <a:r>
+              <a:rPr sz="1000" b="1">
+                <a:solidFill>
+                  <a:srgbClr val="C0612C"/>
+                </a:solidFill>
+                <a:latin typeface="Microsoft YaHei"/>
+                <a:ea typeface="Microsoft YaHei"/>
+                <a:cs typeface="Microsoft YaHei"/>
+              </a:rPr>
+              <a:t>转为 TPOT 先超标</a:t>
             </a:r>
           </a:p>
         </p:txBody>
@@ -15822,6 +16098,77 @@
         </p:nvSpPr>
         <p:spPr>
           <a:xfrm>
+            <a:off x="548640" y="5084064"/>
+            <a:ext cx="6062472" cy="457200"/>
+          </a:xfrm>
+          <a:prstGeom prst="rect">
+            <a:avLst/>
+          </a:prstGeom>
+          <a:noFill/>
+        </p:spPr>
+        <p:txBody>
+          <a:bodyPr wrap="square" anchor="ctr" lIns="0" tIns="0" rIns="0" bIns="0">
+            <a:noAutofit/>
+          </a:bodyPr>
+          <a:lstStyle/>
+          <a:p>
+            <a:pPr algn="l" latinLnBrk="0">
+              <a:lnSpc>
+                <a:spcPct val="100000"/>
+              </a:lnSpc>
+              <a:spcBef>
+                <a:spcPts val="0"/>
+              </a:spcBef>
+              <a:spcAft>
+                <a:spcPts val="100"/>
+              </a:spcAft>
+            </a:pPr>
+            <a:r>
+              <a:rPr sz="1000" b="0">
+                <a:solidFill>
+                  <a:srgbClr val="66727F"/>
+                </a:solidFill>
+                <a:latin typeface="Microsoft YaHei"/>
+                <a:ea typeface="Microsoft YaHei"/>
+                <a:cs typeface="Microsoft YaHei"/>
+              </a:rPr>
+              <a:t>芯片参数暂用内置 H20 预设（公开规格 + 默认效率假设）；M100 规格写入 YAML 即可重跑</a:t>
+            </a:r>
+          </a:p>
+          <a:p>
+            <a:pPr algn="l" latinLnBrk="0">
+              <a:lnSpc>
+                <a:spcPct val="100000"/>
+              </a:lnSpc>
+              <a:spcBef>
+                <a:spcPts val="0"/>
+              </a:spcBef>
+              <a:spcAft>
+                <a:spcPts val="0"/>
+              </a:spcAft>
+            </a:pPr>
+            <a:r>
+              <a:rPr sz="1000" b="0">
+                <a:solidFill>
+                  <a:srgbClr val="66727F"/>
+                </a:solidFill>
+                <a:latin typeface="Microsoft YaHei"/>
+                <a:ea typeface="Microsoft YaHei"/>
+                <a:cs typeface="Microsoft YaHei"/>
+              </a:rPr>
+              <a:t>基线 = 单个 TP8 实例 + EAGLE3（接受率假设 0.7）；launch 固定，只改算子耗时</a:t>
+            </a:r>
+          </a:p>
+        </p:txBody>
+      </p:sp>
+      <p:sp>
+        <p:nvSpPr>
+          <p:cNvPr id="30" name="TextBox 29"/>
+          <p:cNvSpPr txBox="1"/>
+          <p:nvPr/>
+        </p:nvSpPr>
+        <p:spPr>
+          <a:xfrm>
             <a:off x="6858000" y="1810512"/>
             <a:ext cx="4785055" cy="365760"/>
           </a:xfrm>
@@ -15863,7 +16210,7 @@
       </p:sp>
       <p:sp>
         <p:nvSpPr>
-          <p:cNvPr id="30" name="Oval 29"/>
+          <p:cNvPr id="31" name="Oval 30"/>
           <p:cNvSpPr/>
           <p:nvPr/>
         </p:nvSpPr>
@@ -15915,7 +16262,7 @@
       </p:sp>
       <p:sp>
         <p:nvSpPr>
-          <p:cNvPr id="31" name="TextBox 30"/>
+          <p:cNvPr id="32" name="TextBox 31"/>
           <p:cNvSpPr txBox="1"/>
           <p:nvPr/>
         </p:nvSpPr>
@@ -15962,7 +16309,7 @@
       </p:sp>
       <p:sp>
         <p:nvSpPr>
-          <p:cNvPr id="32" name="TextBox 31"/>
+          <p:cNvPr id="33" name="TextBox 32"/>
           <p:cNvSpPr txBox="1"/>
           <p:nvPr/>
         </p:nvSpPr>
@@ -16002,14 +16349,14 @@
                 <a:ea typeface="Microsoft YaHei"/>
                 <a:cs typeface="Microsoft YaHei"/>
               </a:rPr>
-              <a:t>attention 在 prefill 中的占比：4K 输入约 7%，32K 输入约 38%</a:t>
-            </a:r>
-          </a:p>
-        </p:txBody>
-      </p:sp>
-      <p:sp>
-        <p:nvSpPr>
-          <p:cNvPr id="33" name="TextBox 32"/>
+              <a:t>prefill 里 attention 的占比：4K 输入约 7%，32K 约 38%</a:t>
+            </a:r>
+          </a:p>
+        </p:txBody>
+      </p:sp>
+      <p:sp>
+        <p:nvSpPr>
+          <p:cNvPr id="34" name="TextBox 33"/>
           <p:cNvSpPr txBox="1"/>
           <p:nvPr/>
         </p:nvSpPr>
@@ -16056,7 +16403,7 @@
       </p:sp>
       <p:sp>
         <p:nvSpPr>
-          <p:cNvPr id="34" name="Rectangle 33"/>
+          <p:cNvPr id="35" name="Rectangle 34"/>
           <p:cNvSpPr/>
           <p:nvPr/>
         </p:nvSpPr>
@@ -16108,7 +16455,7 @@
       </p:sp>
       <p:sp>
         <p:nvSpPr>
-          <p:cNvPr id="35" name="Rectangle 34"/>
+          <p:cNvPr id="36" name="Rectangle 35"/>
           <p:cNvSpPr/>
           <p:nvPr/>
         </p:nvSpPr>
@@ -16137,7 +16484,7 @@
       </p:sp>
       <p:sp>
         <p:nvSpPr>
-          <p:cNvPr id="36" name="Rectangle 35"/>
+          <p:cNvPr id="37" name="Rectangle 36"/>
           <p:cNvSpPr/>
           <p:nvPr/>
         </p:nvSpPr>
@@ -16166,7 +16513,7 @@
       </p:sp>
       <p:sp>
         <p:nvSpPr>
-          <p:cNvPr id="37" name="TextBox 36"/>
+          <p:cNvPr id="38" name="TextBox 37"/>
           <p:cNvSpPr txBox="1"/>
           <p:nvPr/>
         </p:nvSpPr>
@@ -16213,7 +16560,7 @@
       </p:sp>
       <p:sp>
         <p:nvSpPr>
-          <p:cNvPr id="38" name="Rectangle 37"/>
+          <p:cNvPr id="39" name="Rectangle 38"/>
           <p:cNvSpPr/>
           <p:nvPr/>
         </p:nvSpPr>
@@ -16265,7 +16612,7 @@
       </p:sp>
       <p:sp>
         <p:nvSpPr>
-          <p:cNvPr id="39" name="Rectangle 38"/>
+          <p:cNvPr id="40" name="Rectangle 39"/>
           <p:cNvSpPr/>
           <p:nvPr/>
         </p:nvSpPr>
@@ -16317,7 +16664,7 @@
       </p:sp>
       <p:sp>
         <p:nvSpPr>
-          <p:cNvPr id="40" name="Rectangle 39"/>
+          <p:cNvPr id="41" name="Rectangle 40"/>
           <p:cNvSpPr/>
           <p:nvPr/>
         </p:nvSpPr>
@@ -16346,7 +16693,7 @@
       </p:sp>
       <p:sp>
         <p:nvSpPr>
-          <p:cNvPr id="41" name="Rectangle 40"/>
+          <p:cNvPr id="42" name="Rectangle 41"/>
           <p:cNvSpPr/>
           <p:nvPr/>
         </p:nvSpPr>
@@ -16375,7 +16722,7 @@
       </p:sp>
       <p:sp>
         <p:nvSpPr>
-          <p:cNvPr id="42" name="TextBox 41"/>
+          <p:cNvPr id="43" name="TextBox 42"/>
           <p:cNvSpPr txBox="1"/>
           <p:nvPr/>
         </p:nvSpPr>
@@ -16422,7 +16769,7 @@
       </p:sp>
       <p:sp>
         <p:nvSpPr>
-          <p:cNvPr id="43" name="Rectangle 42"/>
+          <p:cNvPr id="44" name="Rectangle 43"/>
           <p:cNvSpPr/>
           <p:nvPr/>
         </p:nvSpPr>
@@ -16451,7 +16798,7 @@
       </p:sp>
       <p:sp>
         <p:nvSpPr>
-          <p:cNvPr id="44" name="TextBox 43"/>
+          <p:cNvPr id="45" name="TextBox 44"/>
           <p:cNvSpPr txBox="1"/>
           <p:nvPr/>
         </p:nvSpPr>
@@ -16498,7 +16845,7 @@
       </p:sp>
       <p:sp>
         <p:nvSpPr>
-          <p:cNvPr id="45" name="Rectangle 44"/>
+          <p:cNvPr id="46" name="Rectangle 45"/>
           <p:cNvSpPr/>
           <p:nvPr/>
         </p:nvSpPr>
@@ -16527,7 +16874,7 @@
       </p:sp>
       <p:sp>
         <p:nvSpPr>
-          <p:cNvPr id="46" name="TextBox 45"/>
+          <p:cNvPr id="47" name="TextBox 46"/>
           <p:cNvSpPr txBox="1"/>
           <p:nvPr/>
         </p:nvSpPr>
@@ -16574,7 +16921,7 @@
       </p:sp>
       <p:sp>
         <p:nvSpPr>
-          <p:cNvPr id="47" name="TextBox 46"/>
+          <p:cNvPr id="48" name="TextBox 47"/>
           <p:cNvSpPr txBox="1"/>
           <p:nvPr/>
         </p:nvSpPr>
@@ -16621,13 +16968,13 @@
       </p:sp>
       <p:sp>
         <p:nvSpPr>
-          <p:cNvPr id="48" name="Oval 47"/>
+          <p:cNvPr id="49" name="Oval 48"/>
           <p:cNvSpPr/>
           <p:nvPr/>
         </p:nvSpPr>
         <p:spPr>
           <a:xfrm>
-            <a:off x="6858000" y="3785615"/>
+            <a:off x="6858000" y="3730752"/>
             <a:ext cx="292608" cy="292608"/>
           </a:xfrm>
           <a:prstGeom prst="ellipse">
@@ -16673,60 +17020,60 @@
       </p:sp>
       <p:sp>
         <p:nvSpPr>
-          <p:cNvPr id="49" name="TextBox 48"/>
-          <p:cNvSpPr txBox="1"/>
-          <p:nvPr/>
-        </p:nvSpPr>
-        <p:spPr>
-          <a:xfrm>
-            <a:off x="7269480" y="3758183"/>
-            <a:ext cx="4373575" cy="329184"/>
-          </a:xfrm>
-          <a:prstGeom prst="rect">
-            <a:avLst/>
-          </a:prstGeom>
-          <a:noFill/>
-        </p:spPr>
-        <p:txBody>
-          <a:bodyPr wrap="square" anchor="ctr" lIns="0" tIns="0" rIns="0" bIns="0">
-            <a:noAutofit/>
-          </a:bodyPr>
-          <a:lstStyle/>
-          <a:p>
-            <a:pPr algn="l" latinLnBrk="0">
-              <a:lnSpc>
-                <a:spcPct val="100000"/>
-              </a:lnSpc>
-              <a:spcBef>
-                <a:spcPts val="0"/>
-              </a:spcBef>
-              <a:spcAft>
-                <a:spcPts val="0"/>
-              </a:spcAft>
-            </a:pPr>
-            <a:r>
-              <a:rPr sz="1250" b="1">
-                <a:solidFill>
-                  <a:srgbClr val="16202A"/>
-                </a:solidFill>
-                <a:latin typeface="Microsoft YaHei"/>
-                <a:ea typeface="Microsoft YaHei"/>
-                <a:cs typeface="Microsoft YaHei"/>
-              </a:rPr>
-              <a:t>瓶颈指标决定哪段有用</a:t>
-            </a:r>
-          </a:p>
-        </p:txBody>
-      </p:sp>
-      <p:sp>
-        <p:nvSpPr>
           <p:cNvPr id="50" name="TextBox 49"/>
           <p:cNvSpPr txBox="1"/>
           <p:nvPr/>
         </p:nvSpPr>
         <p:spPr>
           <a:xfrm>
-            <a:off x="7269480" y="4096511"/>
+            <a:off x="7269480" y="3703320"/>
+            <a:ext cx="4373575" cy="329184"/>
+          </a:xfrm>
+          <a:prstGeom prst="rect">
+            <a:avLst/>
+          </a:prstGeom>
+          <a:noFill/>
+        </p:spPr>
+        <p:txBody>
+          <a:bodyPr wrap="square" anchor="ctr" lIns="0" tIns="0" rIns="0" bIns="0">
+            <a:noAutofit/>
+          </a:bodyPr>
+          <a:lstStyle/>
+          <a:p>
+            <a:pPr algn="l" latinLnBrk="0">
+              <a:lnSpc>
+                <a:spcPct val="100000"/>
+              </a:lnSpc>
+              <a:spcBef>
+                <a:spcPts val="0"/>
+              </a:spcBef>
+              <a:spcAft>
+                <a:spcPts val="0"/>
+              </a:spcAft>
+            </a:pPr>
+            <a:r>
+              <a:rPr sz="1250" b="1">
+                <a:solidFill>
+                  <a:srgbClr val="16202A"/>
+                </a:solidFill>
+                <a:latin typeface="Microsoft YaHei"/>
+                <a:ea typeface="Microsoft YaHei"/>
+                <a:cs typeface="Microsoft YaHei"/>
+              </a:rPr>
+              <a:t>先超标的指标决定哪段有用</a:t>
+            </a:r>
+          </a:p>
+        </p:txBody>
+      </p:sp>
+      <p:sp>
+        <p:nvSpPr>
+          <p:cNvPr id="51" name="TextBox 50"/>
+          <p:cNvSpPr txBox="1"/>
+          <p:nvPr/>
+        </p:nvSpPr>
+        <p:spPr>
+          <a:xfrm>
+            <a:off x="7269480" y="4041648"/>
             <a:ext cx="4373575" cy="640080"/>
           </a:xfrm>
           <a:prstGeom prst="rect">
@@ -16760,20 +17107,20 @@
                 <a:ea typeface="Microsoft YaHei"/>
                 <a:cs typeface="Microsoft YaHei"/>
               </a:rPr>
-              <a:t>基线两类负载都先卡 TTFT：prefill 受算力限制，chat 的 prefill 约八成时间在 GEMM；RAG 提速后，瓶颈转到 TPOT</a:t>
-            </a:r>
-          </a:p>
-        </p:txBody>
-      </p:sp>
-      <p:sp>
-        <p:nvSpPr>
-          <p:cNvPr id="51" name="Oval 50"/>
+              <a:t>chat 先超标的是 TTFT，prefill 约八成时间在 GEMM：GEMM 快 30%，容量 +40%（TTFT 含排队，提速被放大）；attention 只占约 7%，仅 +1.7%</a:t>
+            </a:r>
+          </a:p>
+        </p:txBody>
+      </p:sp>
+      <p:sp>
+        <p:nvSpPr>
+          <p:cNvPr id="52" name="Oval 51"/>
           <p:cNvSpPr/>
           <p:nvPr/>
         </p:nvSpPr>
         <p:spPr>
           <a:xfrm>
-            <a:off x="6858000" y="4681728"/>
+            <a:off x="6858000" y="4700016"/>
             <a:ext cx="292608" cy="292608"/>
           </a:xfrm>
           <a:prstGeom prst="ellipse">
@@ -16819,61 +17166,14 @@
       </p:sp>
       <p:sp>
         <p:nvSpPr>
-          <p:cNvPr id="52" name="TextBox 51"/>
-          <p:cNvSpPr txBox="1"/>
-          <p:nvPr/>
-        </p:nvSpPr>
-        <p:spPr>
-          <a:xfrm>
-            <a:off x="7269480" y="4654296"/>
-            <a:ext cx="4373575" cy="329184"/>
-          </a:xfrm>
-          <a:prstGeom prst="rect">
-            <a:avLst/>
-          </a:prstGeom>
-          <a:noFill/>
-        </p:spPr>
-        <p:txBody>
-          <a:bodyPr wrap="square" anchor="ctr" lIns="0" tIns="0" rIns="0" bIns="0">
-            <a:noAutofit/>
-          </a:bodyPr>
-          <a:lstStyle/>
-          <a:p>
-            <a:pPr algn="l" latinLnBrk="0">
-              <a:lnSpc>
-                <a:spcPct val="100000"/>
-              </a:lnSpc>
-              <a:spcBef>
-                <a:spcPts val="0"/>
-              </a:spcBef>
-              <a:spcAft>
-                <a:spcPts val="0"/>
-              </a:spcAft>
-            </a:pPr>
-            <a:r>
-              <a:rPr sz="1250" b="1">
-                <a:solidFill>
-                  <a:srgbClr val="16202A"/>
-                </a:solidFill>
-                <a:latin typeface="Microsoft YaHei"/>
-                <a:ea typeface="Microsoft YaHei"/>
-                <a:cs typeface="Microsoft YaHei"/>
-              </a:rPr>
-              <a:t>卡数是离散的，最优形态会变</a:t>
-            </a:r>
-          </a:p>
-        </p:txBody>
-      </p:sp>
-      <p:sp>
-        <p:nvSpPr>
           <p:cNvPr id="53" name="TextBox 52"/>
           <p:cNvSpPr txBox="1"/>
           <p:nvPr/>
         </p:nvSpPr>
         <p:spPr>
           <a:xfrm>
-            <a:off x="7269480" y="4992624"/>
-            <a:ext cx="4373575" cy="640080"/>
+            <a:off x="7269480" y="4672583"/>
+            <a:ext cx="4373575" cy="329184"/>
           </a:xfrm>
           <a:prstGeom prst="rect">
             <a:avLst/>
@@ -16881,6 +17181,53 @@
           <a:noFill/>
         </p:spPr>
         <p:txBody>
+          <a:bodyPr wrap="square" anchor="ctr" lIns="0" tIns="0" rIns="0" bIns="0">
+            <a:noAutofit/>
+          </a:bodyPr>
+          <a:lstStyle/>
+          <a:p>
+            <a:pPr algn="l" latinLnBrk="0">
+              <a:lnSpc>
+                <a:spcPct val="100000"/>
+              </a:lnSpc>
+              <a:spcBef>
+                <a:spcPts val="0"/>
+              </a:spcBef>
+              <a:spcAft>
+                <a:spcPts val="0"/>
+              </a:spcAft>
+            </a:pPr>
+            <a:r>
+              <a:rPr sz="1250" b="1">
+                <a:solidFill>
+                  <a:srgbClr val="16202A"/>
+                </a:solidFill>
+                <a:latin typeface="Microsoft YaHei"/>
+                <a:ea typeface="Microsoft YaHei"/>
+                <a:cs typeface="Microsoft YaHei"/>
+              </a:rPr>
+              <a:t>瓶颈会转移</a:t>
+            </a:r>
+          </a:p>
+        </p:txBody>
+      </p:sp>
+      <p:sp>
+        <p:nvSpPr>
+          <p:cNvPr id="54" name="TextBox 53"/>
+          <p:cNvSpPr txBox="1"/>
+          <p:nvPr/>
+        </p:nvSpPr>
+        <p:spPr>
+          <a:xfrm>
+            <a:off x="7269480" y="5010912"/>
+            <a:ext cx="4373575" cy="502920"/>
+          </a:xfrm>
+          <a:prstGeom prst="rect">
+            <a:avLst/>
+          </a:prstGeom>
+          <a:noFill/>
+        </p:spPr>
+        <p:txBody>
           <a:bodyPr wrap="square" anchor="t" lIns="0" tIns="0" rIns="0" bIns="0">
             <a:noAutofit/>
           </a:bodyPr>
@@ -16906,14 +17253,14 @@
                 <a:ea typeface="Microsoft YaHei"/>
                 <a:cs typeface="Microsoft YaHei"/>
               </a:rPr>
-              <a:t>承载 +2% 不够省掉一个副本（8 req/s 仍要 3 个实例）；GEMM 变快后，最优实例从 TP8 变成 TP4</a:t>
-            </a:r>
-          </a:p>
-        </p:txBody>
-      </p:sp>
-      <p:sp>
-        <p:nvSpPr>
-          <p:cNvPr id="54" name="Rectangle 53"/>
+              <a:t>RAG 两种提速后，先超标的都从 TTFT 变成 TPOT：下一轮先优化谁，要按新瓶颈重新排</a:t>
+            </a:r>
+          </a:p>
+        </p:txBody>
+      </p:sp>
+      <p:sp>
+        <p:nvSpPr>
+          <p:cNvPr id="55" name="Rectangle 54"/>
           <p:cNvSpPr/>
           <p:nvPr/>
         </p:nvSpPr>
@@ -16942,7 +17289,7 @@
       </p:sp>
       <p:sp>
         <p:nvSpPr>
-          <p:cNvPr id="55" name="TextBox 54"/>
+          <p:cNvPr id="56" name="TextBox 55"/>
           <p:cNvSpPr txBox="1"/>
           <p:nvPr/>
         </p:nvSpPr>
@@ -17011,7 +17358,7 @@
       </p:sp>
       <p:sp>
         <p:nvSpPr>
-          <p:cNvPr id="56" name="TextBox 55"/>
+          <p:cNvPr id="57" name="TextBox 56"/>
           <p:cNvSpPr txBox="1"/>
           <p:nvPr/>
         </p:nvSpPr>
@@ -17058,7 +17405,7 @@
       </p:sp>
       <p:sp>
         <p:nvSpPr>
-          <p:cNvPr id="57" name="TextBox 56"/>
+          <p:cNvPr id="58" name="TextBox 57"/>
           <p:cNvSpPr txBox="1"/>
           <p:nvPr/>
         </p:nvSpPr>
@@ -17098,7 +17445,7 @@
                 <a:ea typeface="Microsoft YaHei"/>
                 <a:cs typeface="Microsoft YaHei"/>
               </a:rPr>
-              <a:t>复现：deploy --model qwen3-32b --hardware h20 --workload chat / rag-long-context --no-pd；算子耗时 ×0.7 由脚本注入成本模型</a:t>
+              <a:t>复现：deploy --model qwen3-32b --hardware h20 --sizes 8 --no-pd 取基线 launch；launch 固定，用脚本把算子耗时 ×0.7 后重测单机容量</a:t>
             </a:r>
           </a:p>
         </p:txBody>
@@ -17210,7 +17557,7 @@
                 <a:ea typeface="Microsoft YaHei"/>
                 <a:cs typeface="Microsoft YaHei"/>
               </a:rPr>
-              <a:t>解法：一条从 kernel 算到卡数的换算链，实测校准后再做决策</a:t>
+              <a:t>解法：一条从 kernel 算到单机容量的换算链，实测校准后再做决策</a:t>
             </a:r>
           </a:p>
         </p:txBody>
@@ -17257,7 +17604,7 @@
                 <a:ea typeface="Microsoft YaHei"/>
                 <a:cs typeface="Microsoft YaHei"/>
               </a:rPr>
-              <a:t>五层共用同一套模型和参数：算子、特性、布局任何一处变化，都能一路传到 SLO 和卡数</a:t>
+              <a:t>五层共用同一套模型和参数：算子、特性、布局任何一处变化，都能一路传到 SLO 和单机容量</a:t>
             </a:r>
           </a:p>
         </p:txBody>
@@ -17449,7 +17796,7 @@
                 <a:ea typeface="Microsoft YaHei"/>
                 <a:cs typeface="Microsoft YaHei"/>
               </a:rPr>
-              <a:t>L1 KERNEL</a:t>
+              <a:t>KERNEL</a:t>
             </a:r>
           </a:p>
           <a:p>
@@ -17497,7 +17844,7 @@
                 <a:ea typeface="Microsoft YaHei"/>
                 <a:cs typeface="Microsoft YaHei"/>
               </a:rPr>
-              <a:t>roofline：max(算力, 访存)</a:t>
+              <a:t>roofline：</a:t>
             </a:r>
           </a:p>
           <a:p>
@@ -17521,6 +17868,30 @@
                 <a:ea typeface="Microsoft YaHei"/>
                 <a:cs typeface="Microsoft YaHei"/>
               </a:rPr>
+              <a:t>max(算力, 访存)</a:t>
+            </a:r>
+          </a:p>
+          <a:p>
+            <a:pPr algn="l" latinLnBrk="0">
+              <a:lnSpc>
+                <a:spcPct val="100000"/>
+              </a:lnSpc>
+              <a:spcBef>
+                <a:spcPts val="0"/>
+              </a:spcBef>
+              <a:spcAft>
+                <a:spcPts val="250"/>
+              </a:spcAft>
+            </a:pPr>
+            <a:r>
+              <a:rPr sz="1050" b="0">
+                <a:solidFill>
+                  <a:srgbClr val="35424F"/>
+                </a:solidFill>
+                <a:latin typeface="Microsoft YaHei"/>
+                <a:ea typeface="Microsoft YaHei"/>
+                <a:cs typeface="Microsoft YaHei"/>
+              </a:rPr>
               <a:t>+ launch / 图间隙</a:t>
             </a:r>
           </a:p>
@@ -17569,7 +17940,7 @@
                 <a:ea typeface="Microsoft YaHei"/>
                 <a:cs typeface="Microsoft YaHei"/>
               </a:rPr>
-              <a:t>效率系数来自芯片 YAML</a:t>
+              <a:t>效率系数取自芯片 YAML</a:t>
             </a:r>
           </a:p>
         </p:txBody>
@@ -17645,7 +18016,7 @@
                 <a:ea typeface="Microsoft YaHei"/>
                 <a:cs typeface="Microsoft YaHei"/>
               </a:rPr>
-              <a:t>L2 STEP</a:t>
+              <a:t>STEP</a:t>
             </a:r>
           </a:p>
           <a:p>
@@ -17887,7 +18258,7 @@
                 <a:ea typeface="Microsoft YaHei"/>
                 <a:cs typeface="Microsoft YaHei"/>
               </a:rPr>
-              <a:t>L3 SCHEDULE</a:t>
+              <a:t>SCHEDULE</a:t>
             </a:r>
           </a:p>
           <a:p>
@@ -18129,7 +18500,7 @@
                 <a:ea typeface="Microsoft YaHei"/>
                 <a:cs typeface="Microsoft YaHei"/>
               </a:rPr>
-              <a:t>L4 SLO</a:t>
+              <a:t>SLO</a:t>
             </a:r>
           </a:p>
           <a:p>
@@ -18153,7 +18524,7 @@
                 <a:ea typeface="Microsoft YaHei"/>
                 <a:cs typeface="Microsoft YaHei"/>
               </a:rPr>
-              <a:t>SLO 达成</a:t>
+              <a:t>SLO 判定</a:t>
             </a:r>
           </a:p>
           <a:p>
@@ -18177,7 +18548,7 @@
                 <a:ea typeface="Microsoft YaHei"/>
                 <a:cs typeface="Microsoft YaHei"/>
               </a:rPr>
-              <a:t>判 P90 TTFT / TPOT</a:t>
+              <a:t>按 P90 判 TTFT / TPOT</a:t>
             </a:r>
           </a:p>
           <a:p>
@@ -18201,31 +18572,7 @@
                 <a:ea typeface="Microsoft YaHei"/>
                 <a:cs typeface="Microsoft YaHei"/>
               </a:rPr>
-              <a:t>求单实例容量：</a:t>
-            </a:r>
-          </a:p>
-          <a:p>
-            <a:pPr algn="l" latinLnBrk="0">
-              <a:lnSpc>
-                <a:spcPct val="100000"/>
-              </a:lnSpc>
-              <a:spcBef>
-                <a:spcPts val="0"/>
-              </a:spcBef>
-              <a:spcAft>
-                <a:spcPts val="250"/>
-              </a:spcAft>
-            </a:pPr>
-            <a:r>
-              <a:rPr sz="1050" b="0">
-                <a:solidFill>
-                  <a:srgbClr val="35424F"/>
-                </a:solidFill>
-                <a:latin typeface="Microsoft YaHei"/>
-                <a:ea typeface="Microsoft YaHei"/>
-                <a:cs typeface="Microsoft YaHei"/>
-              </a:rPr>
-              <a:t>SLO 内最大到达率</a:t>
+              <a:t>统计 SLO 达成率</a:t>
             </a:r>
           </a:p>
           <a:p>
@@ -18347,7 +18694,7 @@
                 <a:ea typeface="Microsoft YaHei"/>
                 <a:cs typeface="Microsoft YaHei"/>
               </a:rPr>
-              <a:t>L5 CLUSTER</a:t>
+              <a:t>CAPACITY</a:t>
             </a:r>
           </a:p>
           <a:p>
@@ -18371,7 +18718,7 @@
                 <a:ea typeface="Microsoft YaHei"/>
                 <a:cs typeface="Microsoft YaHei"/>
               </a:rPr>
-              <a:t>卡数</a:t>
+              <a:t>单机容量</a:t>
             </a:r>
           </a:p>
           <a:p>
@@ -18395,7 +18742,7 @@
                 <a:ea typeface="Microsoft YaHei"/>
                 <a:cs typeface="Microsoft YaHei"/>
               </a:rPr>
-              <a:t>副本数 + router</a:t>
+              <a:t>二分搜索 SLO 内</a:t>
             </a:r>
           </a:p>
           <a:p>
@@ -18419,7 +18766,7 @@
                 <a:ea typeface="Microsoft YaHei"/>
                 <a:cs typeface="Microsoft YaHei"/>
               </a:rPr>
-              <a:t>round robin / cache aware</a:t>
+              <a:t>最大到达率</a:t>
             </a:r>
           </a:p>
           <a:p>
@@ -18443,7 +18790,7 @@
                 <a:ea typeface="Microsoft YaHei"/>
                 <a:cs typeface="Microsoft YaHei"/>
               </a:rPr>
-              <a:t>整集群再仿真复核</a:t>
+              <a:t>候选配置逐个比较</a:t>
             </a:r>
           </a:p>
           <a:p>
@@ -18467,7 +18814,7 @@
                 <a:ea typeface="Microsoft YaHei"/>
                 <a:cs typeface="Microsoft YaHei"/>
               </a:rPr>
-              <a:t>不达标最多加 3 个实例</a:t>
+              <a:t>取容量最高的</a:t>
             </a:r>
           </a:p>
         </p:txBody>
@@ -18597,7 +18944,7 @@
                 <a:ea typeface="Microsoft YaHei"/>
                 <a:cs typeface="Microsoft YaHei"/>
               </a:rPr>
-              <a:t>server 日志拟合 prefill / decode 系数（实测 / 模型取中位数）；压测检查预测偏差是否在 ±20% 内；校准后重新规划</a:t>
+              <a:t>server 日志拟合 prefill / decode 系数；压测检查预测偏差是否在 ±20% 内；校准后重新规划</a:t>
             </a:r>
           </a:p>
         </p:txBody>
@@ -18687,7 +19034,7 @@
         <p:spPr>
           <a:xfrm>
             <a:off x="694944" y="5175504"/>
-            <a:ext cx="1371600" cy="274320"/>
+            <a:ext cx="2503322" cy="274320"/>
           </a:xfrm>
           <a:prstGeom prst="rect">
             <a:avLst/>
@@ -18888,7 +19235,7 @@
         <p:spPr>
           <a:xfrm>
             <a:off x="4469282" y="5175504"/>
-            <a:ext cx="1371600" cy="274320"/>
+            <a:ext cx="1835810" cy="274320"/>
           </a:xfrm>
           <a:prstGeom prst="rect">
             <a:avLst/>
@@ -19023,7 +19370,7 @@
                 <a:ea typeface="Microsoft YaHei"/>
                 <a:cs typeface="Microsoft YaHei"/>
               </a:rPr>
-              <a:t>算子提速 → 重新仿真 → 卡数变化</a:t>
+              <a:t>算子提速 → 重新仿真 → 单机容量变化</a:t>
             </a:r>
           </a:p>
           <a:p>
@@ -19090,7 +19437,7 @@
         <p:spPr>
           <a:xfrm>
             <a:off x="8243620" y="5175504"/>
-            <a:ext cx="1371600" cy="274320"/>
+            <a:ext cx="2503322" cy="274320"/>
           </a:xfrm>
           <a:prstGeom prst="rect">
             <a:avLst/>
@@ -19123,7 +19470,7 @@
                 <a:ea typeface="Microsoft YaHei"/>
                 <a:cs typeface="Microsoft YaHei"/>
               </a:rPr>
-              <a:t>提需求</a:t>
+              <a:t>向 Loop C 与平台提需求</a:t>
             </a:r>
           </a:p>
         </p:txBody>
@@ -19225,7 +19572,7 @@
                 <a:ea typeface="Microsoft YaHei"/>
                 <a:cs typeface="Microsoft YaHei"/>
               </a:rPr>
-              <a:t>给 Loop C 与平台算子 Agent 的需求</a:t>
+              <a:t>从“把 X 做快”</a:t>
             </a:r>
           </a:p>
           <a:p>
@@ -19249,7 +19596,7 @@
                 <a:ea typeface="Microsoft YaHei"/>
                 <a:cs typeface="Microsoft YaHei"/>
               </a:rPr>
-              <a:t>从“把 X 做快”变成“这些 shape 下快多少能省卡”</a:t>
+              <a:t>变成“这些 shape 下快多少、单机容量涨多少”</a:t>
             </a:r>
           </a:p>
         </p:txBody>
@@ -20498,7 +20845,7 @@
                 <a:ea typeface="Microsoft YaHei"/>
                 <a:cs typeface="Microsoft YaHei"/>
               </a:rPr>
-              <a:t>部署仿真与 launch / 压测命令</a:t>
+              <a:t>单机部署仿真 · launch / 压测命令</a:t>
             </a:r>
           </a:p>
         </p:txBody>
@@ -21445,7 +21792,7 @@
                 <a:ea typeface="Microsoft YaHei"/>
                 <a:cs typeface="Microsoft YaHei"/>
               </a:rPr>
-              <a:t>what-if：算子提速 → 卡数</a:t>
+              <a:t>what-if：算子提速 → 单机容量</a:t>
             </a:r>
           </a:p>
         </p:txBody>

</xml_diff>

<commit_message>
Add speaker notes to the agent-loop deck: a per-slide script that fits in 12 minutes
Each slide's notes carry the script plus an estimated speaking time and running
total (about 10:20 at 200 characters a minute, 11:30 at 180). The same script is
saved as slides/sglang_maestro_agent_loops_speech.md, with where to cut if the
talk runs long. Slide content is unchanged.
</commit_message>
<xml_diff>
--- a/slides/sglang_maestro_agent_loops.pptx
+++ b/slides/sglang_maestro_agent_loops.pptx
@@ -6,14 +6,14 @@
   </p:sldMasterIdLst>
   <p:sldIdLst>
     <p:sldId id="256" r:id="rId7"/>
-    <p:sldId id="257" r:id="rId8"/>
-    <p:sldId id="258" r:id="rId9"/>
-    <p:sldId id="259" r:id="rId10"/>
-    <p:sldId id="260" r:id="rId11"/>
-    <p:sldId id="261" r:id="rId12"/>
-    <p:sldId id="262" r:id="rId13"/>
-    <p:sldId id="263" r:id="rId14"/>
-    <p:sldId id="264" r:id="rId15"/>
+    <p:sldId id="257" r:id="rId9"/>
+    <p:sldId id="258" r:id="rId10"/>
+    <p:sldId id="259" r:id="rId11"/>
+    <p:sldId id="260" r:id="rId12"/>
+    <p:sldId id="261" r:id="rId13"/>
+    <p:sldId id="262" r:id="rId14"/>
+    <p:sldId id="263" r:id="rId15"/>
+    <p:sldId id="264" r:id="rId16"/>
   </p:sldIdLst>
   <p:sldSz cx="12191695" cy="6858000" type="screen4x3"/>
   <p:notesSz cx="6858000" cy="9144000"/>
@@ -113,6 +113,1643 @@
     </a:lvl9pPr>
   </p:defaultTextStyle>
 </p:presentation>
+</file>
+
+<file path=ppt/notesMasters/notesMaster1.xml><?xml version="1.0" encoding="utf-8"?>
+<p:notesMaster xmlns:a="http://schemas.openxmlformats.org/drawingml/2006/main" xmlns:p="http://schemas.openxmlformats.org/presentationml/2006/main" xmlns:r="http://schemas.openxmlformats.org/officeDocument/2006/relationships">
+  <p:cSld>
+    <p:bg>
+      <p:bgRef idx="1001">
+        <a:schemeClr val="bg1"/>
+      </p:bgRef>
+    </p:bg>
+    <p:spTree>
+      <p:nvGrpSpPr>
+        <p:cNvPr id="1" name=""/>
+        <p:cNvGrpSpPr/>
+        <p:nvPr/>
+      </p:nvGrpSpPr>
+      <p:grpSpPr>
+        <a:xfrm>
+          <a:off x="0" y="0"/>
+          <a:ext cx="0" cy="0"/>
+          <a:chOff x="0" y="0"/>
+          <a:chExt cx="0" cy="0"/>
+        </a:xfrm>
+      </p:grpSpPr>
+      <p:sp>
+        <p:nvSpPr>
+          <p:cNvPr id="2" name="Header Placeholder 1"/>
+          <p:cNvSpPr>
+            <a:spLocks noGrp="1"/>
+          </p:cNvSpPr>
+          <p:nvPr>
+            <p:ph type="hdr" sz="quarter"/>
+          </p:nvPr>
+        </p:nvSpPr>
+        <p:spPr>
+          <a:xfrm>
+            <a:off x="0" y="0"/>
+            <a:ext cx="2971800" cy="457200"/>
+          </a:xfrm>
+          <a:prstGeom prst="rect">
+            <a:avLst/>
+          </a:prstGeom>
+        </p:spPr>
+        <p:txBody>
+          <a:bodyPr vert="horz" lIns="91440" tIns="45720" rIns="91440" bIns="45720" rtlCol="0"/>
+          <a:lstStyle>
+            <a:lvl1pPr algn="l">
+              <a:defRPr sz="1200"/>
+            </a:lvl1pPr>
+          </a:lstStyle>
+          <a:p>
+            <a:endParaRPr lang="en-US"/>
+          </a:p>
+        </p:txBody>
+      </p:sp>
+      <p:sp>
+        <p:nvSpPr>
+          <p:cNvPr id="3" name="Date Placeholder 2"/>
+          <p:cNvSpPr>
+            <a:spLocks noGrp="1"/>
+          </p:cNvSpPr>
+          <p:nvPr>
+            <p:ph type="dt" idx="1"/>
+          </p:nvPr>
+        </p:nvSpPr>
+        <p:spPr>
+          <a:xfrm>
+            <a:off x="3884613" y="0"/>
+            <a:ext cx="2971800" cy="457200"/>
+          </a:xfrm>
+          <a:prstGeom prst="rect">
+            <a:avLst/>
+          </a:prstGeom>
+        </p:spPr>
+        <p:txBody>
+          <a:bodyPr vert="horz" lIns="91440" tIns="45720" rIns="91440" bIns="45720" rtlCol="0"/>
+          <a:lstStyle>
+            <a:lvl1pPr algn="r">
+              <a:defRPr sz="1200"/>
+            </a:lvl1pPr>
+          </a:lstStyle>
+          <a:p>
+            <a:fld id="{0F89C1C7-3DCD-1040-A9CF-14679D8B5DDD}" type="datetimeFigureOut">
+              <a:rPr lang="en-US" smtClean="0"/>
+              <a:t>10/17/16</a:t>
+            </a:fld>
+            <a:endParaRPr lang="en-US"/>
+          </a:p>
+        </p:txBody>
+      </p:sp>
+      <p:sp>
+        <p:nvSpPr>
+          <p:cNvPr id="4" name="Slide Image Placeholder 3"/>
+          <p:cNvSpPr>
+            <a:spLocks noGrp="1" noRot="1" noChangeAspect="1"/>
+          </p:cNvSpPr>
+          <p:nvPr>
+            <p:ph type="sldImg" idx="2"/>
+          </p:nvPr>
+        </p:nvSpPr>
+        <p:spPr>
+          <a:xfrm>
+            <a:off x="1143000" y="685800"/>
+            <a:ext cx="4572000" cy="3429000"/>
+          </a:xfrm>
+          <a:prstGeom prst="rect">
+            <a:avLst/>
+          </a:prstGeom>
+          <a:noFill/>
+          <a:ln w="12700">
+            <a:solidFill>
+              <a:prstClr val="black"/>
+            </a:solidFill>
+          </a:ln>
+        </p:spPr>
+        <p:txBody>
+          <a:bodyPr vert="horz" lIns="91440" tIns="45720" rIns="91440" bIns="45720" rtlCol="0" anchor="ctr"/>
+          <a:lstStyle/>
+          <a:p>
+            <a:endParaRPr lang="en-US"/>
+          </a:p>
+        </p:txBody>
+      </p:sp>
+      <p:sp>
+        <p:nvSpPr>
+          <p:cNvPr id="5" name="Notes Placeholder 4"/>
+          <p:cNvSpPr>
+            <a:spLocks noGrp="1"/>
+          </p:cNvSpPr>
+          <p:nvPr>
+            <p:ph type="body" sz="quarter" idx="3"/>
+          </p:nvPr>
+        </p:nvSpPr>
+        <p:spPr>
+          <a:xfrm>
+            <a:off x="685800" y="4343400"/>
+            <a:ext cx="5486400" cy="4114800"/>
+          </a:xfrm>
+          <a:prstGeom prst="rect">
+            <a:avLst/>
+          </a:prstGeom>
+        </p:spPr>
+        <p:txBody>
+          <a:bodyPr vert="horz" lIns="91440" tIns="45720" rIns="91440" bIns="45720" rtlCol="0"/>
+          <a:lstStyle/>
+          <a:p>
+            <a:pPr lvl="0"/>
+            <a:r>
+              <a:rPr lang="en-US" smtClean="0"/>
+              <a:t>Click to edit Master text styles</a:t>
+            </a:r>
+          </a:p>
+          <a:p>
+            <a:pPr lvl="1"/>
+            <a:r>
+              <a:rPr lang="en-US" smtClean="0"/>
+              <a:t>Second level</a:t>
+            </a:r>
+          </a:p>
+          <a:p>
+            <a:pPr lvl="2"/>
+            <a:r>
+              <a:rPr lang="en-US" smtClean="0"/>
+              <a:t>Third level</a:t>
+            </a:r>
+          </a:p>
+          <a:p>
+            <a:pPr lvl="3"/>
+            <a:r>
+              <a:rPr lang="en-US" smtClean="0"/>
+              <a:t>Fourth level</a:t>
+            </a:r>
+          </a:p>
+          <a:p>
+            <a:pPr lvl="4"/>
+            <a:r>
+              <a:rPr lang="en-US" smtClean="0"/>
+              <a:t>Fifth level</a:t>
+            </a:r>
+            <a:endParaRPr lang="en-US"/>
+          </a:p>
+        </p:txBody>
+      </p:sp>
+      <p:sp>
+        <p:nvSpPr>
+          <p:cNvPr id="6" name="Footer Placeholder 5"/>
+          <p:cNvSpPr>
+            <a:spLocks noGrp="1"/>
+          </p:cNvSpPr>
+          <p:nvPr>
+            <p:ph type="ftr" sz="quarter" idx="4"/>
+          </p:nvPr>
+        </p:nvSpPr>
+        <p:spPr>
+          <a:xfrm>
+            <a:off x="0" y="8685213"/>
+            <a:ext cx="2971800" cy="457200"/>
+          </a:xfrm>
+          <a:prstGeom prst="rect">
+            <a:avLst/>
+          </a:prstGeom>
+        </p:spPr>
+        <p:txBody>
+          <a:bodyPr vert="horz" lIns="91440" tIns="45720" rIns="91440" bIns="45720" rtlCol="0" anchor="b"/>
+          <a:lstStyle>
+            <a:lvl1pPr algn="l">
+              <a:defRPr sz="1200"/>
+            </a:lvl1pPr>
+          </a:lstStyle>
+          <a:p>
+            <a:endParaRPr lang="en-US"/>
+          </a:p>
+        </p:txBody>
+      </p:sp>
+      <p:sp>
+        <p:nvSpPr>
+          <p:cNvPr id="7" name="Slide Number Placeholder 6"/>
+          <p:cNvSpPr>
+            <a:spLocks noGrp="1"/>
+          </p:cNvSpPr>
+          <p:nvPr>
+            <p:ph type="sldNum" sz="quarter" idx="5"/>
+          </p:nvPr>
+        </p:nvSpPr>
+        <p:spPr>
+          <a:xfrm>
+            <a:off x="3884613" y="8685213"/>
+            <a:ext cx="2971800" cy="457200"/>
+          </a:xfrm>
+          <a:prstGeom prst="rect">
+            <a:avLst/>
+          </a:prstGeom>
+        </p:spPr>
+        <p:txBody>
+          <a:bodyPr vert="horz" lIns="91440" tIns="45720" rIns="91440" bIns="45720" rtlCol="0" anchor="b"/>
+          <a:lstStyle>
+            <a:lvl1pPr algn="r">
+              <a:defRPr sz="1200"/>
+            </a:lvl1pPr>
+          </a:lstStyle>
+          <a:p>
+            <a:fld id="{BB5E49A5-4136-284D-997B-48E1D791AD67}" type="slidenum">
+              <a:rPr lang="en-US" smtClean="0"/>
+              <a:t>‹#›</a:t>
+            </a:fld>
+            <a:endParaRPr lang="en-US"/>
+          </a:p>
+        </p:txBody>
+      </p:sp>
+    </p:spTree>
+    <p:extLst>
+      <p:ext uri="{BB962C8B-B14F-4D97-AF65-F5344CB8AC3E}">
+        <p14:creationId xmlns:p14="http://schemas.microsoft.com/office/powerpoint/2010/main" val="2623252185"/>
+      </p:ext>
+    </p:extLst>
+  </p:cSld>
+  <p:clrMap bg1="lt1" tx1="dk1" bg2="lt2" tx2="dk2" accent1="accent1" accent2="accent2" accent3="accent3" accent4="accent4" accent5="accent5" accent6="accent6" hlink="hlink" folHlink="folHlink"/>
+  <p:notesStyle>
+    <a:lvl1pPr marL="0" algn="l" defTabSz="457200" rtl="0" eaLnBrk="1" latinLnBrk="0" hangingPunct="1">
+      <a:defRPr sz="1200" kern="1200">
+        <a:solidFill>
+          <a:schemeClr val="tx1"/>
+        </a:solidFill>
+        <a:latin typeface="+mn-lt"/>
+        <a:ea typeface="+mn-ea"/>
+        <a:cs typeface="+mn-cs"/>
+      </a:defRPr>
+    </a:lvl1pPr>
+    <a:lvl2pPr marL="457200" algn="l" defTabSz="457200" rtl="0" eaLnBrk="1" latinLnBrk="0" hangingPunct="1">
+      <a:defRPr sz="1200" kern="1200">
+        <a:solidFill>
+          <a:schemeClr val="tx1"/>
+        </a:solidFill>
+        <a:latin typeface="+mn-lt"/>
+        <a:ea typeface="+mn-ea"/>
+        <a:cs typeface="+mn-cs"/>
+      </a:defRPr>
+    </a:lvl2pPr>
+    <a:lvl3pPr marL="914400" algn="l" defTabSz="457200" rtl="0" eaLnBrk="1" latinLnBrk="0" hangingPunct="1">
+      <a:defRPr sz="1200" kern="1200">
+        <a:solidFill>
+          <a:schemeClr val="tx1"/>
+        </a:solidFill>
+        <a:latin typeface="+mn-lt"/>
+        <a:ea typeface="+mn-ea"/>
+        <a:cs typeface="+mn-cs"/>
+      </a:defRPr>
+    </a:lvl3pPr>
+    <a:lvl4pPr marL="1371600" algn="l" defTabSz="457200" rtl="0" eaLnBrk="1" latinLnBrk="0" hangingPunct="1">
+      <a:defRPr sz="1200" kern="1200">
+        <a:solidFill>
+          <a:schemeClr val="tx1"/>
+        </a:solidFill>
+        <a:latin typeface="+mn-lt"/>
+        <a:ea typeface="+mn-ea"/>
+        <a:cs typeface="+mn-cs"/>
+      </a:defRPr>
+    </a:lvl4pPr>
+    <a:lvl5pPr marL="1828800" algn="l" defTabSz="457200" rtl="0" eaLnBrk="1" latinLnBrk="0" hangingPunct="1">
+      <a:defRPr sz="1200" kern="1200">
+        <a:solidFill>
+          <a:schemeClr val="tx1"/>
+        </a:solidFill>
+        <a:latin typeface="+mn-lt"/>
+        <a:ea typeface="+mn-ea"/>
+        <a:cs typeface="+mn-cs"/>
+      </a:defRPr>
+    </a:lvl5pPr>
+    <a:lvl6pPr marL="2286000" algn="l" defTabSz="457200" rtl="0" eaLnBrk="1" latinLnBrk="0" hangingPunct="1">
+      <a:defRPr sz="1200" kern="1200">
+        <a:solidFill>
+          <a:schemeClr val="tx1"/>
+        </a:solidFill>
+        <a:latin typeface="+mn-lt"/>
+        <a:ea typeface="+mn-ea"/>
+        <a:cs typeface="+mn-cs"/>
+      </a:defRPr>
+    </a:lvl6pPr>
+    <a:lvl7pPr marL="2743200" algn="l" defTabSz="457200" rtl="0" eaLnBrk="1" latinLnBrk="0" hangingPunct="1">
+      <a:defRPr sz="1200" kern="1200">
+        <a:solidFill>
+          <a:schemeClr val="tx1"/>
+        </a:solidFill>
+        <a:latin typeface="+mn-lt"/>
+        <a:ea typeface="+mn-ea"/>
+        <a:cs typeface="+mn-cs"/>
+      </a:defRPr>
+    </a:lvl7pPr>
+    <a:lvl8pPr marL="3200400" algn="l" defTabSz="457200" rtl="0" eaLnBrk="1" latinLnBrk="0" hangingPunct="1">
+      <a:defRPr sz="1200" kern="1200">
+        <a:solidFill>
+          <a:schemeClr val="tx1"/>
+        </a:solidFill>
+        <a:latin typeface="+mn-lt"/>
+        <a:ea typeface="+mn-ea"/>
+        <a:cs typeface="+mn-cs"/>
+      </a:defRPr>
+    </a:lvl8pPr>
+    <a:lvl9pPr marL="3657600" algn="l" defTabSz="457200" rtl="0" eaLnBrk="1" latinLnBrk="0" hangingPunct="1">
+      <a:defRPr sz="1200" kern="1200">
+        <a:solidFill>
+          <a:schemeClr val="tx1"/>
+        </a:solidFill>
+        <a:latin typeface="+mn-lt"/>
+        <a:ea typeface="+mn-ea"/>
+        <a:cs typeface="+mn-cs"/>
+      </a:defRPr>
+    </a:lvl9pPr>
+  </p:notesStyle>
+</p:notesMaster>
+</file>
+
+<file path=ppt/notesSlides/notesSlide1.xml><?xml version="1.0" encoding="utf-8"?>
+<p:notes xmlns:a="http://schemas.openxmlformats.org/drawingml/2006/main" xmlns:p="http://schemas.openxmlformats.org/presentationml/2006/main" xmlns:r="http://schemas.openxmlformats.org/officeDocument/2006/relationships">
+  <p:cSld>
+    <p:spTree>
+      <p:nvGrpSpPr>
+        <p:cNvPr id="1" name=""/>
+        <p:cNvGrpSpPr/>
+        <p:nvPr/>
+      </p:nvGrpSpPr>
+      <p:grpSpPr>
+        <a:xfrm>
+          <a:off x="0" y="0"/>
+          <a:ext cx="0" cy="0"/>
+          <a:chOff x="0" y="0"/>
+          <a:chExt cx="0" cy="0"/>
+        </a:xfrm>
+      </p:grpSpPr>
+      <p:sp>
+        <p:nvSpPr>
+          <p:cNvPr id="2" name="Slide Image Placeholder 1"/>
+          <p:cNvSpPr>
+            <a:spLocks noGrp="1"/>
+          </p:cNvSpPr>
+          <p:nvPr>
+            <p:ph type="sldImg" idx="2"/>
+          </p:nvPr>
+        </p:nvSpPr>
+        <p:spPr/>
+      </p:sp>
+      <p:sp>
+        <p:nvSpPr>
+          <p:cNvPr id="3" name="Notes Placeholder 2"/>
+          <p:cNvSpPr>
+            <a:spLocks noGrp="1"/>
+          </p:cNvSpPr>
+          <p:nvPr>
+            <p:ph type="body" idx="3" sz="quarter"/>
+          </p:nvPr>
+        </p:nvSpPr>
+        <p:spPr/>
+        <p:txBody>
+          <a:bodyPr/>
+          <a:lstStyle/>
+          <a:p>
+            <a:pPr>
+              <a:spcAft>
+                <a:spcPts val="600"/>
+              </a:spcAft>
+            </a:pPr>
+            <a:r>
+              <a:rPr sz="1200" b="1">
+                <a:solidFill>
+                  <a:srgbClr val="66727F"/>
+                </a:solidFill>
+                <a:latin typeface="Microsoft YaHei"/>
+                <a:ea typeface="Microsoft YaHei"/>
+                <a:cs typeface="Microsoft YaHei"/>
+              </a:rPr>
+              <a:t>【第 1 页 · 封面 · 约 25 秒 · 讲完累计约 0:25】</a:t>
+            </a:r>
+          </a:p>
+          <a:p>
+            <a:pPr>
+              <a:spcAft>
+                <a:spcPts val="600"/>
+              </a:spcAft>
+            </a:pPr>
+            <a:r>
+              <a:rPr sz="1200" b="0">
+                <a:solidFill>
+                  <a:srgbClr val="16202A"/>
+                </a:solidFill>
+                <a:latin typeface="Microsoft YaHei"/>
+                <a:ea typeface="Microsoft YaHei"/>
+                <a:cs typeface="Microsoft YaHei"/>
+              </a:rPr>
+              <a:t>各位好，今天汇报 sglang-maestro：一个帮 SGLang 在 M100 上做适配和调优的 Agent，目前面向单机部署。核心一句话：从算子级做到模型级。</a:t>
+            </a:r>
+          </a:p>
+          <a:p>
+            <a:pPr>
+              <a:spcAft>
+                <a:spcPts val="600"/>
+              </a:spcAft>
+            </a:pPr>
+            <a:r>
+              <a:rPr sz="1200" b="0">
+                <a:solidFill>
+                  <a:srgbClr val="16202A"/>
+                </a:solidFill>
+                <a:latin typeface="Microsoft YaHei"/>
+                <a:ea typeface="Microsoft YaHei"/>
+                <a:cs typeface="Microsoft YaHei"/>
+              </a:rPr>
+              <a:t>下面分三个 Agent Loop，讲它怎么助力框架迭代、模型适配、算子绑定，最后挑一个难点讲透。</a:t>
+            </a:r>
+          </a:p>
+        </p:txBody>
+      </p:sp>
+      <p:sp>
+        <p:nvSpPr>
+          <p:cNvPr id="4" name="Slide Number Placeholder 3"/>
+          <p:cNvSpPr>
+            <a:spLocks noGrp="1"/>
+          </p:cNvSpPr>
+          <p:nvPr>
+            <p:ph type="sldNum" idx="5" sz="quarter"/>
+          </p:nvPr>
+        </p:nvSpPr>
+        <p:spPr/>
+      </p:sp>
+    </p:spTree>
+  </p:cSld>
+  <p:clrMapOvr>
+    <a:masterClrMapping/>
+  </p:clrMapOvr>
+</p:notes>
+</file>
+
+<file path=ppt/notesSlides/notesSlide2.xml><?xml version="1.0" encoding="utf-8"?>
+<p:notes xmlns:a="http://schemas.openxmlformats.org/drawingml/2006/main" xmlns:p="http://schemas.openxmlformats.org/presentationml/2006/main" xmlns:r="http://schemas.openxmlformats.org/officeDocument/2006/relationships">
+  <p:cSld>
+    <p:spTree>
+      <p:nvGrpSpPr>
+        <p:cNvPr id="1" name=""/>
+        <p:cNvGrpSpPr/>
+        <p:nvPr/>
+      </p:nvGrpSpPr>
+      <p:grpSpPr>
+        <a:xfrm>
+          <a:off x="0" y="0"/>
+          <a:ext cx="0" cy="0"/>
+          <a:chOff x="0" y="0"/>
+          <a:chExt cx="0" cy="0"/>
+        </a:xfrm>
+      </p:grpSpPr>
+      <p:sp>
+        <p:nvSpPr>
+          <p:cNvPr id="2" name="Slide Image Placeholder 1"/>
+          <p:cNvSpPr>
+            <a:spLocks noGrp="1"/>
+          </p:cNvSpPr>
+          <p:nvPr>
+            <p:ph type="sldImg" idx="2"/>
+          </p:nvPr>
+        </p:nvSpPr>
+        <p:spPr/>
+      </p:sp>
+      <p:sp>
+        <p:nvSpPr>
+          <p:cNvPr id="3" name="Notes Placeholder 2"/>
+          <p:cNvSpPr>
+            <a:spLocks noGrp="1"/>
+          </p:cNvSpPr>
+          <p:nvPr>
+            <p:ph type="body" idx="3" sz="quarter"/>
+          </p:nvPr>
+        </p:nvSpPr>
+        <p:spPr/>
+        <p:txBody>
+          <a:bodyPr/>
+          <a:lstStyle/>
+          <a:p>
+            <a:pPr>
+              <a:spcAft>
+                <a:spcPts val="600"/>
+              </a:spcAft>
+            </a:pPr>
+            <a:r>
+              <a:rPr sz="1200" b="1">
+                <a:solidFill>
+                  <a:srgbClr val="66727F"/>
+                </a:solidFill>
+                <a:latin typeface="Microsoft YaHei"/>
+                <a:ea typeface="Microsoft YaHei"/>
+                <a:cs typeface="Microsoft YaHei"/>
+              </a:rPr>
+              <a:t>【第 2 页 · 全局 · 三个 Agent Loop · 约 70 秒 · 讲完累计约 1:35】</a:t>
+            </a:r>
+          </a:p>
+          <a:p>
+            <a:pPr>
+              <a:spcAft>
+                <a:spcPts val="600"/>
+              </a:spcAft>
+            </a:pPr>
+            <a:r>
+              <a:rPr sz="1200" b="0">
+                <a:solidFill>
+                  <a:srgbClr val="16202A"/>
+                </a:solidFill>
+                <a:latin typeface="Microsoft YaHei"/>
+                <a:ea typeface="Microsoft YaHei"/>
+                <a:cs typeface="Microsoft YaHei"/>
+              </a:rPr>
+              <a:t>先看全局：三个 Loop 分层咬合，框架定规则，模型定目标，算子定成本。</a:t>
+            </a:r>
+          </a:p>
+          <a:p>
+            <a:pPr>
+              <a:spcAft>
+                <a:spcPts val="600"/>
+              </a:spcAft>
+            </a:pPr>
+            <a:r>
+              <a:rPr sz="1200" b="0">
+                <a:solidFill>
+                  <a:srgbClr val="16202A"/>
+                </a:solidFill>
+                <a:latin typeface="Microsoft YaHei"/>
+                <a:ea typeface="Microsoft YaHei"/>
+                <a:cs typeface="Microsoft YaHei"/>
+              </a:rPr>
+              <a:t>最上面的 Loop A 回答：这一版 SGLang 在 M100 上能开哪些特性、插件要补什么。它向下提供启动参数、特性约束、平台 hook 和算子分发规则；下面两个 Loop 发现的缺口，再回传给它。</a:t>
+            </a:r>
+          </a:p>
+          <a:p>
+            <a:pPr>
+              <a:spcAft>
+                <a:spcPts val="600"/>
+              </a:spcAft>
+            </a:pPr>
+            <a:r>
+              <a:rPr sz="1200" b="0">
+                <a:solidFill>
+                  <a:srgbClr val="16202A"/>
+                </a:solidFill>
+                <a:latin typeface="Microsoft YaHei"/>
+                <a:ea typeface="Microsoft YaHei"/>
+                <a:cs typeface="Microsoft YaHei"/>
+              </a:rPr>
+              <a:t>下面两个 Loop 互为输入：Loop B 看模型能不能上、怎么配、单机在 SLO 内能扛多少；Loop C 看每个算子实际跑哪条实现、慢在哪、先优化谁。B 把算子缺口和热点按占 step 的比例排好序交给 C，C 把实测耗时交回 B，校准成本模型、重新规划。</a:t>
+            </a:r>
+          </a:p>
+          <a:p>
+            <a:pPr>
+              <a:spcAft>
+                <a:spcPts val="600"/>
+              </a:spcAft>
+            </a:pPr>
+            <a:r>
+              <a:rPr sz="1200" b="0">
+                <a:solidFill>
+                  <a:srgbClr val="16202A"/>
+                </a:solidFill>
+                <a:latin typeface="Microsoft YaHei"/>
+                <a:ea typeface="Microsoft YaHei"/>
+                <a:cs typeface="Microsoft YaHei"/>
+              </a:rPr>
+              <a:t>三个 Loop 共用一套证据底座：源码静态分析、算子级成本模型和实测校准。图里虚线表示规划中。接下来逐个看。</a:t>
+            </a:r>
+          </a:p>
+        </p:txBody>
+      </p:sp>
+      <p:sp>
+        <p:nvSpPr>
+          <p:cNvPr id="4" name="Slide Number Placeholder 3"/>
+          <p:cNvSpPr>
+            <a:spLocks noGrp="1"/>
+          </p:cNvSpPr>
+          <p:nvPr>
+            <p:ph type="sldNum" idx="5" sz="quarter"/>
+          </p:nvPr>
+        </p:nvSpPr>
+        <p:spPr/>
+      </p:sp>
+    </p:spTree>
+  </p:cSld>
+  <p:clrMapOvr>
+    <a:masterClrMapping/>
+  </p:clrMapOvr>
+</p:notes>
+</file>
+
+<file path=ppt/notesSlides/notesSlide3.xml><?xml version="1.0" encoding="utf-8"?>
+<p:notes xmlns:a="http://schemas.openxmlformats.org/drawingml/2006/main" xmlns:p="http://schemas.openxmlformats.org/presentationml/2006/main" xmlns:r="http://schemas.openxmlformats.org/officeDocument/2006/relationships">
+  <p:cSld>
+    <p:spTree>
+      <p:nvGrpSpPr>
+        <p:cNvPr id="1" name=""/>
+        <p:cNvGrpSpPr/>
+        <p:nvPr/>
+      </p:nvGrpSpPr>
+      <p:grpSpPr>
+        <a:xfrm>
+          <a:off x="0" y="0"/>
+          <a:ext cx="0" cy="0"/>
+          <a:chOff x="0" y="0"/>
+          <a:chExt cx="0" cy="0"/>
+        </a:xfrm>
+      </p:grpSpPr>
+      <p:sp>
+        <p:nvSpPr>
+          <p:cNvPr id="2" name="Slide Image Placeholder 1"/>
+          <p:cNvSpPr>
+            <a:spLocks noGrp="1"/>
+          </p:cNvSpPr>
+          <p:nvPr>
+            <p:ph type="sldImg" idx="2"/>
+          </p:nvPr>
+        </p:nvSpPr>
+        <p:spPr/>
+      </p:sp>
+      <p:sp>
+        <p:nvSpPr>
+          <p:cNvPr id="3" name="Notes Placeholder 2"/>
+          <p:cNvSpPr>
+            <a:spLocks noGrp="1"/>
+          </p:cNvSpPr>
+          <p:nvPr>
+            <p:ph type="body" idx="3" sz="quarter"/>
+          </p:nvPr>
+        </p:nvSpPr>
+        <p:spPr/>
+        <p:txBody>
+          <a:bodyPr/>
+          <a:lstStyle/>
+          <a:p>
+            <a:pPr>
+              <a:spcAft>
+                <a:spcPts val="600"/>
+              </a:spcAft>
+            </a:pPr>
+            <a:r>
+              <a:rPr sz="1200" b="1">
+                <a:solidFill>
+                  <a:srgbClr val="66727F"/>
+                </a:solidFill>
+                <a:latin typeface="Microsoft YaHei"/>
+                <a:ea typeface="Microsoft YaHei"/>
+                <a:cs typeface="Microsoft YaHei"/>
+              </a:rPr>
+              <a:t>【第 3 页 · Loop A · 助力框架迭代 · 约 65 秒 · 讲完累计约 2:40】</a:t>
+            </a:r>
+          </a:p>
+          <a:p>
+            <a:pPr>
+              <a:spcAft>
+                <a:spcPts val="600"/>
+              </a:spcAft>
+            </a:pPr>
+            <a:r>
+              <a:rPr sz="1200" b="0">
+                <a:solidFill>
+                  <a:srgbClr val="16202A"/>
+                </a:solidFill>
+                <a:latin typeface="Microsoft YaHei"/>
+                <a:ea typeface="Microsoft YaHei"/>
+                <a:cs typeface="Microsoft YaHei"/>
+              </a:rPr>
+              <a:t>Loop A 助力框架迭代：SGLang 每升一版，Agent 就重算一遍 M100 能开哪些特性、怎么调。</a:t>
+            </a:r>
+          </a:p>
+          <a:p>
+            <a:pPr>
+              <a:spcAft>
+                <a:spcPts val="600"/>
+              </a:spcAft>
+            </a:pPr>
+            <a:r>
+              <a:rPr sz="1200" b="0">
+                <a:solidFill>
+                  <a:srgbClr val="16202A"/>
+                </a:solidFill>
+                <a:latin typeface="Microsoft YaHei"/>
+                <a:ea typeface="Microsoft YaHei"/>
+                <a:cs typeface="Microsoft YaHei"/>
+              </a:rPr>
+              <a:t>新版本、新特性或 M100 插件更新都会触发它。流程四步：同步知识，静态分析源码生成能力快照，不需要 GPU；判可行，复用 SGLang 自己的校验规则，再核对插件 hook 和平台能力；算收益，用成本模型估 KV 容量、decode 吞吐和时延；出配置，把能共存的特性合并成一条 launch。</a:t>
+            </a:r>
+          </a:p>
+          <a:p>
+            <a:pPr>
+              <a:spcAft>
+                <a:spcPts val="600"/>
+              </a:spcAft>
+            </a:pPr>
+            <a:r>
+              <a:rPr sz="1200" b="0">
+                <a:solidFill>
+                  <a:srgbClr val="16202A"/>
+                </a:solidFill>
+                <a:latin typeface="Microsoft YaHei"/>
+                <a:ea typeface="Microsoft YaHei"/>
+                <a:cs typeface="Microsoft YaHei"/>
+              </a:rPr>
+              <a:t>以 10 月 14 号的快照为例，里面有 521 个启动参数、37 个平台 hook。交给框架迭代的结论，比如 7 个子系统在 OOT 平台上会被直接拒绝，2 处必须由插件实现 hook 才能用，这就是插件开发清单。</a:t>
+            </a:r>
+          </a:p>
+        </p:txBody>
+      </p:sp>
+      <p:sp>
+        <p:nvSpPr>
+          <p:cNvPr id="4" name="Slide Number Placeholder 3"/>
+          <p:cNvSpPr>
+            <a:spLocks noGrp="1"/>
+          </p:cNvSpPr>
+          <p:nvPr>
+            <p:ph type="sldNum" idx="5" sz="quarter"/>
+          </p:nvPr>
+        </p:nvSpPr>
+        <p:spPr/>
+      </p:sp>
+    </p:spTree>
+  </p:cSld>
+  <p:clrMapOvr>
+    <a:masterClrMapping/>
+  </p:clrMapOvr>
+</p:notes>
+</file>
+
+<file path=ppt/notesSlides/notesSlide4.xml><?xml version="1.0" encoding="utf-8"?>
+<p:notes xmlns:a="http://schemas.openxmlformats.org/drawingml/2006/main" xmlns:p="http://schemas.openxmlformats.org/presentationml/2006/main" xmlns:r="http://schemas.openxmlformats.org/officeDocument/2006/relationships">
+  <p:cSld>
+    <p:spTree>
+      <p:nvGrpSpPr>
+        <p:cNvPr id="1" name=""/>
+        <p:cNvGrpSpPr/>
+        <p:nvPr/>
+      </p:nvGrpSpPr>
+      <p:grpSpPr>
+        <a:xfrm>
+          <a:off x="0" y="0"/>
+          <a:ext cx="0" cy="0"/>
+          <a:chOff x="0" y="0"/>
+          <a:chExt cx="0" cy="0"/>
+        </a:xfrm>
+      </p:grpSpPr>
+      <p:sp>
+        <p:nvSpPr>
+          <p:cNvPr id="2" name="Slide Image Placeholder 1"/>
+          <p:cNvSpPr>
+            <a:spLocks noGrp="1"/>
+          </p:cNvSpPr>
+          <p:nvPr>
+            <p:ph type="sldImg" idx="2"/>
+          </p:nvPr>
+        </p:nvSpPr>
+        <p:spPr/>
+      </p:sp>
+      <p:sp>
+        <p:nvSpPr>
+          <p:cNvPr id="3" name="Notes Placeholder 2"/>
+          <p:cNvSpPr>
+            <a:spLocks noGrp="1"/>
+          </p:cNvSpPr>
+          <p:nvPr>
+            <p:ph type="body" idx="3" sz="quarter"/>
+          </p:nvPr>
+        </p:nvSpPr>
+        <p:spPr/>
+        <p:txBody>
+          <a:bodyPr/>
+          <a:lstStyle/>
+          <a:p>
+            <a:pPr>
+              <a:spcAft>
+                <a:spcPts val="600"/>
+              </a:spcAft>
+            </a:pPr>
+            <a:r>
+              <a:rPr sz="1200" b="1">
+                <a:solidFill>
+                  <a:srgbClr val="66727F"/>
+                </a:solidFill>
+                <a:latin typeface="Microsoft YaHei"/>
+                <a:ea typeface="Microsoft YaHei"/>
+                <a:cs typeface="Microsoft YaHei"/>
+              </a:rPr>
+              <a:t>【第 4 页 · Loop B · 助力模型适配与评估优化 · 约 80 秒 · 讲完累计约 4:00】</a:t>
+            </a:r>
+          </a:p>
+          <a:p>
+            <a:pPr>
+              <a:spcAft>
+                <a:spcPts val="600"/>
+              </a:spcAft>
+            </a:pPr>
+            <a:r>
+              <a:rPr sz="1200" b="0">
+                <a:solidFill>
+                  <a:srgbClr val="16202A"/>
+                </a:solidFill>
+                <a:latin typeface="Microsoft YaHei"/>
+                <a:ea typeface="Microsoft YaHei"/>
+                <a:cs typeface="Microsoft YaHei"/>
+              </a:rPr>
+              <a:t>Loop B 助力模型适配与评估优化：把一个新模型从“能不能跑”，一路推到“单机在 SLO 内能扛多少请求”。</a:t>
+            </a:r>
+          </a:p>
+          <a:p>
+            <a:pPr>
+              <a:spcAft>
+                <a:spcPts val="600"/>
+              </a:spcAft>
+            </a:pPr>
+            <a:r>
+              <a:rPr sz="1200" b="0">
+                <a:solidFill>
+                  <a:srgbClr val="16202A"/>
+                </a:solidFill>
+                <a:latin typeface="Microsoft YaHei"/>
+                <a:ea typeface="Microsoft YaHei"/>
+                <a:cs typeface="Microsoft YaHei"/>
+              </a:rPr>
+              <a:t>左边这个环有六步：适配分析、精度路线、特性组合、仿真评估、压测验证、校准回灌。其中压测目前还靠人工执行 Agent 给的命令。</a:t>
+            </a:r>
+          </a:p>
+          <a:p>
+            <a:pPr>
+              <a:spcAft>
+                <a:spcPts val="600"/>
+              </a:spcAft>
+            </a:pPr>
+            <a:r>
+              <a:rPr sz="1200" b="0">
+                <a:solidFill>
+                  <a:srgbClr val="16202A"/>
+                </a:solidFill>
+                <a:latin typeface="Microsoft YaHei"/>
+                <a:ea typeface="Microsoft YaHei"/>
+                <a:cs typeface="Microsoft YaHei"/>
+              </a:rPr>
+              <a:t>右边是三个机制。候选方案怎么来：先套 Loop A 调好的 launch；TTFT 先超标，就试 prefill 更快的布局，比如关掉 DP attention；TPOT 先超标、又没开投机解码，就试更小的 mixed chunk。怎么算：仿真 SGLang 的调度，按 P90 判 SLO，二分搜索单机在 SLO 内的最大到达率。怎么信：用 server 日志拟合系数，压测检查偏差是否在正负 20% 以内。</a:t>
+            </a:r>
+          </a:p>
+          <a:p>
+            <a:pPr>
+              <a:spcAft>
+                <a:spcPts val="600"/>
+              </a:spcAft>
+            </a:pPr>
+            <a:r>
+              <a:rPr sz="1200" b="0">
+                <a:solidFill>
+                  <a:srgbClr val="16202A"/>
+                </a:solidFill>
+                <a:latin typeface="Microsoft YaHei"/>
+                <a:ea typeface="Microsoft YaHei"/>
+                <a:cs typeface="Microsoft YaHei"/>
+              </a:rPr>
+              <a:t>和 Loop C 的接口：占 step 10% 以上的算子缺口标高优先级，3% 以上标中，交给 C。</a:t>
+            </a:r>
+          </a:p>
+        </p:txBody>
+      </p:sp>
+      <p:sp>
+        <p:nvSpPr>
+          <p:cNvPr id="4" name="Slide Number Placeholder 3"/>
+          <p:cNvSpPr>
+            <a:spLocks noGrp="1"/>
+          </p:cNvSpPr>
+          <p:nvPr>
+            <p:ph type="sldNum" idx="5" sz="quarter"/>
+          </p:nvPr>
+        </p:nvSpPr>
+        <p:spPr/>
+      </p:sp>
+    </p:spTree>
+  </p:cSld>
+  <p:clrMapOvr>
+    <a:masterClrMapping/>
+  </p:clrMapOvr>
+</p:notes>
+</file>
+
+<file path=ppt/notesSlides/notesSlide5.xml><?xml version="1.0" encoding="utf-8"?>
+<p:notes xmlns:a="http://schemas.openxmlformats.org/drawingml/2006/main" xmlns:p="http://schemas.openxmlformats.org/presentationml/2006/main" xmlns:r="http://schemas.openxmlformats.org/officeDocument/2006/relationships">
+  <p:cSld>
+    <p:spTree>
+      <p:nvGrpSpPr>
+        <p:cNvPr id="1" name=""/>
+        <p:cNvGrpSpPr/>
+        <p:nvPr/>
+      </p:nvGrpSpPr>
+      <p:grpSpPr>
+        <a:xfrm>
+          <a:off x="0" y="0"/>
+          <a:ext cx="0" cy="0"/>
+          <a:chOff x="0" y="0"/>
+          <a:chExt cx="0" cy="0"/>
+        </a:xfrm>
+      </p:grpSpPr>
+      <p:sp>
+        <p:nvSpPr>
+          <p:cNvPr id="2" name="Slide Image Placeholder 1"/>
+          <p:cNvSpPr>
+            <a:spLocks noGrp="1"/>
+          </p:cNvSpPr>
+          <p:nvPr>
+            <p:ph type="sldImg" idx="2"/>
+          </p:nvPr>
+        </p:nvSpPr>
+        <p:spPr/>
+      </p:sp>
+      <p:sp>
+        <p:nvSpPr>
+          <p:cNvPr id="3" name="Notes Placeholder 2"/>
+          <p:cNvSpPr>
+            <a:spLocks noGrp="1"/>
+          </p:cNvSpPr>
+          <p:nvPr>
+            <p:ph type="body" idx="3" sz="quarter"/>
+          </p:nvPr>
+        </p:nvSpPr>
+        <p:spPr/>
+        <p:txBody>
+          <a:bodyPr/>
+          <a:lstStyle/>
+          <a:p>
+            <a:pPr>
+              <a:spcAft>
+                <a:spcPts val="600"/>
+              </a:spcAft>
+            </a:pPr>
+            <a:r>
+              <a:rPr sz="1200" b="1">
+                <a:solidFill>
+                  <a:srgbClr val="66727F"/>
+                </a:solidFill>
+                <a:latin typeface="Microsoft YaHei"/>
+                <a:ea typeface="Microsoft YaHei"/>
+                <a:cs typeface="Microsoft YaHei"/>
+              </a:rPr>
+              <a:t>【第 5 页 · Loop C · 助力算子绑定评估与优化 · 约 80 秒 · 讲完累计约 5:20】</a:t>
+            </a:r>
+          </a:p>
+          <a:p>
+            <a:pPr>
+              <a:spcAft>
+                <a:spcPts val="600"/>
+              </a:spcAft>
+            </a:pPr>
+            <a:r>
+              <a:rPr sz="1200" b="0">
+                <a:solidFill>
+                  <a:srgbClr val="16202A"/>
+                </a:solidFill>
+                <a:latin typeface="Microsoft YaHei"/>
+                <a:ea typeface="Microsoft YaHei"/>
+                <a:cs typeface="Microsoft YaHei"/>
+              </a:rPr>
+              <a:t>Loop C 助力算子绑定评估与优化：先查绑没绑对，再查快不快，最后按模型占比排优先级。</a:t>
+            </a:r>
+          </a:p>
+          <a:p>
+            <a:pPr>
+              <a:spcAft>
+                <a:spcPts val="600"/>
+              </a:spcAft>
+            </a:pPr>
+            <a:r>
+              <a:rPr sz="1200" b="0">
+                <a:solidFill>
+                  <a:srgbClr val="16202A"/>
+                </a:solidFill>
+                <a:latin typeface="Microsoft YaHei"/>
+                <a:ea typeface="Microsoft YaHei"/>
+                <a:cs typeface="Microsoft YaHei"/>
+              </a:rPr>
+              <a:t>为什么先查绑定？因为生成了 kernel，不等于模型用上了它。左边从模型实际用到的算子族出发，沿 SGLang 的分发入口，解析出每个算子在 M100 上实际走哪条路径：厂商实现、SGLang 内置实现，还是回落到 torch、甚至没有可用实现。</a:t>
+            </a:r>
+          </a:p>
+          <a:p>
+            <a:pPr>
+              <a:spcAft>
+                <a:spcPts val="600"/>
+              </a:spcAft>
+            </a:pPr>
+            <a:r>
+              <a:rPr sz="1200" b="0">
+                <a:solidFill>
+                  <a:srgbClr val="16202A"/>
+                </a:solidFill>
+                <a:latin typeface="Microsoft YaHei"/>
+                <a:ea typeface="Microsoft YaHei"/>
+                <a:cs typeface="Microsoft YaHei"/>
+              </a:rPr>
+              <a:t>典型陷阱是模型能跑通，注册的 kernel 却没被调用，比如 OOT 注册只认精确的类，子类不会继承。Agent 从源码解析继承链，直接把这类路径标出来。</a:t>
+            </a:r>
+          </a:p>
+          <a:p>
+            <a:pPr>
+              <a:spcAft>
+                <a:spcPts val="600"/>
+              </a:spcAft>
+            </a:pPr>
+            <a:r>
+              <a:rPr sz="1200" b="0">
+                <a:solidFill>
+                  <a:srgbClr val="16202A"/>
+                </a:solidFill>
+                <a:latin typeface="Microsoft YaHei"/>
+                <a:ea typeface="Microsoft YaHei"/>
+                <a:cs typeface="Microsoft YaHei"/>
+              </a:rPr>
+              <a:t>右边是性能评估：按真实 batch 形状算出各类 kernel 的期望耗时，对照实测找异常；再匹配融合、通算重叠、多流、L2 预取等手段，每条发现都折算成每个 step 多少毫秒，交给 Loop B。自动 A/B 复测还在规划中。</a:t>
+            </a:r>
+          </a:p>
+        </p:txBody>
+      </p:sp>
+      <p:sp>
+        <p:nvSpPr>
+          <p:cNvPr id="4" name="Slide Number Placeholder 3"/>
+          <p:cNvSpPr>
+            <a:spLocks noGrp="1"/>
+          </p:cNvSpPr>
+          <p:nvPr>
+            <p:ph type="sldNum" idx="5" sz="quarter"/>
+          </p:nvPr>
+        </p:nvSpPr>
+        <p:spPr/>
+      </p:sp>
+    </p:spTree>
+  </p:cSld>
+  <p:clrMapOvr>
+    <a:masterClrMapping/>
+  </p:clrMapOvr>
+</p:notes>
+</file>
+
+<file path=ppt/notesSlides/notesSlide6.xml><?xml version="1.0" encoding="utf-8"?>
+<p:notes xmlns:a="http://schemas.openxmlformats.org/drawingml/2006/main" xmlns:p="http://schemas.openxmlformats.org/presentationml/2006/main" xmlns:r="http://schemas.openxmlformats.org/officeDocument/2006/relationships">
+  <p:cSld>
+    <p:spTree>
+      <p:nvGrpSpPr>
+        <p:cNvPr id="1" name=""/>
+        <p:cNvGrpSpPr/>
+        <p:nvPr/>
+      </p:nvGrpSpPr>
+      <p:grpSpPr>
+        <a:xfrm>
+          <a:off x="0" y="0"/>
+          <a:ext cx="0" cy="0"/>
+          <a:chOff x="0" y="0"/>
+          <a:chExt cx="0" cy="0"/>
+        </a:xfrm>
+      </p:grpSpPr>
+      <p:sp>
+        <p:nvSpPr>
+          <p:cNvPr id="2" name="Slide Image Placeholder 1"/>
+          <p:cNvSpPr>
+            <a:spLocks noGrp="1"/>
+          </p:cNvSpPr>
+          <p:nvPr>
+            <p:ph type="sldImg" idx="2"/>
+          </p:nvPr>
+        </p:nvSpPr>
+        <p:spPr/>
+      </p:sp>
+      <p:sp>
+        <p:nvSpPr>
+          <p:cNvPr id="3" name="Notes Placeholder 2"/>
+          <p:cNvSpPr>
+            <a:spLocks noGrp="1"/>
+          </p:cNvSpPr>
+          <p:nvPr>
+            <p:ph type="body" idx="3" sz="quarter"/>
+          </p:nvPr>
+        </p:nvSpPr>
+        <p:spPr/>
+        <p:txBody>
+          <a:bodyPr/>
+          <a:lstStyle/>
+          <a:p>
+            <a:pPr>
+              <a:spcAft>
+                <a:spcPts val="600"/>
+              </a:spcAft>
+            </a:pPr>
+            <a:r>
+              <a:rPr sz="1200" b="1">
+                <a:solidFill>
+                  <a:srgbClr val="66727F"/>
+                </a:solidFill>
+                <a:latin typeface="Microsoft YaHei"/>
+                <a:ea typeface="Microsoft YaHei"/>
+                <a:cs typeface="Microsoft YaHei"/>
+              </a:rPr>
+              <a:t>【第 6 页 · 差异 · 算子级 vs 模型级 · 约 65 秒 · 讲完累计约 6:25】</a:t>
+            </a:r>
+          </a:p>
+          <a:p>
+            <a:pPr>
+              <a:spcAft>
+                <a:spcPts val="600"/>
+              </a:spcAft>
+            </a:pPr>
+            <a:r>
+              <a:rPr sz="1200" b="0">
+                <a:solidFill>
+                  <a:srgbClr val="16202A"/>
+                </a:solidFill>
+                <a:latin typeface="Microsoft YaHei"/>
+                <a:ea typeface="Microsoft YaHei"/>
+                <a:cs typeface="Microsoft YaHei"/>
+              </a:rPr>
+              <a:t>和平台算子 Agent 的区别，一句话：它把 kernel 做快，我们把模型跑好，两者互补。</a:t>
+            </a:r>
+          </a:p>
+          <a:p>
+            <a:pPr>
+              <a:spcAft>
+                <a:spcPts val="600"/>
+              </a:spcAft>
+            </a:pPr>
+            <a:r>
+              <a:rPr sz="1200" b="0">
+                <a:solidFill>
+                  <a:srgbClr val="16202A"/>
+                </a:solidFill>
+                <a:latin typeface="Microsoft YaHei"/>
+                <a:ea typeface="Microsoft YaHei"/>
+                <a:cs typeface="Microsoft YaHei"/>
+              </a:rPr>
+              <a:t>从下往上看：L1 是单个 kernel 怎么写最快，这是平台算子 Agent 的主场，我们以它的 kernel 为输入。往上，L2 看算子分发到哪条实现，L3 看真实 batch 下 step 里谁占大头，L4 看调度和特性怎么开，L5 看单机在 SLO 内能扛多少、先超标的是 TTFT 还是 TPOT。L2 到 L5 是我们做的。</a:t>
+            </a:r>
+          </a:p>
+          <a:p>
+            <a:pPr>
+              <a:spcAft>
+                <a:spcPts val="600"/>
+              </a:spcAft>
+            </a:pPr>
+            <a:r>
+              <a:rPr sz="1200" b="0">
+                <a:solidFill>
+                  <a:srgbClr val="16202A"/>
+                </a:solidFill>
+                <a:latin typeface="Microsoft YaHei"/>
+                <a:ea typeface="Microsoft YaHei"/>
+                <a:cs typeface="Microsoft YaHei"/>
+              </a:rPr>
+              <a:t>所以评价口径也不同：算子级看 kernel 耗时和离屋顶线多远，模型级看单机容量和 SLO 达成率。协作接口还在规划中：我们按模型级收益给平台排好算子需求，平台交回 kernel，我们做模型级复测。</a:t>
+            </a:r>
+          </a:p>
+        </p:txBody>
+      </p:sp>
+      <p:sp>
+        <p:nvSpPr>
+          <p:cNvPr id="4" name="Slide Number Placeholder 3"/>
+          <p:cNvSpPr>
+            <a:spLocks noGrp="1"/>
+          </p:cNvSpPr>
+          <p:nvPr>
+            <p:ph type="sldNum" idx="5" sz="quarter"/>
+          </p:nvPr>
+        </p:nvSpPr>
+        <p:spPr/>
+      </p:sp>
+    </p:spTree>
+  </p:cSld>
+  <p:clrMapOvr>
+    <a:masterClrMapping/>
+  </p:clrMapOvr>
+</p:notes>
+</file>
+
+<file path=ppt/notesSlides/notesSlide7.xml><?xml version="1.0" encoding="utf-8"?>
+<p:notes xmlns:a="http://schemas.openxmlformats.org/drawingml/2006/main" xmlns:p="http://schemas.openxmlformats.org/presentationml/2006/main" xmlns:r="http://schemas.openxmlformats.org/officeDocument/2006/relationships">
+  <p:cSld>
+    <p:spTree>
+      <p:nvGrpSpPr>
+        <p:cNvPr id="1" name=""/>
+        <p:cNvGrpSpPr/>
+        <p:nvPr/>
+      </p:nvGrpSpPr>
+      <p:grpSpPr>
+        <a:xfrm>
+          <a:off x="0" y="0"/>
+          <a:ext cx="0" cy="0"/>
+          <a:chOff x="0" y="0"/>
+          <a:chExt cx="0" cy="0"/>
+        </a:xfrm>
+      </p:grpSpPr>
+      <p:sp>
+        <p:nvSpPr>
+          <p:cNvPr id="2" name="Slide Image Placeholder 1"/>
+          <p:cNvSpPr>
+            <a:spLocks noGrp="1"/>
+          </p:cNvSpPr>
+          <p:nvPr>
+            <p:ph type="sldImg" idx="2"/>
+          </p:nvPr>
+        </p:nvSpPr>
+        <p:spPr/>
+      </p:sp>
+      <p:sp>
+        <p:nvSpPr>
+          <p:cNvPr id="3" name="Notes Placeholder 2"/>
+          <p:cNvSpPr>
+            <a:spLocks noGrp="1"/>
+          </p:cNvSpPr>
+          <p:nvPr>
+            <p:ph type="body" idx="3" sz="quarter"/>
+          </p:nvPr>
+        </p:nvSpPr>
+        <p:spPr/>
+        <p:txBody>
+          <a:bodyPr/>
+          <a:lstStyle/>
+          <a:p>
+            <a:pPr>
+              <a:spcAft>
+                <a:spcPts val="600"/>
+              </a:spcAft>
+            </a:pPr>
+            <a:r>
+              <a:rPr sz="1200" b="1">
+                <a:solidFill>
+                  <a:srgbClr val="66727F"/>
+                </a:solidFill>
+                <a:latin typeface="Microsoft YaHei"/>
+                <a:ea typeface="Microsoft YaHei"/>
+                <a:cs typeface="Microsoft YaHei"/>
+              </a:rPr>
+              <a:t>【第 7 页 · 深挖 · 难点 · 约 115 秒 · 讲完累计约 8:20】</a:t>
+            </a:r>
+          </a:p>
+          <a:p>
+            <a:pPr>
+              <a:spcAft>
+                <a:spcPts val="600"/>
+              </a:spcAft>
+            </a:pPr>
+            <a:r>
+              <a:rPr sz="1200" b="0">
+                <a:solidFill>
+                  <a:srgbClr val="16202A"/>
+                </a:solidFill>
+                <a:latin typeface="Microsoft YaHei"/>
+                <a:ea typeface="Microsoft YaHei"/>
+                <a:cs typeface="Microsoft YaHei"/>
+              </a:rPr>
+              <a:t>下面深挖一个难点：算子快 30%，单机容量涨多少？不能直接换算。</a:t>
+            </a:r>
+          </a:p>
+          <a:p>
+            <a:pPr>
+              <a:spcAft>
+                <a:spcPts val="600"/>
+              </a:spcAft>
+            </a:pPr>
+            <a:r>
+              <a:rPr sz="1200" b="0">
+                <a:solidFill>
+                  <a:srgbClr val="16202A"/>
+                </a:solidFill>
+                <a:latin typeface="Microsoft YaHei"/>
+                <a:ea typeface="Microsoft YaHei"/>
+                <a:cs typeface="Microsoft YaHei"/>
+              </a:rPr>
+              <a:t>先说明口径：这是推演，还没有实测校准，只用来说明方法；芯片参数暂用 H20 预设，M100 规格写进 YAML 就能重跑。场景是 Qwen3-32B，单机一个 TP8 实例，launch 固定，只把一类算子的耗时减 30%，看单机容量怎么变。</a:t>
+            </a:r>
+          </a:p>
+          <a:p>
+            <a:pPr>
+              <a:spcAft>
+                <a:spcPts val="600"/>
+              </a:spcAft>
+            </a:pPr>
+            <a:r>
+              <a:rPr sz="1200" b="0">
+                <a:solidFill>
+                  <a:srgbClr val="16202A"/>
+                </a:solidFill>
+                <a:latin typeface="Microsoft YaHei"/>
+                <a:ea typeface="Microsoft YaHei"/>
+                <a:cs typeface="Microsoft YaHei"/>
+              </a:rPr>
+              <a:t>结果差别很大：chat 负载下，attention 快 30%，容量只涨 1.7%；GEMM 快 30%，容量涨 40%。长上下文 RAG 下，分别涨 21% 和 31%。</a:t>
+            </a:r>
+          </a:p>
+          <a:p>
+            <a:pPr>
+              <a:spcAft>
+                <a:spcPts val="600"/>
+              </a:spcAft>
+            </a:pPr>
+            <a:r>
+              <a:rPr sz="1200" b="0">
+                <a:solidFill>
+                  <a:srgbClr val="16202A"/>
+                </a:solidFill>
+                <a:latin typeface="Microsoft YaHei"/>
+                <a:ea typeface="Microsoft YaHei"/>
+                <a:cs typeface="Microsoft YaHei"/>
+              </a:rPr>
+              <a:t>为什么不能直接换算？第一，占比随形状变：prefill 里 attention 的占比，4K 输入约 7%，32K 约 38%，所以它在 RAG 上收益大得多。第二，先超标的指标决定哪段有用：chat 先超标的是 TTFT，而 prefill 约八成时间在 GEMM，所以 GEMM 提速最管用；TTFT 里还有排队，提速还会被放大。第三，瓶颈会转移：RAG 提速后，先超标的从 TTFT 变成了 TPOT，下一轮先优化谁，要按新瓶颈重排。</a:t>
+            </a:r>
+          </a:p>
+          <a:p>
+            <a:pPr>
+              <a:spcAft>
+                <a:spcPts val="600"/>
+              </a:spcAft>
+            </a:pPr>
+            <a:r>
+              <a:rPr sz="1200" b="0">
+                <a:solidFill>
+                  <a:srgbClr val="16202A"/>
+                </a:solidFill>
+                <a:latin typeface="Microsoft YaHei"/>
+                <a:ea typeface="Microsoft YaHei"/>
+                <a:cs typeface="Microsoft YaHei"/>
+              </a:rPr>
+              <a:t>结论：算子优化值不值得做、先做哪个，必须放到负载、SLO 和部署里算，这正是模型级 Agent 的工作。</a:t>
+            </a:r>
+          </a:p>
+        </p:txBody>
+      </p:sp>
+      <p:sp>
+        <p:nvSpPr>
+          <p:cNvPr id="4" name="Slide Number Placeholder 3"/>
+          <p:cNvSpPr>
+            <a:spLocks noGrp="1"/>
+          </p:cNvSpPr>
+          <p:nvPr>
+            <p:ph type="sldNum" idx="5" sz="quarter"/>
+          </p:nvPr>
+        </p:nvSpPr>
+        <p:spPr/>
+      </p:sp>
+    </p:spTree>
+  </p:cSld>
+  <p:clrMapOvr>
+    <a:masterClrMapping/>
+  </p:clrMapOvr>
+</p:notes>
+</file>
+
+<file path=ppt/notesSlides/notesSlide8.xml><?xml version="1.0" encoding="utf-8"?>
+<p:notes xmlns:a="http://schemas.openxmlformats.org/drawingml/2006/main" xmlns:p="http://schemas.openxmlformats.org/presentationml/2006/main" xmlns:r="http://schemas.openxmlformats.org/officeDocument/2006/relationships">
+  <p:cSld>
+    <p:spTree>
+      <p:nvGrpSpPr>
+        <p:cNvPr id="1" name=""/>
+        <p:cNvGrpSpPr/>
+        <p:nvPr/>
+      </p:nvGrpSpPr>
+      <p:grpSpPr>
+        <a:xfrm>
+          <a:off x="0" y="0"/>
+          <a:ext cx="0" cy="0"/>
+          <a:chOff x="0" y="0"/>
+          <a:chExt cx="0" cy="0"/>
+        </a:xfrm>
+      </p:grpSpPr>
+      <p:sp>
+        <p:nvSpPr>
+          <p:cNvPr id="2" name="Slide Image Placeholder 1"/>
+          <p:cNvSpPr>
+            <a:spLocks noGrp="1"/>
+          </p:cNvSpPr>
+          <p:nvPr>
+            <p:ph type="sldImg" idx="2"/>
+          </p:nvPr>
+        </p:nvSpPr>
+        <p:spPr/>
+      </p:sp>
+      <p:sp>
+        <p:nvSpPr>
+          <p:cNvPr id="3" name="Notes Placeholder 2"/>
+          <p:cNvSpPr>
+            <a:spLocks noGrp="1"/>
+          </p:cNvSpPr>
+          <p:nvPr>
+            <p:ph type="body" idx="3" sz="quarter"/>
+          </p:nvPr>
+        </p:nvSpPr>
+        <p:spPr/>
+        <p:txBody>
+          <a:bodyPr/>
+          <a:lstStyle/>
+          <a:p>
+            <a:pPr>
+              <a:spcAft>
+                <a:spcPts val="600"/>
+              </a:spcAft>
+            </a:pPr>
+            <a:r>
+              <a:rPr sz="1200" b="1">
+                <a:solidFill>
+                  <a:srgbClr val="66727F"/>
+                </a:solidFill>
+                <a:latin typeface="Microsoft YaHei"/>
+                <a:ea typeface="Microsoft YaHei"/>
+                <a:cs typeface="Microsoft YaHei"/>
+              </a:rPr>
+              <a:t>【第 8 页 · 深挖 · 解法 · 约 80 秒 · 讲完累计约 9:40】</a:t>
+            </a:r>
+          </a:p>
+          <a:p>
+            <a:pPr>
+              <a:spcAft>
+                <a:spcPts val="600"/>
+              </a:spcAft>
+            </a:pPr>
+            <a:r>
+              <a:rPr sz="1200" b="0">
+                <a:solidFill>
+                  <a:srgbClr val="16202A"/>
+                </a:solidFill>
+                <a:latin typeface="Microsoft YaHei"/>
+                <a:ea typeface="Microsoft YaHei"/>
+                <a:cs typeface="Microsoft YaHei"/>
+              </a:rPr>
+              <a:t>怎么解？我们用一条换算链，从 kernel 一路算到单机容量。</a:t>
+            </a:r>
+          </a:p>
+          <a:p>
+            <a:pPr>
+              <a:spcAft>
+                <a:spcPts val="600"/>
+              </a:spcAft>
+            </a:pPr>
+            <a:r>
+              <a:rPr sz="1200" b="0">
+                <a:solidFill>
+                  <a:srgbClr val="16202A"/>
+                </a:solidFill>
+                <a:latin typeface="Microsoft YaHei"/>
+                <a:ea typeface="Microsoft YaHei"/>
+                <a:cs typeface="Microsoft YaHei"/>
+              </a:rPr>
+              <a:t>五层从左到右：kernel 层用 roofline 加 launch 间隙和通信算算子耗时，效率系数取自芯片 YAML；step 层按真实 batch 形状逐层累加；调度层用离散事件仿真 SGLang，得到请求时延；SLO 层按 P90 判定，标出先超标的指标；容量层二分搜索最大到达率，在候选配置里取容量最高的。五层共用一套模型和参数，算子、特性、布局任何一处变了，都能一路传到单机容量。底下是校准回路：压测偏差超过正负 20%，就用日志校准、重新规划。</a:t>
+            </a:r>
+          </a:p>
+          <a:p>
+            <a:pPr>
+              <a:spcAft>
+                <a:spcPts val="600"/>
+              </a:spcAft>
+            </a:pPr>
+            <a:r>
+              <a:rPr sz="1200" b="0">
+                <a:solidFill>
+                  <a:srgbClr val="16202A"/>
+                </a:solidFill>
+                <a:latin typeface="Microsoft YaHei"/>
+                <a:ea typeface="Microsoft YaHei"/>
+                <a:cs typeface="Microsoft YaHei"/>
+              </a:rPr>
+              <a:t>Agent 用这条链做三件事：排优先级，已经实现；what-if，规划中，上一页就是手工跑的；还有给 Loop C 和平台提需求，从“把 X 做快”变成“这些 shape 下快多少、单机容量涨多少”，也在规划中。</a:t>
+            </a:r>
+          </a:p>
+        </p:txBody>
+      </p:sp>
+      <p:sp>
+        <p:nvSpPr>
+          <p:cNvPr id="4" name="Slide Number Placeholder 3"/>
+          <p:cNvSpPr>
+            <a:spLocks noGrp="1"/>
+          </p:cNvSpPr>
+          <p:nvPr>
+            <p:ph type="sldNum" idx="5" sz="quarter"/>
+          </p:nvPr>
+        </p:nvSpPr>
+        <p:spPr/>
+      </p:sp>
+    </p:spTree>
+  </p:cSld>
+  <p:clrMapOvr>
+    <a:masterClrMapping/>
+  </p:clrMapOvr>
+</p:notes>
+</file>
+
+<file path=ppt/notesSlides/notesSlide9.xml><?xml version="1.0" encoding="utf-8"?>
+<p:notes xmlns:a="http://schemas.openxmlformats.org/drawingml/2006/main" xmlns:p="http://schemas.openxmlformats.org/presentationml/2006/main" xmlns:r="http://schemas.openxmlformats.org/officeDocument/2006/relationships">
+  <p:cSld>
+    <p:spTree>
+      <p:nvGrpSpPr>
+        <p:cNvPr id="1" name=""/>
+        <p:cNvGrpSpPr/>
+        <p:nvPr/>
+      </p:nvGrpSpPr>
+      <p:grpSpPr>
+        <a:xfrm>
+          <a:off x="0" y="0"/>
+          <a:ext cx="0" cy="0"/>
+          <a:chOff x="0" y="0"/>
+          <a:chExt cx="0" cy="0"/>
+        </a:xfrm>
+      </p:grpSpPr>
+      <p:sp>
+        <p:nvSpPr>
+          <p:cNvPr id="2" name="Slide Image Placeholder 1"/>
+          <p:cNvSpPr>
+            <a:spLocks noGrp="1"/>
+          </p:cNvSpPr>
+          <p:nvPr>
+            <p:ph type="sldImg" idx="2"/>
+          </p:nvPr>
+        </p:nvSpPr>
+        <p:spPr/>
+      </p:sp>
+      <p:sp>
+        <p:nvSpPr>
+          <p:cNvPr id="3" name="Notes Placeholder 2"/>
+          <p:cNvSpPr>
+            <a:spLocks noGrp="1"/>
+          </p:cNvSpPr>
+          <p:nvPr>
+            <p:ph type="body" idx="3" sz="quarter"/>
+          </p:nvPr>
+        </p:nvSpPr>
+        <p:spPr/>
+        <p:txBody>
+          <a:bodyPr/>
+          <a:lstStyle/>
+          <a:p>
+            <a:pPr>
+              <a:spcAft>
+                <a:spcPts val="600"/>
+              </a:spcAft>
+            </a:pPr>
+            <a:r>
+              <a:rPr sz="1200" b="1">
+                <a:solidFill>
+                  <a:srgbClr val="66727F"/>
+                </a:solidFill>
+                <a:latin typeface="Microsoft YaHei"/>
+                <a:ea typeface="Microsoft YaHei"/>
+                <a:cs typeface="Microsoft YaHei"/>
+              </a:rPr>
+              <a:t>【第 9 页 · 现状与下一步 · 约 40 秒 · 讲完累计约 10:20】</a:t>
+            </a:r>
+          </a:p>
+          <a:p>
+            <a:pPr>
+              <a:spcAft>
+                <a:spcPts val="600"/>
+              </a:spcAft>
+            </a:pPr>
+            <a:r>
+              <a:rPr sz="1200" b="0">
+                <a:solidFill>
+                  <a:srgbClr val="16202A"/>
+                </a:solidFill>
+                <a:latin typeface="Microsoft YaHei"/>
+                <a:ea typeface="Microsoft YaHei"/>
+                <a:cs typeface="Microsoft YaHei"/>
+              </a:rPr>
+              <a:t>最后是现状：评估和决策已经打通。Loop A 有源码能力快照和特性顾问，Loop B 有适配分析、单机部署仿真和校准，Loop C 有绑定解析、trace 诊断和优化评估。下一步是把执行和复测自动化：自动拉起服务和压测、自动 A/B，以及 what-if 命令、对接平台算子 Agent。</a:t>
+            </a:r>
+          </a:p>
+          <a:p>
+            <a:pPr>
+              <a:spcAft>
+                <a:spcPts val="600"/>
+              </a:spcAft>
+            </a:pPr>
+            <a:r>
+              <a:rPr sz="1200" b="0">
+                <a:solidFill>
+                  <a:srgbClr val="16202A"/>
+                </a:solidFill>
+                <a:latin typeface="Microsoft YaHei"/>
+                <a:ea typeface="Microsoft YaHei"/>
+                <a:cs typeface="Microsoft YaHei"/>
+              </a:rPr>
+              <a:t>我们的定位是：不替代算子生成，而是把算子能力兑现为模型级收益。谢谢大家。</a:t>
+            </a:r>
+          </a:p>
+        </p:txBody>
+      </p:sp>
+      <p:sp>
+        <p:nvSpPr>
+          <p:cNvPr id="4" name="Slide Number Placeholder 3"/>
+          <p:cNvSpPr>
+            <a:spLocks noGrp="1"/>
+          </p:cNvSpPr>
+          <p:nvPr>
+            <p:ph type="sldNum" idx="5" sz="quarter"/>
+          </p:nvPr>
+        </p:nvSpPr>
+        <p:spPr/>
+      </p:sp>
+    </p:spTree>
+  </p:cSld>
+  <p:clrMapOvr>
+    <a:masterClrMapping/>
+  </p:clrMapOvr>
+</p:notes>
 </file>
 
 <file path=ppt/slideLayouts/slideLayout1.xml><?xml version="1.0" encoding="utf-8"?>
@@ -22304,4 +23941,324 @@
   </a:objectDefaults>
   <a:extraClrSchemeLst/>
 </a:theme>
+</file>
+
+<file path=ppt/theme/theme2.xml><?xml version="1.0" encoding="utf-8"?>
+<a:theme xmlns:a="http://schemas.openxmlformats.org/drawingml/2006/main" name="Office Theme">
+  <a:themeElements>
+    <a:clrScheme name="Office">
+      <a:dk1>
+        <a:sysClr val="windowText" lastClr="000000"/>
+      </a:dk1>
+      <a:lt1>
+        <a:sysClr val="window" lastClr="FFFFFF"/>
+      </a:lt1>
+      <a:dk2>
+        <a:srgbClr val="1F497D"/>
+      </a:dk2>
+      <a:lt2>
+        <a:srgbClr val="EEECE1"/>
+      </a:lt2>
+      <a:accent1>
+        <a:srgbClr val="4F81BD"/>
+      </a:accent1>
+      <a:accent2>
+        <a:srgbClr val="C0504D"/>
+      </a:accent2>
+      <a:accent3>
+        <a:srgbClr val="9BBB59"/>
+      </a:accent3>
+      <a:accent4>
+        <a:srgbClr val="8064A2"/>
+      </a:accent4>
+      <a:accent5>
+        <a:srgbClr val="4BACC6"/>
+      </a:accent5>
+      <a:accent6>
+        <a:srgbClr val="F79646"/>
+      </a:accent6>
+      <a:hlink>
+        <a:srgbClr val="0000FF"/>
+      </a:hlink>
+      <a:folHlink>
+        <a:srgbClr val="800080"/>
+      </a:folHlink>
+    </a:clrScheme>
+    <a:fontScheme name="Office">
+      <a:majorFont>
+        <a:latin typeface="Calibri"/>
+        <a:ea typeface=""/>
+        <a:cs typeface=""/>
+        <a:font script="Jpan" typeface="ＭＳ Ｐゴシック"/>
+        <a:font script="Hang" typeface="맑은 고딕"/>
+        <a:font script="Hans" typeface="宋体"/>
+        <a:font script="Hant" typeface="新細明體"/>
+        <a:font script="Arab" typeface="Times New Roman"/>
+        <a:font script="Hebr" typeface="Times New Roman"/>
+        <a:font script="Thai" typeface="Angsana New"/>
+        <a:font script="Ethi" typeface="Nyala"/>
+        <a:font script="Beng" typeface="Vrinda"/>
+        <a:font script="Gujr" typeface="Shruti"/>
+        <a:font script="Khmr" typeface="MoolBoran"/>
+        <a:font script="Knda" typeface="Tunga"/>
+        <a:font script="Guru" typeface="Raavi"/>
+        <a:font script="Cans" typeface="Euphemia"/>
+        <a:font script="Cher" typeface="Plantagenet Cherokee"/>
+        <a:font script="Yiii" typeface="Microsoft Yi Baiti"/>
+        <a:font script="Tibt" typeface="Microsoft Himalaya"/>
+        <a:font script="Thaa" typeface="MV Boli"/>
+        <a:font script="Deva" typeface="Mangal"/>
+        <a:font script="Telu" typeface="Gautami"/>
+        <a:font script="Taml" typeface="Latha"/>
+        <a:font script="Syrc" typeface="Estrangelo Edessa"/>
+        <a:font script="Orya" typeface="Kalinga"/>
+        <a:font script="Mlym" typeface="Kartika"/>
+        <a:font script="Laoo" typeface="DokChampa"/>
+        <a:font script="Sinh" typeface="Iskoola Pota"/>
+        <a:font script="Mong" typeface="Mongolian Baiti"/>
+        <a:font script="Viet" typeface="Times New Roman"/>
+        <a:font script="Uigh" typeface="Microsoft Uighur"/>
+        <a:font script="Geor" typeface="Sylfaen"/>
+      </a:majorFont>
+      <a:minorFont>
+        <a:latin typeface="Calibri"/>
+        <a:ea typeface=""/>
+        <a:cs typeface=""/>
+        <a:font script="Jpan" typeface="ＭＳ Ｐゴシック"/>
+        <a:font script="Hang" typeface="맑은 고딕"/>
+        <a:font script="Hans" typeface="宋体"/>
+        <a:font script="Hant" typeface="新細明體"/>
+        <a:font script="Arab" typeface="Arial"/>
+        <a:font script="Hebr" typeface="Arial"/>
+        <a:font script="Thai" typeface="Cordia New"/>
+        <a:font script="Ethi" typeface="Nyala"/>
+        <a:font script="Beng" typeface="Vrinda"/>
+        <a:font script="Gujr" typeface="Shruti"/>
+        <a:font script="Khmr" typeface="DaunPenh"/>
+        <a:font script="Knda" typeface="Tunga"/>
+        <a:font script="Guru" typeface="Raavi"/>
+        <a:font script="Cans" typeface="Euphemia"/>
+        <a:font script="Cher" typeface="Plantagenet Cherokee"/>
+        <a:font script="Yiii" typeface="Microsoft Yi Baiti"/>
+        <a:font script="Tibt" typeface="Microsoft Himalaya"/>
+        <a:font script="Thaa" typeface="MV Boli"/>
+        <a:font script="Deva" typeface="Mangal"/>
+        <a:font script="Telu" typeface="Gautami"/>
+        <a:font script="Taml" typeface="Latha"/>
+        <a:font script="Syrc" typeface="Estrangelo Edessa"/>
+        <a:font script="Orya" typeface="Kalinga"/>
+        <a:font script="Mlym" typeface="Kartika"/>
+        <a:font script="Laoo" typeface="DokChampa"/>
+        <a:font script="Sinh" typeface="Iskoola Pota"/>
+        <a:font script="Mong" typeface="Mongolian Baiti"/>
+        <a:font script="Viet" typeface="Arial"/>
+        <a:font script="Uigh" typeface="Microsoft Uighur"/>
+        <a:font script="Geor" typeface="Sylfaen"/>
+      </a:minorFont>
+    </a:fontScheme>
+    <a:fmtScheme name="Office">
+      <a:fillStyleLst>
+        <a:solidFill>
+          <a:schemeClr val="phClr"/>
+        </a:solidFill>
+        <a:gradFill rotWithShape="1">
+          <a:gsLst>
+            <a:gs pos="0">
+              <a:schemeClr val="phClr">
+                <a:tint val="50000"/>
+                <a:satMod val="300000"/>
+              </a:schemeClr>
+            </a:gs>
+            <a:gs pos="35000">
+              <a:schemeClr val="phClr">
+                <a:tint val="37000"/>
+                <a:satMod val="300000"/>
+              </a:schemeClr>
+            </a:gs>
+            <a:gs pos="100000">
+              <a:schemeClr val="phClr">
+                <a:tint val="15000"/>
+                <a:satMod val="350000"/>
+              </a:schemeClr>
+            </a:gs>
+          </a:gsLst>
+          <a:lin ang="16200000" scaled="1"/>
+        </a:gradFill>
+        <a:gradFill rotWithShape="1">
+          <a:gsLst>
+            <a:gs pos="0">
+              <a:schemeClr val="phClr">
+                <a:tint val="100000"/>
+                <a:shade val="100000"/>
+                <a:satMod val="130000"/>
+              </a:schemeClr>
+            </a:gs>
+            <a:gs pos="100000">
+              <a:schemeClr val="phClr">
+                <a:tint val="50000"/>
+                <a:shade val="100000"/>
+                <a:satMod val="350000"/>
+              </a:schemeClr>
+            </a:gs>
+          </a:gsLst>
+          <a:lin ang="16200000" scaled="0"/>
+        </a:gradFill>
+      </a:fillStyleLst>
+      <a:lnStyleLst>
+        <a:ln w="9525" cap="flat" cmpd="sng" algn="ctr">
+          <a:solidFill>
+            <a:schemeClr val="phClr">
+              <a:shade val="95000"/>
+              <a:satMod val="105000"/>
+            </a:schemeClr>
+          </a:solidFill>
+          <a:prstDash val="solid"/>
+        </a:ln>
+        <a:ln w="25400" cap="flat" cmpd="sng" algn="ctr">
+          <a:solidFill>
+            <a:schemeClr val="phClr"/>
+          </a:solidFill>
+          <a:prstDash val="solid"/>
+        </a:ln>
+        <a:ln w="38100" cap="flat" cmpd="sng" algn="ctr">
+          <a:solidFill>
+            <a:schemeClr val="phClr"/>
+          </a:solidFill>
+          <a:prstDash val="solid"/>
+        </a:ln>
+      </a:lnStyleLst>
+      <a:effectStyleLst>
+        <a:effectStyle>
+          <a:effectLst>
+            <a:outerShdw blurRad="40000" dist="20000" dir="5400000" rotWithShape="0">
+              <a:srgbClr val="000000">
+                <a:alpha val="38000"/>
+              </a:srgbClr>
+            </a:outerShdw>
+          </a:effectLst>
+        </a:effectStyle>
+        <a:effectStyle>
+          <a:effectLst>
+            <a:outerShdw blurRad="40000" dist="23000" dir="5400000" rotWithShape="0">
+              <a:srgbClr val="000000">
+                <a:alpha val="35000"/>
+              </a:srgbClr>
+            </a:outerShdw>
+          </a:effectLst>
+        </a:effectStyle>
+        <a:effectStyle>
+          <a:effectLst>
+            <a:outerShdw blurRad="40000" dist="23000" dir="5400000" rotWithShape="0">
+              <a:srgbClr val="000000">
+                <a:alpha val="35000"/>
+              </a:srgbClr>
+            </a:outerShdw>
+          </a:effectLst>
+          <a:scene3d>
+            <a:camera prst="orthographicFront">
+              <a:rot lat="0" lon="0" rev="0"/>
+            </a:camera>
+            <a:lightRig rig="threePt" dir="t">
+              <a:rot lat="0" lon="0" rev="1200000"/>
+            </a:lightRig>
+          </a:scene3d>
+          <a:sp3d>
+            <a:bevelT w="63500" h="25400"/>
+          </a:sp3d>
+        </a:effectStyle>
+      </a:effectStyleLst>
+      <a:bgFillStyleLst>
+        <a:solidFill>
+          <a:schemeClr val="phClr"/>
+        </a:solidFill>
+        <a:gradFill rotWithShape="1">
+          <a:gsLst>
+            <a:gs pos="0">
+              <a:schemeClr val="phClr">
+                <a:tint val="40000"/>
+                <a:satMod val="350000"/>
+              </a:schemeClr>
+            </a:gs>
+            <a:gs pos="40000">
+              <a:schemeClr val="phClr">
+                <a:tint val="45000"/>
+                <a:shade val="99000"/>
+                <a:satMod val="350000"/>
+              </a:schemeClr>
+            </a:gs>
+            <a:gs pos="100000">
+              <a:schemeClr val="phClr">
+                <a:shade val="20000"/>
+                <a:satMod val="255000"/>
+              </a:schemeClr>
+            </a:gs>
+          </a:gsLst>
+          <a:path path="circle">
+            <a:fillToRect l="50000" t="-80000" r="50000" b="180000"/>
+          </a:path>
+        </a:gradFill>
+        <a:gradFill rotWithShape="1">
+          <a:gsLst>
+            <a:gs pos="0">
+              <a:schemeClr val="phClr">
+                <a:tint val="80000"/>
+                <a:satMod val="300000"/>
+              </a:schemeClr>
+            </a:gs>
+            <a:gs pos="100000">
+              <a:schemeClr val="phClr">
+                <a:shade val="30000"/>
+                <a:satMod val="200000"/>
+              </a:schemeClr>
+            </a:gs>
+          </a:gsLst>
+          <a:path path="circle">
+            <a:fillToRect l="50000" t="50000" r="50000" b="50000"/>
+          </a:path>
+        </a:gradFill>
+      </a:bgFillStyleLst>
+    </a:fmtScheme>
+  </a:themeElements>
+  <a:objectDefaults>
+    <a:spDef>
+      <a:spPr/>
+      <a:bodyPr/>
+      <a:lstStyle/>
+      <a:style>
+        <a:lnRef idx="1">
+          <a:schemeClr val="accent1"/>
+        </a:lnRef>
+        <a:fillRef idx="3">
+          <a:schemeClr val="accent1"/>
+        </a:fillRef>
+        <a:effectRef idx="2">
+          <a:schemeClr val="accent1"/>
+        </a:effectRef>
+        <a:fontRef idx="minor">
+          <a:schemeClr val="lt1"/>
+        </a:fontRef>
+      </a:style>
+    </a:spDef>
+    <a:lnDef>
+      <a:spPr/>
+      <a:bodyPr/>
+      <a:lstStyle/>
+      <a:style>
+        <a:lnRef idx="2">
+          <a:schemeClr val="accent1"/>
+        </a:lnRef>
+        <a:fillRef idx="0">
+          <a:schemeClr val="accent1"/>
+        </a:fillRef>
+        <a:effectRef idx="1">
+          <a:schemeClr val="accent1"/>
+        </a:effectRef>
+        <a:fontRef idx="minor">
+          <a:schemeClr val="tx1"/>
+        </a:fontRef>
+      </a:style>
+    </a:lnDef>
+  </a:objectDefaults>
+  <a:extraClrSchemeLst/>
+</a:theme>
 </file>
</xml_diff>